<commit_message>
Align lesson page and lower expert portrait in PPTX
</commit_message>
<xml_diff>
--- a/ekaterina-tax-students/assets/tax-systems-ekaterina.pptx
+++ b/ekaterina-tax-students/assets/tax-systems-ekaterina.pptx
@@ -2,28 +2,28 @@
 <file path=ppt/presentation.xml><?xml version="1.0" encoding="utf-8"?>
 <p:presentation xmlns:p="http://schemas.openxmlformats.org/presentationml/2006/main">
   <p:sldMasterIdLst>
-    <p:sldMasterId xmlns:r="http://schemas.openxmlformats.org/officeDocument/2006/relationships" id="2147483648" r:id="R0845cae7c9fe4739"/>
+    <p:sldMasterId xmlns:r="http://schemas.openxmlformats.org/officeDocument/2006/relationships" id="2147483648" r:id="Rd5e0fd5f99af42c1"/>
   </p:sldMasterIdLst>
   <p:notesMasterIdLst>
-    <p:notesMasterId xmlns:r="http://schemas.openxmlformats.org/officeDocument/2006/relationships" r:id="R5162121a711b428a"/>
+    <p:notesMasterId xmlns:r="http://schemas.openxmlformats.org/officeDocument/2006/relationships" r:id="R9590b5788c7a4112"/>
   </p:notesMasterIdLst>
   <p:sldIdLst>
-    <p:sldId xmlns:r="http://schemas.openxmlformats.org/officeDocument/2006/relationships" id="256" r:id="Rdec548b62b5d41c0"/>
-    <p:sldId xmlns:r="http://schemas.openxmlformats.org/officeDocument/2006/relationships" id="257" r:id="R69326d16d2554ad6"/>
-    <p:sldId xmlns:r="http://schemas.openxmlformats.org/officeDocument/2006/relationships" id="258" r:id="R5f3ff450dba044ac"/>
-    <p:sldId xmlns:r="http://schemas.openxmlformats.org/officeDocument/2006/relationships" id="259" r:id="Re3c5fa5e7c114b29"/>
-    <p:sldId xmlns:r="http://schemas.openxmlformats.org/officeDocument/2006/relationships" id="260" r:id="Rb980facce059489c"/>
-    <p:sldId xmlns:r="http://schemas.openxmlformats.org/officeDocument/2006/relationships" id="261" r:id="R2f68ebbe850a4bb1"/>
-    <p:sldId xmlns:r="http://schemas.openxmlformats.org/officeDocument/2006/relationships" id="262" r:id="Rb212d8a416cc425d"/>
-    <p:sldId xmlns:r="http://schemas.openxmlformats.org/officeDocument/2006/relationships" id="263" r:id="R206421fd8b0043f6"/>
-    <p:sldId xmlns:r="http://schemas.openxmlformats.org/officeDocument/2006/relationships" id="264" r:id="Rd77a4017848a4134"/>
-    <p:sldId xmlns:r="http://schemas.openxmlformats.org/officeDocument/2006/relationships" id="265" r:id="R381abb9ade7040cb"/>
-    <p:sldId xmlns:r="http://schemas.openxmlformats.org/officeDocument/2006/relationships" id="266" r:id="R548c47b4c8fb4dd1"/>
-    <p:sldId xmlns:r="http://schemas.openxmlformats.org/officeDocument/2006/relationships" id="267" r:id="Rce2731f445b94f0a"/>
-    <p:sldId xmlns:r="http://schemas.openxmlformats.org/officeDocument/2006/relationships" id="268" r:id="Rc13dc3edce24423a"/>
-    <p:sldId xmlns:r="http://schemas.openxmlformats.org/officeDocument/2006/relationships" id="269" r:id="R171067dfd9ce4b2a"/>
-    <p:sldId xmlns:r="http://schemas.openxmlformats.org/officeDocument/2006/relationships" id="270" r:id="Rc9d3a4e13e934c83"/>
-    <p:sldId xmlns:r="http://schemas.openxmlformats.org/officeDocument/2006/relationships" id="271" r:id="Ra167f5f42b3a4c7b"/>
+    <p:sldId xmlns:r="http://schemas.openxmlformats.org/officeDocument/2006/relationships" id="256" r:id="Rd9dddc35799747a5"/>
+    <p:sldId xmlns:r="http://schemas.openxmlformats.org/officeDocument/2006/relationships" id="257" r:id="R81faac79b8a24f76"/>
+    <p:sldId xmlns:r="http://schemas.openxmlformats.org/officeDocument/2006/relationships" id="258" r:id="R81fc46661856483e"/>
+    <p:sldId xmlns:r="http://schemas.openxmlformats.org/officeDocument/2006/relationships" id="259" r:id="R4a203676e9514f7c"/>
+    <p:sldId xmlns:r="http://schemas.openxmlformats.org/officeDocument/2006/relationships" id="260" r:id="R96b374a33e8c497b"/>
+    <p:sldId xmlns:r="http://schemas.openxmlformats.org/officeDocument/2006/relationships" id="261" r:id="R920ca8f483274b6d"/>
+    <p:sldId xmlns:r="http://schemas.openxmlformats.org/officeDocument/2006/relationships" id="262" r:id="Rf96e42363c194bda"/>
+    <p:sldId xmlns:r="http://schemas.openxmlformats.org/officeDocument/2006/relationships" id="263" r:id="R952f4f3acf04439c"/>
+    <p:sldId xmlns:r="http://schemas.openxmlformats.org/officeDocument/2006/relationships" id="264" r:id="Ref4a4a484e594865"/>
+    <p:sldId xmlns:r="http://schemas.openxmlformats.org/officeDocument/2006/relationships" id="265" r:id="R987ae04dbaa34de8"/>
+    <p:sldId xmlns:r="http://schemas.openxmlformats.org/officeDocument/2006/relationships" id="266" r:id="R0c2e510b46ee4f8c"/>
+    <p:sldId xmlns:r="http://schemas.openxmlformats.org/officeDocument/2006/relationships" id="267" r:id="R58efa6517da9412e"/>
+    <p:sldId xmlns:r="http://schemas.openxmlformats.org/officeDocument/2006/relationships" id="268" r:id="R798b5c502a934d6d"/>
+    <p:sldId xmlns:r="http://schemas.openxmlformats.org/officeDocument/2006/relationships" id="269" r:id="Rbe1abd1416934ffc"/>
+    <p:sldId xmlns:r="http://schemas.openxmlformats.org/officeDocument/2006/relationships" id="270" r:id="R44c66cdc27714867"/>
+    <p:sldId xmlns:r="http://schemas.openxmlformats.org/officeDocument/2006/relationships" id="271" r:id="Rbd1ce0d9921e4fbb"/>
   </p:sldIdLst>
   <p:sldSz cx="12192000" cy="6858000"/>
   <p:notesSz cx="6858000" cy="9144000"/>
@@ -1606,7 +1606,7 @@
   </p:cSld>
   <p:clrMap bg1="lt1" tx1="dk1" bg2="lt2" tx2="dk2" accent1="accent1" accent2="accent2" accent3="accent3" accent4="accent4" accent5="accent5" accent6="accent6" hlink="hlink" folHlink="folHlink"/>
   <p:sldLayoutIdLst>
-    <p:sldLayoutId xmlns:r="http://schemas.openxmlformats.org/officeDocument/2006/relationships" id="2147483649" r:id="R7a978e2d6d5a4aad"/>
+    <p:sldLayoutId xmlns:r="http://schemas.openxmlformats.org/officeDocument/2006/relationships" id="2147483649" r:id="R59a50e189bf0446f"/>
   </p:sldLayoutIdLst>
   <p:txStyles>
     <p:titleStyle>
@@ -2157,7 +2157,7 @@
           <p:cNvPr id="1" name="">
             <a:extLst xmlns:a="http://schemas.openxmlformats.org/drawingml/2006/main">
               <a:ext uri="{FF2B5EF4-FFF2-40B4-BE49-F238E27FC236}">
-                <a16:creationId xmlns:a16="http://schemas.microsoft.com/office/drawing/2014/main" id="{E76341AE-DC69-4E8D-B501-76070E591572}"/>
+                <a16:creationId xmlns:a16="http://schemas.microsoft.com/office/drawing/2014/main" id="{E50660D3-3F54-427D-B8F9-C75613787608}"/>
               </a:ext>
             </a:extLst>
           </p:cNvPr>
@@ -2211,7 +2211,7 @@
           <p:cNvPr id="2" name="">
             <a:extLst xmlns:a="http://schemas.openxmlformats.org/drawingml/2006/main">
               <a:ext uri="{FF2B5EF4-FFF2-40B4-BE49-F238E27FC236}">
-                <a16:creationId xmlns:a16="http://schemas.microsoft.com/office/drawing/2014/main" id="{D7691E4B-9044-4AAB-BEF9-5D72004C469E}"/>
+                <a16:creationId xmlns:a16="http://schemas.microsoft.com/office/drawing/2014/main" id="{FF3C3EDF-3E92-4C88-A3A1-7602B80ECCD8}"/>
               </a:ext>
             </a:extLst>
           </p:cNvPr>
@@ -2242,7 +2242,7 @@
           <p:cNvPr id="3" name="">
             <a:extLst xmlns:a="http://schemas.openxmlformats.org/drawingml/2006/main">
               <a:ext uri="{FF2B5EF4-FFF2-40B4-BE49-F238E27FC236}">
-                <a16:creationId xmlns:a16="http://schemas.microsoft.com/office/drawing/2014/main" id="{452E95F3-7528-4821-AA6C-E9BA01E4635D}"/>
+                <a16:creationId xmlns:a16="http://schemas.microsoft.com/office/drawing/2014/main" id="{F5EB60CF-D35B-40B7-9889-291625699714}"/>
               </a:ext>
             </a:extLst>
           </p:cNvPr>
@@ -2292,7 +2292,7 @@
           <p:cNvPr id="4" name="">
             <a:extLst xmlns:a="http://schemas.openxmlformats.org/drawingml/2006/main">
               <a:ext uri="{FF2B5EF4-FFF2-40B4-BE49-F238E27FC236}">
-                <a16:creationId xmlns:a16="http://schemas.microsoft.com/office/drawing/2014/main" id="{2EDF0DAB-C292-490E-9D9C-1DAA86DDB2B4}"/>
+                <a16:creationId xmlns:a16="http://schemas.microsoft.com/office/drawing/2014/main" id="{7FF0784F-05FA-428A-9042-9A5C08096CB5}"/>
               </a:ext>
             </a:extLst>
           </p:cNvPr>
@@ -2329,16 +2329,16 @@
           <p:nvPr/>
         </p:nvPicPr>
         <p:blipFill>
-          <a:blip xmlns:r="http://schemas.openxmlformats.org/officeDocument/2006/relationships" xmlns:a="http://schemas.openxmlformats.org/drawingml/2006/main" r:embed="R681887c13a79456e"/>
-          <a:srcRect xmlns:a="http://schemas.openxmlformats.org/drawingml/2006/main" l="0" t="9515" r="0" b="9515"/>
+          <a:blip xmlns:r="http://schemas.openxmlformats.org/officeDocument/2006/relationships" xmlns:a="http://schemas.openxmlformats.org/drawingml/2006/main" r:embed="Rc33fb81344914b24"/>
+          <a:srcRect xmlns:a="http://schemas.openxmlformats.org/drawingml/2006/main" l="0" t="10645" r="0" b="10645"/>
           <a:stretch xmlns:a="http://schemas.openxmlformats.org/drawingml/2006/main">
             <a:fillRect l="0" t="0" r="0" b="0"/>
           </a:stretch>
         </p:blipFill>
         <p:spPr>
           <a:xfrm xmlns:a="http://schemas.openxmlformats.org/drawingml/2006/main">
-            <a:off x="685800" y="1047750"/>
-            <a:ext cx="3371850" cy="4095750"/>
+            <a:off x="685800" y="1162050"/>
+            <a:ext cx="3371850" cy="3981450"/>
           </a:xfrm>
           <a:prstGeom xmlns:a="http://schemas.openxmlformats.org/drawingml/2006/main" prst="roundRect">
             <a:avLst>
@@ -2352,7 +2352,7 @@
           <p:cNvPr id="6" name="">
             <a:extLst xmlns:a="http://schemas.openxmlformats.org/drawingml/2006/main">
               <a:ext uri="{FF2B5EF4-FFF2-40B4-BE49-F238E27FC236}">
-                <a16:creationId xmlns:a16="http://schemas.microsoft.com/office/drawing/2014/main" id="{56ED9049-1D2F-4685-AA9E-C9CE15932CCC}"/>
+                <a16:creationId xmlns:a16="http://schemas.microsoft.com/office/drawing/2014/main" id="{7FFB2D0A-DD46-4831-BC15-BEDD2DF47723}"/>
               </a:ext>
             </a:extLst>
           </p:cNvPr>
@@ -2402,7 +2402,7 @@
           <p:cNvPr id="7" name="">
             <a:extLst xmlns:a="http://schemas.openxmlformats.org/drawingml/2006/main">
               <a:ext uri="{FF2B5EF4-FFF2-40B4-BE49-F238E27FC236}">
-                <a16:creationId xmlns:a16="http://schemas.microsoft.com/office/drawing/2014/main" id="{34E7509B-7F76-4F5A-B07F-D9EEAB95744D}"/>
+                <a16:creationId xmlns:a16="http://schemas.microsoft.com/office/drawing/2014/main" id="{C09CB1C4-508B-47A4-801A-C6AF1703461B}"/>
               </a:ext>
             </a:extLst>
           </p:cNvPr>
@@ -2452,7 +2452,7 @@
           <p:cNvPr id="8" name="">
             <a:extLst xmlns:a="http://schemas.openxmlformats.org/drawingml/2006/main">
               <a:ext uri="{FF2B5EF4-FFF2-40B4-BE49-F238E27FC236}">
-                <a16:creationId xmlns:a16="http://schemas.microsoft.com/office/drawing/2014/main" id="{67546B08-68A6-447D-A43A-4792B9EC5E21}"/>
+                <a16:creationId xmlns:a16="http://schemas.microsoft.com/office/drawing/2014/main" id="{9058CC85-BEFB-4B37-8DD1-F652FC8CEF87}"/>
               </a:ext>
             </a:extLst>
           </p:cNvPr>
@@ -2519,7 +2519,7 @@
           <p:cNvPr id="9" name="">
             <a:extLst xmlns:a="http://schemas.openxmlformats.org/drawingml/2006/main">
               <a:ext uri="{FF2B5EF4-FFF2-40B4-BE49-F238E27FC236}">
-                <a16:creationId xmlns:a16="http://schemas.microsoft.com/office/drawing/2014/main" id="{1630FAF0-A808-42D0-AF09-B8FF6C1E82ED}"/>
+                <a16:creationId xmlns:a16="http://schemas.microsoft.com/office/drawing/2014/main" id="{38E90D93-FFE6-4182-8F11-EE791FEE3E6A}"/>
               </a:ext>
             </a:extLst>
           </p:cNvPr>
@@ -2554,7 +2554,7 @@
           <p:cNvPr id="10" name="">
             <a:extLst xmlns:a="http://schemas.openxmlformats.org/drawingml/2006/main">
               <a:ext uri="{FF2B5EF4-FFF2-40B4-BE49-F238E27FC236}">
-                <a16:creationId xmlns:a16="http://schemas.microsoft.com/office/drawing/2014/main" id="{6FB384EA-450E-4CB0-BF86-0472552EBDB5}"/>
+                <a16:creationId xmlns:a16="http://schemas.microsoft.com/office/drawing/2014/main" id="{8CF0A7B0-2736-4368-B9A8-2C1E49365D36}"/>
               </a:ext>
             </a:extLst>
           </p:cNvPr>
@@ -2587,7 +2587,7 @@
           <p:cNvPr id="11" name="">
             <a:extLst xmlns:a="http://schemas.openxmlformats.org/drawingml/2006/main">
               <a:ext uri="{FF2B5EF4-FFF2-40B4-BE49-F238E27FC236}">
-                <a16:creationId xmlns:a16="http://schemas.microsoft.com/office/drawing/2014/main" id="{99B8C2F0-055A-4686-B95A-858BAF323B8A}"/>
+                <a16:creationId xmlns:a16="http://schemas.microsoft.com/office/drawing/2014/main" id="{B29F2CA0-CABA-4B10-A142-033349EF70F1}"/>
               </a:ext>
             </a:extLst>
           </p:cNvPr>
@@ -2637,7 +2637,7 @@
           <p:cNvPr id="12" name="">
             <a:extLst xmlns:a="http://schemas.openxmlformats.org/drawingml/2006/main">
               <a:ext uri="{FF2B5EF4-FFF2-40B4-BE49-F238E27FC236}">
-                <a16:creationId xmlns:a16="http://schemas.microsoft.com/office/drawing/2014/main" id="{BD09E43D-A3C7-4A06-AE5D-725BEC4693A3}"/>
+                <a16:creationId xmlns:a16="http://schemas.microsoft.com/office/drawing/2014/main" id="{4931A9A6-D37A-4C90-B450-EAAE1D1CF4D1}"/>
               </a:ext>
             </a:extLst>
           </p:cNvPr>
@@ -2687,7 +2687,7 @@
           <p:cNvPr id="13" name="">
             <a:extLst xmlns:a="http://schemas.openxmlformats.org/drawingml/2006/main">
               <a:ext uri="{FF2B5EF4-FFF2-40B4-BE49-F238E27FC236}">
-                <a16:creationId xmlns:a16="http://schemas.microsoft.com/office/drawing/2014/main" id="{FB202BF9-1340-4492-8868-CB6F2410320B}"/>
+                <a16:creationId xmlns:a16="http://schemas.microsoft.com/office/drawing/2014/main" id="{41750B02-632A-487B-AEA1-EC32CE531AFA}"/>
               </a:ext>
             </a:extLst>
           </p:cNvPr>
@@ -2741,7 +2741,7 @@
           <p:cNvPr id="14" name="">
             <a:extLst xmlns:a="http://schemas.openxmlformats.org/drawingml/2006/main">
               <a:ext uri="{FF2B5EF4-FFF2-40B4-BE49-F238E27FC236}">
-                <a16:creationId xmlns:a16="http://schemas.microsoft.com/office/drawing/2014/main" id="{D679C584-271D-4416-8C52-1B91B62FBF25}"/>
+                <a16:creationId xmlns:a16="http://schemas.microsoft.com/office/drawing/2014/main" id="{712FFB53-E46D-4232-8D10-62AE7B19B2A1}"/>
               </a:ext>
             </a:extLst>
           </p:cNvPr>
@@ -2795,7 +2795,7 @@
           <p:cNvPr id="15" name="">
             <a:extLst xmlns:a="http://schemas.openxmlformats.org/drawingml/2006/main">
               <a:ext uri="{FF2B5EF4-FFF2-40B4-BE49-F238E27FC236}">
-                <a16:creationId xmlns:a16="http://schemas.microsoft.com/office/drawing/2014/main" id="{B200B075-C744-49EA-92B5-E52BC63D7467}"/>
+                <a16:creationId xmlns:a16="http://schemas.microsoft.com/office/drawing/2014/main" id="{7A51AF8E-E698-4289-A91B-A4FFCA04FAAA}"/>
               </a:ext>
             </a:extLst>
           </p:cNvPr>
@@ -2847,7 +2847,7 @@
     </p:spTree>
     <p:extLst>
       <p:ext uri="{BB962C8B-B14F-4D97-AF65-F5344CB8AC3E}">
-        <p14:creationId xmlns:p14="http://schemas.microsoft.com/office/powerpoint/2010/main" val="679936489"/>
+        <p14:creationId xmlns:p14="http://schemas.microsoft.com/office/powerpoint/2010/main" val="1259710694"/>
       </p:ext>
     </p:extLst>
   </p:cSld>
@@ -2878,7 +2878,7 @@
           <p:cNvPr id="1" name="">
             <a:extLst xmlns:a="http://schemas.openxmlformats.org/drawingml/2006/main">
               <a:ext uri="{FF2B5EF4-FFF2-40B4-BE49-F238E27FC236}">
-                <a16:creationId xmlns:a16="http://schemas.microsoft.com/office/drawing/2014/main" id="{E57DD6E6-C652-4AE0-9D9E-B6413ED93B12}"/>
+                <a16:creationId xmlns:a16="http://schemas.microsoft.com/office/drawing/2014/main" id="{9D1F5362-55CD-4928-9F43-110B178E3E04}"/>
               </a:ext>
             </a:extLst>
           </p:cNvPr>
@@ -2932,7 +2932,7 @@
           <p:cNvPr id="2" name="">
             <a:extLst xmlns:a="http://schemas.openxmlformats.org/drawingml/2006/main">
               <a:ext uri="{FF2B5EF4-FFF2-40B4-BE49-F238E27FC236}">
-                <a16:creationId xmlns:a16="http://schemas.microsoft.com/office/drawing/2014/main" id="{990B1F8A-ED98-49B1-A5A8-9C83CC274C5B}"/>
+                <a16:creationId xmlns:a16="http://schemas.microsoft.com/office/drawing/2014/main" id="{32EF4F65-6572-4C4F-8287-437439FFAECF}"/>
               </a:ext>
             </a:extLst>
           </p:cNvPr>
@@ -2963,7 +2963,7 @@
           <p:cNvPr id="3" name="">
             <a:extLst xmlns:a="http://schemas.openxmlformats.org/drawingml/2006/main">
               <a:ext uri="{FF2B5EF4-FFF2-40B4-BE49-F238E27FC236}">
-                <a16:creationId xmlns:a16="http://schemas.microsoft.com/office/drawing/2014/main" id="{EEB6A267-AE93-4788-ABEF-6BCDE2DDB864}"/>
+                <a16:creationId xmlns:a16="http://schemas.microsoft.com/office/drawing/2014/main" id="{25A132F1-DE15-4C51-8730-0420DDC87EBE}"/>
               </a:ext>
             </a:extLst>
           </p:cNvPr>
@@ -3013,7 +3013,7 @@
           <p:cNvPr id="4" name="">
             <a:extLst xmlns:a="http://schemas.openxmlformats.org/drawingml/2006/main">
               <a:ext uri="{FF2B5EF4-FFF2-40B4-BE49-F238E27FC236}">
-                <a16:creationId xmlns:a16="http://schemas.microsoft.com/office/drawing/2014/main" id="{3458CEEE-C27C-4615-A2D7-55F045423AC4}"/>
+                <a16:creationId xmlns:a16="http://schemas.microsoft.com/office/drawing/2014/main" id="{8915BFD6-96F4-4C24-96DC-66AF5D627257}"/>
               </a:ext>
             </a:extLst>
           </p:cNvPr>
@@ -3063,7 +3063,7 @@
           <p:cNvPr id="5" name="">
             <a:extLst xmlns:a="http://schemas.openxmlformats.org/drawingml/2006/main">
               <a:ext uri="{FF2B5EF4-FFF2-40B4-BE49-F238E27FC236}">
-                <a16:creationId xmlns:a16="http://schemas.microsoft.com/office/drawing/2014/main" id="{9CAD6E2B-F7C4-4B69-B413-5AE9EF3D3270}"/>
+                <a16:creationId xmlns:a16="http://schemas.microsoft.com/office/drawing/2014/main" id="{5FF45B74-4BE8-492E-BED3-9D417D3F181E}"/>
               </a:ext>
             </a:extLst>
           </p:cNvPr>
@@ -3113,7 +3113,7 @@
           <p:cNvPr id="6" name="">
             <a:extLst xmlns:a="http://schemas.openxmlformats.org/drawingml/2006/main">
               <a:ext uri="{FF2B5EF4-FFF2-40B4-BE49-F238E27FC236}">
-                <a16:creationId xmlns:a16="http://schemas.microsoft.com/office/drawing/2014/main" id="{ED3740ED-961B-44DE-B5B0-873756592307}"/>
+                <a16:creationId xmlns:a16="http://schemas.microsoft.com/office/drawing/2014/main" id="{3236ECB0-1892-4030-8437-8BF6EC26E6B9}"/>
               </a:ext>
             </a:extLst>
           </p:cNvPr>
@@ -3148,7 +3148,7 @@
           <p:cNvPr id="7" name="">
             <a:extLst xmlns:a="http://schemas.openxmlformats.org/drawingml/2006/main">
               <a:ext uri="{FF2B5EF4-FFF2-40B4-BE49-F238E27FC236}">
-                <a16:creationId xmlns:a16="http://schemas.microsoft.com/office/drawing/2014/main" id="{E096B736-42CC-47F0-B111-62BB205D48DC}"/>
+                <a16:creationId xmlns:a16="http://schemas.microsoft.com/office/drawing/2014/main" id="{1C8746B5-7122-47A5-911D-BD9F2E63CE02}"/>
               </a:ext>
             </a:extLst>
           </p:cNvPr>
@@ -3198,7 +3198,7 @@
           <p:cNvPr id="8" name="">
             <a:extLst xmlns:a="http://schemas.openxmlformats.org/drawingml/2006/main">
               <a:ext uri="{FF2B5EF4-FFF2-40B4-BE49-F238E27FC236}">
-                <a16:creationId xmlns:a16="http://schemas.microsoft.com/office/drawing/2014/main" id="{90813CD0-1538-4362-ABE4-8F117E6DA10A}"/>
+                <a16:creationId xmlns:a16="http://schemas.microsoft.com/office/drawing/2014/main" id="{DAE5B075-AA57-479D-A79F-713119A85E77}"/>
               </a:ext>
             </a:extLst>
           </p:cNvPr>
@@ -3248,7 +3248,7 @@
           <p:cNvPr id="9" name="">
             <a:extLst xmlns:a="http://schemas.openxmlformats.org/drawingml/2006/main">
               <a:ext uri="{FF2B5EF4-FFF2-40B4-BE49-F238E27FC236}">
-                <a16:creationId xmlns:a16="http://schemas.microsoft.com/office/drawing/2014/main" id="{D4CE1C07-729D-4D7B-8CB5-19A92AB1D6A6}"/>
+                <a16:creationId xmlns:a16="http://schemas.microsoft.com/office/drawing/2014/main" id="{77C3FFC9-E87D-4784-9EF8-2BD8F5AA861E}"/>
               </a:ext>
             </a:extLst>
           </p:cNvPr>
@@ -3283,7 +3283,7 @@
           <p:cNvPr id="10" name="">
             <a:extLst xmlns:a="http://schemas.openxmlformats.org/drawingml/2006/main">
               <a:ext uri="{FF2B5EF4-FFF2-40B4-BE49-F238E27FC236}">
-                <a16:creationId xmlns:a16="http://schemas.microsoft.com/office/drawing/2014/main" id="{FA36896E-2A93-43B4-BA87-671E5E1FA488}"/>
+                <a16:creationId xmlns:a16="http://schemas.microsoft.com/office/drawing/2014/main" id="{DCB60EBD-AE69-482E-B14E-BBA923B24047}"/>
               </a:ext>
             </a:extLst>
           </p:cNvPr>
@@ -3333,7 +3333,7 @@
           <p:cNvPr id="11" name="">
             <a:extLst xmlns:a="http://schemas.openxmlformats.org/drawingml/2006/main">
               <a:ext uri="{FF2B5EF4-FFF2-40B4-BE49-F238E27FC236}">
-                <a16:creationId xmlns:a16="http://schemas.microsoft.com/office/drawing/2014/main" id="{882759E3-697B-4367-9D44-CC99FFB8A288}"/>
+                <a16:creationId xmlns:a16="http://schemas.microsoft.com/office/drawing/2014/main" id="{EA30BF91-E32E-41AA-B56B-936EA02F10F0}"/>
               </a:ext>
             </a:extLst>
           </p:cNvPr>
@@ -3383,7 +3383,7 @@
           <p:cNvPr id="12" name="">
             <a:extLst xmlns:a="http://schemas.openxmlformats.org/drawingml/2006/main">
               <a:ext uri="{FF2B5EF4-FFF2-40B4-BE49-F238E27FC236}">
-                <a16:creationId xmlns:a16="http://schemas.microsoft.com/office/drawing/2014/main" id="{638B916D-C0BC-4FCD-B8D6-219A8175B362}"/>
+                <a16:creationId xmlns:a16="http://schemas.microsoft.com/office/drawing/2014/main" id="{3987443E-BCB3-45BF-A13A-29669B07E8C2}"/>
               </a:ext>
             </a:extLst>
           </p:cNvPr>
@@ -3418,7 +3418,7 @@
           <p:cNvPr id="13" name="">
             <a:extLst xmlns:a="http://schemas.openxmlformats.org/drawingml/2006/main">
               <a:ext uri="{FF2B5EF4-FFF2-40B4-BE49-F238E27FC236}">
-                <a16:creationId xmlns:a16="http://schemas.microsoft.com/office/drawing/2014/main" id="{4B19D959-6C95-426C-B928-57F5748610DF}"/>
+                <a16:creationId xmlns:a16="http://schemas.microsoft.com/office/drawing/2014/main" id="{1394FCB8-F264-49F2-9CDC-28CF66559144}"/>
               </a:ext>
             </a:extLst>
           </p:cNvPr>
@@ -3468,7 +3468,7 @@
           <p:cNvPr id="14" name="">
             <a:extLst xmlns:a="http://schemas.openxmlformats.org/drawingml/2006/main">
               <a:ext uri="{FF2B5EF4-FFF2-40B4-BE49-F238E27FC236}">
-                <a16:creationId xmlns:a16="http://schemas.microsoft.com/office/drawing/2014/main" id="{7136A8C0-B1E4-410C-8D9A-42B454FD1964}"/>
+                <a16:creationId xmlns:a16="http://schemas.microsoft.com/office/drawing/2014/main" id="{EAA11E9B-C6FF-434F-A81F-AD7B58E7D447}"/>
               </a:ext>
             </a:extLst>
           </p:cNvPr>
@@ -3518,7 +3518,7 @@
           <p:cNvPr id="15" name="">
             <a:extLst xmlns:a="http://schemas.openxmlformats.org/drawingml/2006/main">
               <a:ext uri="{FF2B5EF4-FFF2-40B4-BE49-F238E27FC236}">
-                <a16:creationId xmlns:a16="http://schemas.microsoft.com/office/drawing/2014/main" id="{1903D772-96B9-442D-9061-566DC0686EFB}"/>
+                <a16:creationId xmlns:a16="http://schemas.microsoft.com/office/drawing/2014/main" id="{3B14E90F-2F69-44B6-9071-B7A41CBCE8AB}"/>
               </a:ext>
             </a:extLst>
           </p:cNvPr>
@@ -3553,7 +3553,7 @@
           <p:cNvPr id="16" name="">
             <a:extLst xmlns:a="http://schemas.openxmlformats.org/drawingml/2006/main">
               <a:ext uri="{FF2B5EF4-FFF2-40B4-BE49-F238E27FC236}">
-                <a16:creationId xmlns:a16="http://schemas.microsoft.com/office/drawing/2014/main" id="{E69D3D1F-BE8B-4B0B-B704-B9833CC0C77F}"/>
+                <a16:creationId xmlns:a16="http://schemas.microsoft.com/office/drawing/2014/main" id="{B2797DD6-E5E8-4BCC-8AC9-2A1E4634F8E0}"/>
               </a:ext>
             </a:extLst>
           </p:cNvPr>
@@ -3603,7 +3603,7 @@
           <p:cNvPr id="17" name="">
             <a:extLst xmlns:a="http://schemas.openxmlformats.org/drawingml/2006/main">
               <a:ext uri="{FF2B5EF4-FFF2-40B4-BE49-F238E27FC236}">
-                <a16:creationId xmlns:a16="http://schemas.microsoft.com/office/drawing/2014/main" id="{3DF6860E-9B31-4CB9-B42E-08B35CE8C38F}"/>
+                <a16:creationId xmlns:a16="http://schemas.microsoft.com/office/drawing/2014/main" id="{4913A627-0150-4FA5-BADB-2B1E29854423}"/>
               </a:ext>
             </a:extLst>
           </p:cNvPr>
@@ -3653,7 +3653,7 @@
           <p:cNvPr id="18" name="">
             <a:extLst xmlns:a="http://schemas.openxmlformats.org/drawingml/2006/main">
               <a:ext uri="{FF2B5EF4-FFF2-40B4-BE49-F238E27FC236}">
-                <a16:creationId xmlns:a16="http://schemas.microsoft.com/office/drawing/2014/main" id="{F402CA3C-EA7F-4EEB-BE49-79D2D79EAFD0}"/>
+                <a16:creationId xmlns:a16="http://schemas.microsoft.com/office/drawing/2014/main" id="{CBABF193-AFB1-48C5-BBE9-936EE7057FE6}"/>
               </a:ext>
             </a:extLst>
           </p:cNvPr>
@@ -3688,7 +3688,7 @@
           <p:cNvPr id="19" name="">
             <a:extLst xmlns:a="http://schemas.openxmlformats.org/drawingml/2006/main">
               <a:ext uri="{FF2B5EF4-FFF2-40B4-BE49-F238E27FC236}">
-                <a16:creationId xmlns:a16="http://schemas.microsoft.com/office/drawing/2014/main" id="{EE478120-5B65-4F26-84FF-C418DBF73E8C}"/>
+                <a16:creationId xmlns:a16="http://schemas.microsoft.com/office/drawing/2014/main" id="{15D880E1-B16F-4C4F-B9BD-701B4F7FAA0B}"/>
               </a:ext>
             </a:extLst>
           </p:cNvPr>
@@ -3721,7 +3721,7 @@
           <p:cNvPr id="20" name="">
             <a:extLst xmlns:a="http://schemas.openxmlformats.org/drawingml/2006/main">
               <a:ext uri="{FF2B5EF4-FFF2-40B4-BE49-F238E27FC236}">
-                <a16:creationId xmlns:a16="http://schemas.microsoft.com/office/drawing/2014/main" id="{CBEDC49F-378C-4EF4-950F-BF7A5949D9FE}"/>
+                <a16:creationId xmlns:a16="http://schemas.microsoft.com/office/drawing/2014/main" id="{F31D1097-B859-4B06-B6C6-640DE3055F5A}"/>
               </a:ext>
             </a:extLst>
           </p:cNvPr>
@@ -3771,7 +3771,7 @@
           <p:cNvPr id="21" name="">
             <a:extLst xmlns:a="http://schemas.openxmlformats.org/drawingml/2006/main">
               <a:ext uri="{FF2B5EF4-FFF2-40B4-BE49-F238E27FC236}">
-                <a16:creationId xmlns:a16="http://schemas.microsoft.com/office/drawing/2014/main" id="{ACE19121-5D42-4723-B66B-7207826AF2E0}"/>
+                <a16:creationId xmlns:a16="http://schemas.microsoft.com/office/drawing/2014/main" id="{EAAF8C39-676D-47F4-9B70-B10B02265261}"/>
               </a:ext>
             </a:extLst>
           </p:cNvPr>
@@ -3819,7 +3819,7 @@
     </p:spTree>
     <p:extLst>
       <p:ext uri="{BB962C8B-B14F-4D97-AF65-F5344CB8AC3E}">
-        <p14:creationId xmlns:p14="http://schemas.microsoft.com/office/powerpoint/2010/main" val="1731241131"/>
+        <p14:creationId xmlns:p14="http://schemas.microsoft.com/office/powerpoint/2010/main" val="1888479979"/>
       </p:ext>
     </p:extLst>
   </p:cSld>
@@ -3850,7 +3850,7 @@
           <p:cNvPr id="1" name="">
             <a:extLst xmlns:a="http://schemas.openxmlformats.org/drawingml/2006/main">
               <a:ext uri="{FF2B5EF4-FFF2-40B4-BE49-F238E27FC236}">
-                <a16:creationId xmlns:a16="http://schemas.microsoft.com/office/drawing/2014/main" id="{4BA6B773-FFA2-47C8-A953-B431ECA85FA0}"/>
+                <a16:creationId xmlns:a16="http://schemas.microsoft.com/office/drawing/2014/main" id="{A803415A-92C0-4B5A-B4FA-36687BF15F79}"/>
               </a:ext>
             </a:extLst>
           </p:cNvPr>
@@ -3904,7 +3904,7 @@
           <p:cNvPr id="2" name="">
             <a:extLst xmlns:a="http://schemas.openxmlformats.org/drawingml/2006/main">
               <a:ext uri="{FF2B5EF4-FFF2-40B4-BE49-F238E27FC236}">
-                <a16:creationId xmlns:a16="http://schemas.microsoft.com/office/drawing/2014/main" id="{4EED8B2A-37B2-4FA9-942B-2BFD67E6E81A}"/>
+                <a16:creationId xmlns:a16="http://schemas.microsoft.com/office/drawing/2014/main" id="{AA3743BC-2304-47CA-ACD7-6270435F67BB}"/>
               </a:ext>
             </a:extLst>
           </p:cNvPr>
@@ -3935,7 +3935,7 @@
           <p:cNvPr id="3" name="">
             <a:extLst xmlns:a="http://schemas.openxmlformats.org/drawingml/2006/main">
               <a:ext uri="{FF2B5EF4-FFF2-40B4-BE49-F238E27FC236}">
-                <a16:creationId xmlns:a16="http://schemas.microsoft.com/office/drawing/2014/main" id="{37022283-F87A-48FE-B15A-A5C6EAAD097D}"/>
+                <a16:creationId xmlns:a16="http://schemas.microsoft.com/office/drawing/2014/main" id="{786F9807-F321-45E7-A1C6-A1D14D858728}"/>
               </a:ext>
             </a:extLst>
           </p:cNvPr>
@@ -3985,7 +3985,7 @@
           <p:cNvPr id="4" name="">
             <a:extLst xmlns:a="http://schemas.openxmlformats.org/drawingml/2006/main">
               <a:ext uri="{FF2B5EF4-FFF2-40B4-BE49-F238E27FC236}">
-                <a16:creationId xmlns:a16="http://schemas.microsoft.com/office/drawing/2014/main" id="{6D5E1355-981A-45C7-94DD-0C4010B336A0}"/>
+                <a16:creationId xmlns:a16="http://schemas.microsoft.com/office/drawing/2014/main" id="{F6F6C493-177D-4E4F-B323-83D5D322C615}"/>
               </a:ext>
             </a:extLst>
           </p:cNvPr>
@@ -4035,7 +4035,7 @@
           <p:cNvPr id="5" name="">
             <a:extLst xmlns:a="http://schemas.openxmlformats.org/drawingml/2006/main">
               <a:ext uri="{FF2B5EF4-FFF2-40B4-BE49-F238E27FC236}">
-                <a16:creationId xmlns:a16="http://schemas.microsoft.com/office/drawing/2014/main" id="{8417F8B6-B094-4D52-8AB3-9D6EFA3F2E8B}"/>
+                <a16:creationId xmlns:a16="http://schemas.microsoft.com/office/drawing/2014/main" id="{CB7ECDF5-9C67-4523-A709-162778E8FFBA}"/>
               </a:ext>
             </a:extLst>
           </p:cNvPr>
@@ -4085,7 +4085,7 @@
           <p:cNvPr id="6" name="">
             <a:extLst xmlns:a="http://schemas.openxmlformats.org/drawingml/2006/main">
               <a:ext uri="{FF2B5EF4-FFF2-40B4-BE49-F238E27FC236}">
-                <a16:creationId xmlns:a16="http://schemas.microsoft.com/office/drawing/2014/main" id="{44167991-7987-4248-9E94-D4A88DB8AA0A}"/>
+                <a16:creationId xmlns:a16="http://schemas.microsoft.com/office/drawing/2014/main" id="{496C7373-69AD-4ECE-98AB-5D5AC27F12BB}"/>
               </a:ext>
             </a:extLst>
           </p:cNvPr>
@@ -4120,7 +4120,7 @@
           <p:cNvPr id="7" name="">
             <a:extLst xmlns:a="http://schemas.openxmlformats.org/drawingml/2006/main">
               <a:ext uri="{FF2B5EF4-FFF2-40B4-BE49-F238E27FC236}">
-                <a16:creationId xmlns:a16="http://schemas.microsoft.com/office/drawing/2014/main" id="{4EEA732E-1CA7-4D59-B605-29033ADC2A45}"/>
+                <a16:creationId xmlns:a16="http://schemas.microsoft.com/office/drawing/2014/main" id="{BA2DFEEF-0214-47C2-BB26-6E4DAA508897}"/>
               </a:ext>
             </a:extLst>
           </p:cNvPr>
@@ -4153,7 +4153,7 @@
           <p:cNvPr id="8" name="">
             <a:extLst xmlns:a="http://schemas.openxmlformats.org/drawingml/2006/main">
               <a:ext uri="{FF2B5EF4-FFF2-40B4-BE49-F238E27FC236}">
-                <a16:creationId xmlns:a16="http://schemas.microsoft.com/office/drawing/2014/main" id="{C7C43223-B2E3-44F2-98BA-569EC635866F}"/>
+                <a16:creationId xmlns:a16="http://schemas.microsoft.com/office/drawing/2014/main" id="{1C561075-E93F-46EE-B8D8-8164F485A057}"/>
               </a:ext>
             </a:extLst>
           </p:cNvPr>
@@ -4203,7 +4203,7 @@
           <p:cNvPr id="9" name="">
             <a:extLst xmlns:a="http://schemas.openxmlformats.org/drawingml/2006/main">
               <a:ext uri="{FF2B5EF4-FFF2-40B4-BE49-F238E27FC236}">
-                <a16:creationId xmlns:a16="http://schemas.microsoft.com/office/drawing/2014/main" id="{A6997151-79FA-4B39-B8FD-53F9963E4335}"/>
+                <a16:creationId xmlns:a16="http://schemas.microsoft.com/office/drawing/2014/main" id="{0A2E0545-0D36-49D1-8B79-982961A3DB7C}"/>
               </a:ext>
             </a:extLst>
           </p:cNvPr>
@@ -4241,7 +4241,7 @@
           <p:cNvPr id="10" name="">
             <a:extLst xmlns:a="http://schemas.openxmlformats.org/drawingml/2006/main">
               <a:ext uri="{FF2B5EF4-FFF2-40B4-BE49-F238E27FC236}">
-                <a16:creationId xmlns:a16="http://schemas.microsoft.com/office/drawing/2014/main" id="{A5581D27-2D6B-4F3D-9769-8102D124A962}"/>
+                <a16:creationId xmlns:a16="http://schemas.microsoft.com/office/drawing/2014/main" id="{C3FF0A36-2A99-4520-94FC-A10CD4F3FE9E}"/>
               </a:ext>
             </a:extLst>
           </p:cNvPr>
@@ -4272,7 +4272,7 @@
           <p:cNvPr id="11" name="">
             <a:extLst xmlns:a="http://schemas.openxmlformats.org/drawingml/2006/main">
               <a:ext uri="{FF2B5EF4-FFF2-40B4-BE49-F238E27FC236}">
-                <a16:creationId xmlns:a16="http://schemas.microsoft.com/office/drawing/2014/main" id="{BA4DA3F5-7D69-45AC-92A8-609B728FF79E}"/>
+                <a16:creationId xmlns:a16="http://schemas.microsoft.com/office/drawing/2014/main" id="{83D4FF50-8823-400D-BC59-64388CF4DE48}"/>
               </a:ext>
             </a:extLst>
           </p:cNvPr>
@@ -4322,7 +4322,7 @@
           <p:cNvPr id="12" name="">
             <a:extLst xmlns:a="http://schemas.openxmlformats.org/drawingml/2006/main">
               <a:ext uri="{FF2B5EF4-FFF2-40B4-BE49-F238E27FC236}">
-                <a16:creationId xmlns:a16="http://schemas.microsoft.com/office/drawing/2014/main" id="{22835E6B-2E2E-4728-A925-E3733CCEBC7C}"/>
+                <a16:creationId xmlns:a16="http://schemas.microsoft.com/office/drawing/2014/main" id="{6CF1372E-14DE-4588-9A8B-A5E432964F35}"/>
               </a:ext>
             </a:extLst>
           </p:cNvPr>
@@ -4353,7 +4353,7 @@
           <p:cNvPr id="13" name="">
             <a:extLst xmlns:a="http://schemas.openxmlformats.org/drawingml/2006/main">
               <a:ext uri="{FF2B5EF4-FFF2-40B4-BE49-F238E27FC236}">
-                <a16:creationId xmlns:a16="http://schemas.microsoft.com/office/drawing/2014/main" id="{36E4D996-A04B-4B50-A1B8-D495FAE9D378}"/>
+                <a16:creationId xmlns:a16="http://schemas.microsoft.com/office/drawing/2014/main" id="{A6E3023C-E884-47F5-A503-4040D014745D}"/>
               </a:ext>
             </a:extLst>
           </p:cNvPr>
@@ -4403,7 +4403,7 @@
           <p:cNvPr id="14" name="">
             <a:extLst xmlns:a="http://schemas.openxmlformats.org/drawingml/2006/main">
               <a:ext uri="{FF2B5EF4-FFF2-40B4-BE49-F238E27FC236}">
-                <a16:creationId xmlns:a16="http://schemas.microsoft.com/office/drawing/2014/main" id="{0BCBF94E-064F-46AF-AC77-563A14E6083A}"/>
+                <a16:creationId xmlns:a16="http://schemas.microsoft.com/office/drawing/2014/main" id="{45F71A8F-6249-4376-8ADF-2289713D7CD7}"/>
               </a:ext>
             </a:extLst>
           </p:cNvPr>
@@ -4434,7 +4434,7 @@
           <p:cNvPr id="15" name="">
             <a:extLst xmlns:a="http://schemas.openxmlformats.org/drawingml/2006/main">
               <a:ext uri="{FF2B5EF4-FFF2-40B4-BE49-F238E27FC236}">
-                <a16:creationId xmlns:a16="http://schemas.microsoft.com/office/drawing/2014/main" id="{83BFA2AE-685E-4018-8C4F-6688354DC450}"/>
+                <a16:creationId xmlns:a16="http://schemas.microsoft.com/office/drawing/2014/main" id="{0E32E3DA-35CD-43AF-9ADE-5E6D3AC5C73E}"/>
               </a:ext>
             </a:extLst>
           </p:cNvPr>
@@ -4484,7 +4484,7 @@
           <p:cNvPr id="16" name="">
             <a:extLst xmlns:a="http://schemas.openxmlformats.org/drawingml/2006/main">
               <a:ext uri="{FF2B5EF4-FFF2-40B4-BE49-F238E27FC236}">
-                <a16:creationId xmlns:a16="http://schemas.microsoft.com/office/drawing/2014/main" id="{532EDD18-98D4-42C7-AC2E-A20C07070CD6}"/>
+                <a16:creationId xmlns:a16="http://schemas.microsoft.com/office/drawing/2014/main" id="{C4F48A23-7469-4A4D-9C31-9DC21895AB7C}"/>
               </a:ext>
             </a:extLst>
           </p:cNvPr>
@@ -4519,7 +4519,7 @@
           <p:cNvPr id="17" name="">
             <a:extLst xmlns:a="http://schemas.openxmlformats.org/drawingml/2006/main">
               <a:ext uri="{FF2B5EF4-FFF2-40B4-BE49-F238E27FC236}">
-                <a16:creationId xmlns:a16="http://schemas.microsoft.com/office/drawing/2014/main" id="{D64A75B1-8445-4EBE-9AE3-9F241CDAF813}"/>
+                <a16:creationId xmlns:a16="http://schemas.microsoft.com/office/drawing/2014/main" id="{4FD6E288-E537-409F-AFE2-185138246522}"/>
               </a:ext>
             </a:extLst>
           </p:cNvPr>
@@ -4552,7 +4552,7 @@
           <p:cNvPr id="18" name="">
             <a:extLst xmlns:a="http://schemas.openxmlformats.org/drawingml/2006/main">
               <a:ext uri="{FF2B5EF4-FFF2-40B4-BE49-F238E27FC236}">
-                <a16:creationId xmlns:a16="http://schemas.microsoft.com/office/drawing/2014/main" id="{FB2C6BE6-3A3B-42CF-88D7-863C3B97A77C}"/>
+                <a16:creationId xmlns:a16="http://schemas.microsoft.com/office/drawing/2014/main" id="{E120B70F-B1F0-41F0-811B-AFDB066E7FFE}"/>
               </a:ext>
             </a:extLst>
           </p:cNvPr>
@@ -4602,7 +4602,7 @@
           <p:cNvPr id="19" name="">
             <a:extLst xmlns:a="http://schemas.openxmlformats.org/drawingml/2006/main">
               <a:ext uri="{FF2B5EF4-FFF2-40B4-BE49-F238E27FC236}">
-                <a16:creationId xmlns:a16="http://schemas.microsoft.com/office/drawing/2014/main" id="{531AA97D-354C-4639-8514-723143065028}"/>
+                <a16:creationId xmlns:a16="http://schemas.microsoft.com/office/drawing/2014/main" id="{E2490376-2AE7-43AD-B948-C3E71D6990D5}"/>
               </a:ext>
             </a:extLst>
           </p:cNvPr>
@@ -4640,7 +4640,7 @@
           <p:cNvPr id="20" name="">
             <a:extLst xmlns:a="http://schemas.openxmlformats.org/drawingml/2006/main">
               <a:ext uri="{FF2B5EF4-FFF2-40B4-BE49-F238E27FC236}">
-                <a16:creationId xmlns:a16="http://schemas.microsoft.com/office/drawing/2014/main" id="{3E7D72FD-AA32-49AA-B81B-F08EDD608CAC}"/>
+                <a16:creationId xmlns:a16="http://schemas.microsoft.com/office/drawing/2014/main" id="{9E03F1C6-FBA9-4482-A2E2-FD4DC434D57E}"/>
               </a:ext>
             </a:extLst>
           </p:cNvPr>
@@ -4671,7 +4671,7 @@
           <p:cNvPr id="21" name="">
             <a:extLst xmlns:a="http://schemas.openxmlformats.org/drawingml/2006/main">
               <a:ext uri="{FF2B5EF4-FFF2-40B4-BE49-F238E27FC236}">
-                <a16:creationId xmlns:a16="http://schemas.microsoft.com/office/drawing/2014/main" id="{B2EB6D55-94BE-4C44-B9F1-F69D8D550029}"/>
+                <a16:creationId xmlns:a16="http://schemas.microsoft.com/office/drawing/2014/main" id="{B3D528FF-36CF-4717-AAB2-414E1C08B6B8}"/>
               </a:ext>
             </a:extLst>
           </p:cNvPr>
@@ -4721,7 +4721,7 @@
           <p:cNvPr id="22" name="">
             <a:extLst xmlns:a="http://schemas.openxmlformats.org/drawingml/2006/main">
               <a:ext uri="{FF2B5EF4-FFF2-40B4-BE49-F238E27FC236}">
-                <a16:creationId xmlns:a16="http://schemas.microsoft.com/office/drawing/2014/main" id="{AC157B18-2B8A-461C-9278-F7C789B5886F}"/>
+                <a16:creationId xmlns:a16="http://schemas.microsoft.com/office/drawing/2014/main" id="{D117D64D-D5B4-44F9-80EE-5DD21F359636}"/>
               </a:ext>
             </a:extLst>
           </p:cNvPr>
@@ -4752,7 +4752,7 @@
           <p:cNvPr id="23" name="">
             <a:extLst xmlns:a="http://schemas.openxmlformats.org/drawingml/2006/main">
               <a:ext uri="{FF2B5EF4-FFF2-40B4-BE49-F238E27FC236}">
-                <a16:creationId xmlns:a16="http://schemas.microsoft.com/office/drawing/2014/main" id="{57C2D55F-6B12-4E64-A29E-435A8AC12AC0}"/>
+                <a16:creationId xmlns:a16="http://schemas.microsoft.com/office/drawing/2014/main" id="{710FDF28-ACDB-4A1A-BE3D-925B8CA7FF91}"/>
               </a:ext>
             </a:extLst>
           </p:cNvPr>
@@ -4802,7 +4802,7 @@
           <p:cNvPr id="24" name="">
             <a:extLst xmlns:a="http://schemas.openxmlformats.org/drawingml/2006/main">
               <a:ext uri="{FF2B5EF4-FFF2-40B4-BE49-F238E27FC236}">
-                <a16:creationId xmlns:a16="http://schemas.microsoft.com/office/drawing/2014/main" id="{3A76F97C-C58E-4517-8BE5-1762B31B64DB}"/>
+                <a16:creationId xmlns:a16="http://schemas.microsoft.com/office/drawing/2014/main" id="{A8A9F1A6-99C6-4A52-9508-A918E8E8081B}"/>
               </a:ext>
             </a:extLst>
           </p:cNvPr>
@@ -4833,7 +4833,7 @@
           <p:cNvPr id="25" name="">
             <a:extLst xmlns:a="http://schemas.openxmlformats.org/drawingml/2006/main">
               <a:ext uri="{FF2B5EF4-FFF2-40B4-BE49-F238E27FC236}">
-                <a16:creationId xmlns:a16="http://schemas.microsoft.com/office/drawing/2014/main" id="{E7E2DC2D-B642-4F64-BD9F-68C85AE88917}"/>
+                <a16:creationId xmlns:a16="http://schemas.microsoft.com/office/drawing/2014/main" id="{E22C1A48-327F-4AD2-9C66-C7617CA54034}"/>
               </a:ext>
             </a:extLst>
           </p:cNvPr>
@@ -4883,7 +4883,7 @@
           <p:cNvPr id="26" name="">
             <a:extLst xmlns:a="http://schemas.openxmlformats.org/drawingml/2006/main">
               <a:ext uri="{FF2B5EF4-FFF2-40B4-BE49-F238E27FC236}">
-                <a16:creationId xmlns:a16="http://schemas.microsoft.com/office/drawing/2014/main" id="{BEEEF0F9-58AF-44E4-B2AD-C0471BCFAACC}"/>
+                <a16:creationId xmlns:a16="http://schemas.microsoft.com/office/drawing/2014/main" id="{324D123E-E5B4-4232-9CFF-631B34378D4D}"/>
               </a:ext>
             </a:extLst>
           </p:cNvPr>
@@ -4918,7 +4918,7 @@
           <p:cNvPr id="27" name="">
             <a:extLst xmlns:a="http://schemas.openxmlformats.org/drawingml/2006/main">
               <a:ext uri="{FF2B5EF4-FFF2-40B4-BE49-F238E27FC236}">
-                <a16:creationId xmlns:a16="http://schemas.microsoft.com/office/drawing/2014/main" id="{7A2E563E-7FAE-489E-BC4E-39F34A031F25}"/>
+                <a16:creationId xmlns:a16="http://schemas.microsoft.com/office/drawing/2014/main" id="{5C211147-8299-43D3-9B77-5342D965259A}"/>
               </a:ext>
             </a:extLst>
           </p:cNvPr>
@@ -4951,7 +4951,7 @@
           <p:cNvPr id="28" name="">
             <a:extLst xmlns:a="http://schemas.openxmlformats.org/drawingml/2006/main">
               <a:ext uri="{FF2B5EF4-FFF2-40B4-BE49-F238E27FC236}">
-                <a16:creationId xmlns:a16="http://schemas.microsoft.com/office/drawing/2014/main" id="{61D70734-5893-4906-827E-64CB6DB78074}"/>
+                <a16:creationId xmlns:a16="http://schemas.microsoft.com/office/drawing/2014/main" id="{FDCC025A-0B6B-4F2D-A7E2-2B0823C67E0F}"/>
               </a:ext>
             </a:extLst>
           </p:cNvPr>
@@ -5001,7 +5001,7 @@
           <p:cNvPr id="29" name="">
             <a:extLst xmlns:a="http://schemas.openxmlformats.org/drawingml/2006/main">
               <a:ext uri="{FF2B5EF4-FFF2-40B4-BE49-F238E27FC236}">
-                <a16:creationId xmlns:a16="http://schemas.microsoft.com/office/drawing/2014/main" id="{D31A151E-FBC2-4841-9030-C4586D6EC465}"/>
+                <a16:creationId xmlns:a16="http://schemas.microsoft.com/office/drawing/2014/main" id="{6CB33E3F-238B-42E2-A975-D671D2193619}"/>
               </a:ext>
             </a:extLst>
           </p:cNvPr>
@@ -5039,7 +5039,7 @@
           <p:cNvPr id="30" name="">
             <a:extLst xmlns:a="http://schemas.openxmlformats.org/drawingml/2006/main">
               <a:ext uri="{FF2B5EF4-FFF2-40B4-BE49-F238E27FC236}">
-                <a16:creationId xmlns:a16="http://schemas.microsoft.com/office/drawing/2014/main" id="{7046FA9E-83B4-4195-9DE3-410B0EEC7826}"/>
+                <a16:creationId xmlns:a16="http://schemas.microsoft.com/office/drawing/2014/main" id="{245BA1C1-9AA4-49E5-A553-790C2D4FAB93}"/>
               </a:ext>
             </a:extLst>
           </p:cNvPr>
@@ -5070,7 +5070,7 @@
           <p:cNvPr id="31" name="">
             <a:extLst xmlns:a="http://schemas.openxmlformats.org/drawingml/2006/main">
               <a:ext uri="{FF2B5EF4-FFF2-40B4-BE49-F238E27FC236}">
-                <a16:creationId xmlns:a16="http://schemas.microsoft.com/office/drawing/2014/main" id="{ABE65CBE-08EA-4891-AF93-F1066BFCCB90}"/>
+                <a16:creationId xmlns:a16="http://schemas.microsoft.com/office/drawing/2014/main" id="{E8AA09B7-B529-4B53-9730-9DA6B72A302D}"/>
               </a:ext>
             </a:extLst>
           </p:cNvPr>
@@ -5120,7 +5120,7 @@
           <p:cNvPr id="32" name="">
             <a:extLst xmlns:a="http://schemas.openxmlformats.org/drawingml/2006/main">
               <a:ext uri="{FF2B5EF4-FFF2-40B4-BE49-F238E27FC236}">
-                <a16:creationId xmlns:a16="http://schemas.microsoft.com/office/drawing/2014/main" id="{9C9EAFFE-924F-42A1-B8C4-C9151D0DEC74}"/>
+                <a16:creationId xmlns:a16="http://schemas.microsoft.com/office/drawing/2014/main" id="{DB5F59C5-E486-46CF-AE9B-AD8DC418EADB}"/>
               </a:ext>
             </a:extLst>
           </p:cNvPr>
@@ -5151,7 +5151,7 @@
           <p:cNvPr id="33" name="">
             <a:extLst xmlns:a="http://schemas.openxmlformats.org/drawingml/2006/main">
               <a:ext uri="{FF2B5EF4-FFF2-40B4-BE49-F238E27FC236}">
-                <a16:creationId xmlns:a16="http://schemas.microsoft.com/office/drawing/2014/main" id="{68F75DAF-169E-47E4-8800-8D9E63B18216}"/>
+                <a16:creationId xmlns:a16="http://schemas.microsoft.com/office/drawing/2014/main" id="{C6197E18-287B-4F21-9317-6FCAB867D3F5}"/>
               </a:ext>
             </a:extLst>
           </p:cNvPr>
@@ -5201,7 +5201,7 @@
           <p:cNvPr id="34" name="">
             <a:extLst xmlns:a="http://schemas.openxmlformats.org/drawingml/2006/main">
               <a:ext uri="{FF2B5EF4-FFF2-40B4-BE49-F238E27FC236}">
-                <a16:creationId xmlns:a16="http://schemas.microsoft.com/office/drawing/2014/main" id="{DFD0DEAF-4974-4F37-A723-A952EAE5CD7D}"/>
+                <a16:creationId xmlns:a16="http://schemas.microsoft.com/office/drawing/2014/main" id="{CB0E6FC5-FBFC-4FA5-BB6D-1DBAEE7BC1EE}"/>
               </a:ext>
             </a:extLst>
           </p:cNvPr>
@@ -5232,7 +5232,7 @@
           <p:cNvPr id="35" name="">
             <a:extLst xmlns:a="http://schemas.openxmlformats.org/drawingml/2006/main">
               <a:ext uri="{FF2B5EF4-FFF2-40B4-BE49-F238E27FC236}">
-                <a16:creationId xmlns:a16="http://schemas.microsoft.com/office/drawing/2014/main" id="{D6B1B64D-5678-4544-A041-66E30E99059C}"/>
+                <a16:creationId xmlns:a16="http://schemas.microsoft.com/office/drawing/2014/main" id="{99EB9C3C-A644-4FE8-A270-6C639BB1E1EE}"/>
               </a:ext>
             </a:extLst>
           </p:cNvPr>
@@ -5282,7 +5282,7 @@
           <p:cNvPr id="36" name="">
             <a:extLst xmlns:a="http://schemas.openxmlformats.org/drawingml/2006/main">
               <a:ext uri="{FF2B5EF4-FFF2-40B4-BE49-F238E27FC236}">
-                <a16:creationId xmlns:a16="http://schemas.microsoft.com/office/drawing/2014/main" id="{04277CD1-357E-4C1C-AA36-2605A59743D1}"/>
+                <a16:creationId xmlns:a16="http://schemas.microsoft.com/office/drawing/2014/main" id="{3D29E1B2-93D6-4BF1-98B5-216FAE909881}"/>
               </a:ext>
             </a:extLst>
           </p:cNvPr>
@@ -5330,7 +5330,7 @@
     </p:spTree>
     <p:extLst>
       <p:ext uri="{BB962C8B-B14F-4D97-AF65-F5344CB8AC3E}">
-        <p14:creationId xmlns:p14="http://schemas.microsoft.com/office/powerpoint/2010/main" val="872971955"/>
+        <p14:creationId xmlns:p14="http://schemas.microsoft.com/office/powerpoint/2010/main" val="541009277"/>
       </p:ext>
     </p:extLst>
   </p:cSld>
@@ -5361,7 +5361,7 @@
           <p:cNvPr id="1" name="">
             <a:extLst xmlns:a="http://schemas.openxmlformats.org/drawingml/2006/main">
               <a:ext uri="{FF2B5EF4-FFF2-40B4-BE49-F238E27FC236}">
-                <a16:creationId xmlns:a16="http://schemas.microsoft.com/office/drawing/2014/main" id="{D6E63049-77DB-4E0E-990D-D4F661D2E73E}"/>
+                <a16:creationId xmlns:a16="http://schemas.microsoft.com/office/drawing/2014/main" id="{E3D0C058-3FBF-43C2-8CCF-9521B2FE9ADE}"/>
               </a:ext>
             </a:extLst>
           </p:cNvPr>
@@ -5415,7 +5415,7 @@
           <p:cNvPr id="2" name="">
             <a:extLst xmlns:a="http://schemas.openxmlformats.org/drawingml/2006/main">
               <a:ext uri="{FF2B5EF4-FFF2-40B4-BE49-F238E27FC236}">
-                <a16:creationId xmlns:a16="http://schemas.microsoft.com/office/drawing/2014/main" id="{96D995E1-9708-4DF2-BA89-CF64874F0E0E}"/>
+                <a16:creationId xmlns:a16="http://schemas.microsoft.com/office/drawing/2014/main" id="{5A2792FF-25FE-487C-9331-0E9652C186DC}"/>
               </a:ext>
             </a:extLst>
           </p:cNvPr>
@@ -5446,7 +5446,7 @@
           <p:cNvPr id="3" name="">
             <a:extLst xmlns:a="http://schemas.openxmlformats.org/drawingml/2006/main">
               <a:ext uri="{FF2B5EF4-FFF2-40B4-BE49-F238E27FC236}">
-                <a16:creationId xmlns:a16="http://schemas.microsoft.com/office/drawing/2014/main" id="{2CDD02F3-BC09-494E-8FE8-A5410F16C9E2}"/>
+                <a16:creationId xmlns:a16="http://schemas.microsoft.com/office/drawing/2014/main" id="{91A42306-29EC-4969-900A-5725CD3DE0DC}"/>
               </a:ext>
             </a:extLst>
           </p:cNvPr>
@@ -5496,7 +5496,7 @@
           <p:cNvPr id="4" name="">
             <a:extLst xmlns:a="http://schemas.openxmlformats.org/drawingml/2006/main">
               <a:ext uri="{FF2B5EF4-FFF2-40B4-BE49-F238E27FC236}">
-                <a16:creationId xmlns:a16="http://schemas.microsoft.com/office/drawing/2014/main" id="{9C04671A-3578-4AB0-9221-FAA9EC7CCA8F}"/>
+                <a16:creationId xmlns:a16="http://schemas.microsoft.com/office/drawing/2014/main" id="{BF24433F-D1D5-4802-818F-16FD8AB93704}"/>
               </a:ext>
             </a:extLst>
           </p:cNvPr>
@@ -5546,7 +5546,7 @@
           <p:cNvPr id="5" name="">
             <a:extLst xmlns:a="http://schemas.openxmlformats.org/drawingml/2006/main">
               <a:ext uri="{FF2B5EF4-FFF2-40B4-BE49-F238E27FC236}">
-                <a16:creationId xmlns:a16="http://schemas.microsoft.com/office/drawing/2014/main" id="{7098ACC1-AF3B-4DA1-8723-0613F30789F6}"/>
+                <a16:creationId xmlns:a16="http://schemas.microsoft.com/office/drawing/2014/main" id="{C277DDC5-6FEB-4B5D-9EC1-D2C4E9B060B8}"/>
               </a:ext>
             </a:extLst>
           </p:cNvPr>
@@ -5596,7 +5596,7 @@
           <p:cNvPr id="6" name="">
             <a:extLst xmlns:a="http://schemas.openxmlformats.org/drawingml/2006/main">
               <a:ext uri="{FF2B5EF4-FFF2-40B4-BE49-F238E27FC236}">
-                <a16:creationId xmlns:a16="http://schemas.microsoft.com/office/drawing/2014/main" id="{F351F19C-1F2F-4A19-8B41-13AE4086E711}"/>
+                <a16:creationId xmlns:a16="http://schemas.microsoft.com/office/drawing/2014/main" id="{AE213831-9939-47B4-8852-8E48D2C809A4}"/>
               </a:ext>
             </a:extLst>
           </p:cNvPr>
@@ -5631,7 +5631,7 @@
           <p:cNvPr id="7" name="">
             <a:extLst xmlns:a="http://schemas.openxmlformats.org/drawingml/2006/main">
               <a:ext uri="{FF2B5EF4-FFF2-40B4-BE49-F238E27FC236}">
-                <a16:creationId xmlns:a16="http://schemas.microsoft.com/office/drawing/2014/main" id="{D7C5671C-E758-4F86-A21E-C5089BB93F1A}"/>
+                <a16:creationId xmlns:a16="http://schemas.microsoft.com/office/drawing/2014/main" id="{D4B8DC4B-4E55-40EC-95E2-B06D4627D844}"/>
               </a:ext>
             </a:extLst>
           </p:cNvPr>
@@ -5664,7 +5664,7 @@
           <p:cNvPr id="8" name="">
             <a:extLst xmlns:a="http://schemas.openxmlformats.org/drawingml/2006/main">
               <a:ext uri="{FF2B5EF4-FFF2-40B4-BE49-F238E27FC236}">
-                <a16:creationId xmlns:a16="http://schemas.microsoft.com/office/drawing/2014/main" id="{3EB19644-2A37-48B7-9E23-9E9CC20B20BE}"/>
+                <a16:creationId xmlns:a16="http://schemas.microsoft.com/office/drawing/2014/main" id="{E58C6663-207F-4FF8-8226-D9BA7E774ADF}"/>
               </a:ext>
             </a:extLst>
           </p:cNvPr>
@@ -5714,7 +5714,7 @@
           <p:cNvPr id="9" name="">
             <a:extLst xmlns:a="http://schemas.openxmlformats.org/drawingml/2006/main">
               <a:ext uri="{FF2B5EF4-FFF2-40B4-BE49-F238E27FC236}">
-                <a16:creationId xmlns:a16="http://schemas.microsoft.com/office/drawing/2014/main" id="{6F065FDD-B8A6-4BED-809D-65042CC29C29}"/>
+                <a16:creationId xmlns:a16="http://schemas.microsoft.com/office/drawing/2014/main" id="{A5511CBC-260E-409E-A86B-401AB6F65E37}"/>
               </a:ext>
             </a:extLst>
           </p:cNvPr>
@@ -5752,7 +5752,7 @@
           <p:cNvPr id="10" name="">
             <a:extLst xmlns:a="http://schemas.openxmlformats.org/drawingml/2006/main">
               <a:ext uri="{FF2B5EF4-FFF2-40B4-BE49-F238E27FC236}">
-                <a16:creationId xmlns:a16="http://schemas.microsoft.com/office/drawing/2014/main" id="{5A396F2B-7107-443A-8854-3469C1C91EE2}"/>
+                <a16:creationId xmlns:a16="http://schemas.microsoft.com/office/drawing/2014/main" id="{FEBB2EB8-8555-48D9-BB34-1437CF5DE5F5}"/>
               </a:ext>
             </a:extLst>
           </p:cNvPr>
@@ -5783,7 +5783,7 @@
           <p:cNvPr id="11" name="">
             <a:extLst xmlns:a="http://schemas.openxmlformats.org/drawingml/2006/main">
               <a:ext uri="{FF2B5EF4-FFF2-40B4-BE49-F238E27FC236}">
-                <a16:creationId xmlns:a16="http://schemas.microsoft.com/office/drawing/2014/main" id="{BC1036E1-B0CC-4DA6-95FA-BBC12D150BDA}"/>
+                <a16:creationId xmlns:a16="http://schemas.microsoft.com/office/drawing/2014/main" id="{35C678A5-60BF-4F6D-9A9E-8170E3DA2029}"/>
               </a:ext>
             </a:extLst>
           </p:cNvPr>
@@ -5833,7 +5833,7 @@
           <p:cNvPr id="12" name="">
             <a:extLst xmlns:a="http://schemas.openxmlformats.org/drawingml/2006/main">
               <a:ext uri="{FF2B5EF4-FFF2-40B4-BE49-F238E27FC236}">
-                <a16:creationId xmlns:a16="http://schemas.microsoft.com/office/drawing/2014/main" id="{C912C282-C716-4F47-8015-4693CC84E099}"/>
+                <a16:creationId xmlns:a16="http://schemas.microsoft.com/office/drawing/2014/main" id="{42903167-B8E0-40B7-970C-017BD419A83B}"/>
               </a:ext>
             </a:extLst>
           </p:cNvPr>
@@ -5864,7 +5864,7 @@
           <p:cNvPr id="13" name="">
             <a:extLst xmlns:a="http://schemas.openxmlformats.org/drawingml/2006/main">
               <a:ext uri="{FF2B5EF4-FFF2-40B4-BE49-F238E27FC236}">
-                <a16:creationId xmlns:a16="http://schemas.microsoft.com/office/drawing/2014/main" id="{C4BECF4C-BC93-4039-91DC-5ED7CE15C47E}"/>
+                <a16:creationId xmlns:a16="http://schemas.microsoft.com/office/drawing/2014/main" id="{FCD0ACFB-2492-4B48-9F65-D23424A08E9C}"/>
               </a:ext>
             </a:extLst>
           </p:cNvPr>
@@ -5914,7 +5914,7 @@
           <p:cNvPr id="14" name="">
             <a:extLst xmlns:a="http://schemas.openxmlformats.org/drawingml/2006/main">
               <a:ext uri="{FF2B5EF4-FFF2-40B4-BE49-F238E27FC236}">
-                <a16:creationId xmlns:a16="http://schemas.microsoft.com/office/drawing/2014/main" id="{8799B047-A95F-42C8-95E6-288ED8AAD44C}"/>
+                <a16:creationId xmlns:a16="http://schemas.microsoft.com/office/drawing/2014/main" id="{034BDD4B-4DAB-4221-B51B-DF86308036AC}"/>
               </a:ext>
             </a:extLst>
           </p:cNvPr>
@@ -5945,7 +5945,7 @@
           <p:cNvPr id="15" name="">
             <a:extLst xmlns:a="http://schemas.openxmlformats.org/drawingml/2006/main">
               <a:ext uri="{FF2B5EF4-FFF2-40B4-BE49-F238E27FC236}">
-                <a16:creationId xmlns:a16="http://schemas.microsoft.com/office/drawing/2014/main" id="{D3E88CE8-15A0-450F-A10B-EF79BBDD24F6}"/>
+                <a16:creationId xmlns:a16="http://schemas.microsoft.com/office/drawing/2014/main" id="{7F7C695E-83A5-4CCB-BD30-F3EF93EC1536}"/>
               </a:ext>
             </a:extLst>
           </p:cNvPr>
@@ -5995,7 +5995,7 @@
           <p:cNvPr id="16" name="">
             <a:extLst xmlns:a="http://schemas.openxmlformats.org/drawingml/2006/main">
               <a:ext uri="{FF2B5EF4-FFF2-40B4-BE49-F238E27FC236}">
-                <a16:creationId xmlns:a16="http://schemas.microsoft.com/office/drawing/2014/main" id="{0AE9BA6A-5072-48B2-B4D5-B245B7CAEB72}"/>
+                <a16:creationId xmlns:a16="http://schemas.microsoft.com/office/drawing/2014/main" id="{466B4CE0-4967-4EEA-A41D-D981569D233F}"/>
               </a:ext>
             </a:extLst>
           </p:cNvPr>
@@ -6026,7 +6026,7 @@
           <p:cNvPr id="17" name="">
             <a:extLst xmlns:a="http://schemas.openxmlformats.org/drawingml/2006/main">
               <a:ext uri="{FF2B5EF4-FFF2-40B4-BE49-F238E27FC236}">
-                <a16:creationId xmlns:a16="http://schemas.microsoft.com/office/drawing/2014/main" id="{9C699ABD-416F-42DA-A8DF-09A00BC7F1F6}"/>
+                <a16:creationId xmlns:a16="http://schemas.microsoft.com/office/drawing/2014/main" id="{4741E7AF-50B5-48FA-9B73-8120643B0497}"/>
               </a:ext>
             </a:extLst>
           </p:cNvPr>
@@ -6076,7 +6076,7 @@
           <p:cNvPr id="18" name="">
             <a:extLst xmlns:a="http://schemas.openxmlformats.org/drawingml/2006/main">
               <a:ext uri="{FF2B5EF4-FFF2-40B4-BE49-F238E27FC236}">
-                <a16:creationId xmlns:a16="http://schemas.microsoft.com/office/drawing/2014/main" id="{84B7DBDB-8919-4D2E-ADC0-816B97862ADE}"/>
+                <a16:creationId xmlns:a16="http://schemas.microsoft.com/office/drawing/2014/main" id="{1D09F628-DA46-4050-B6E4-AB5F2370A093}"/>
               </a:ext>
             </a:extLst>
           </p:cNvPr>
@@ -6107,7 +6107,7 @@
           <p:cNvPr id="19" name="">
             <a:extLst xmlns:a="http://schemas.openxmlformats.org/drawingml/2006/main">
               <a:ext uri="{FF2B5EF4-FFF2-40B4-BE49-F238E27FC236}">
-                <a16:creationId xmlns:a16="http://schemas.microsoft.com/office/drawing/2014/main" id="{AFAB3AE5-D502-4EFF-BEAC-C85EE0FAEEAD}"/>
+                <a16:creationId xmlns:a16="http://schemas.microsoft.com/office/drawing/2014/main" id="{F9A96F96-CC91-47EA-AEA0-2EDEB4FCEEE7}"/>
               </a:ext>
             </a:extLst>
           </p:cNvPr>
@@ -6157,7 +6157,7 @@
           <p:cNvPr id="20" name="">
             <a:extLst xmlns:a="http://schemas.openxmlformats.org/drawingml/2006/main">
               <a:ext uri="{FF2B5EF4-FFF2-40B4-BE49-F238E27FC236}">
-                <a16:creationId xmlns:a16="http://schemas.microsoft.com/office/drawing/2014/main" id="{D4CF0B27-CD0E-435E-AB1A-E28085D44F5C}"/>
+                <a16:creationId xmlns:a16="http://schemas.microsoft.com/office/drawing/2014/main" id="{239484F8-E150-4F2B-8C9D-895CFB3D0A46}"/>
               </a:ext>
             </a:extLst>
           </p:cNvPr>
@@ -6192,7 +6192,7 @@
           <p:cNvPr id="21" name="">
             <a:extLst xmlns:a="http://schemas.openxmlformats.org/drawingml/2006/main">
               <a:ext uri="{FF2B5EF4-FFF2-40B4-BE49-F238E27FC236}">
-                <a16:creationId xmlns:a16="http://schemas.microsoft.com/office/drawing/2014/main" id="{84ECAE42-C647-48B0-B205-49F1A02AE634}"/>
+                <a16:creationId xmlns:a16="http://schemas.microsoft.com/office/drawing/2014/main" id="{630CA0BD-DC34-4136-8DDB-0C5B96BA6EBA}"/>
               </a:ext>
             </a:extLst>
           </p:cNvPr>
@@ -6225,7 +6225,7 @@
           <p:cNvPr id="22" name="">
             <a:extLst xmlns:a="http://schemas.openxmlformats.org/drawingml/2006/main">
               <a:ext uri="{FF2B5EF4-FFF2-40B4-BE49-F238E27FC236}">
-                <a16:creationId xmlns:a16="http://schemas.microsoft.com/office/drawing/2014/main" id="{E6C77E5D-4920-4CF2-B61A-A40FDEF05298}"/>
+                <a16:creationId xmlns:a16="http://schemas.microsoft.com/office/drawing/2014/main" id="{530CA235-0BDC-40D1-9634-4C92FF488987}"/>
               </a:ext>
             </a:extLst>
           </p:cNvPr>
@@ -6275,7 +6275,7 @@
           <p:cNvPr id="23" name="">
             <a:extLst xmlns:a="http://schemas.openxmlformats.org/drawingml/2006/main">
               <a:ext uri="{FF2B5EF4-FFF2-40B4-BE49-F238E27FC236}">
-                <a16:creationId xmlns:a16="http://schemas.microsoft.com/office/drawing/2014/main" id="{0B316DB2-DFFB-4CC9-866F-5D1734D88600}"/>
+                <a16:creationId xmlns:a16="http://schemas.microsoft.com/office/drawing/2014/main" id="{B28E442D-D08F-4056-AB9A-3BC7EE51E875}"/>
               </a:ext>
             </a:extLst>
           </p:cNvPr>
@@ -6313,7 +6313,7 @@
           <p:cNvPr id="24" name="">
             <a:extLst xmlns:a="http://schemas.openxmlformats.org/drawingml/2006/main">
               <a:ext uri="{FF2B5EF4-FFF2-40B4-BE49-F238E27FC236}">
-                <a16:creationId xmlns:a16="http://schemas.microsoft.com/office/drawing/2014/main" id="{D61209FF-0BFA-47FD-8F94-7F4878C43FC8}"/>
+                <a16:creationId xmlns:a16="http://schemas.microsoft.com/office/drawing/2014/main" id="{C7DE0464-D0CE-44B1-B00B-70F4BB4DEEF1}"/>
               </a:ext>
             </a:extLst>
           </p:cNvPr>
@@ -6344,7 +6344,7 @@
           <p:cNvPr id="25" name="">
             <a:extLst xmlns:a="http://schemas.openxmlformats.org/drawingml/2006/main">
               <a:ext uri="{FF2B5EF4-FFF2-40B4-BE49-F238E27FC236}">
-                <a16:creationId xmlns:a16="http://schemas.microsoft.com/office/drawing/2014/main" id="{6A51539C-D721-4D75-A881-CE119197CB44}"/>
+                <a16:creationId xmlns:a16="http://schemas.microsoft.com/office/drawing/2014/main" id="{8B31F175-5B65-4EF6-99F2-A506235AC784}"/>
               </a:ext>
             </a:extLst>
           </p:cNvPr>
@@ -6394,7 +6394,7 @@
           <p:cNvPr id="26" name="">
             <a:extLst xmlns:a="http://schemas.openxmlformats.org/drawingml/2006/main">
               <a:ext uri="{FF2B5EF4-FFF2-40B4-BE49-F238E27FC236}">
-                <a16:creationId xmlns:a16="http://schemas.microsoft.com/office/drawing/2014/main" id="{2CDC20C7-677C-4939-8EBC-C5A0F810578F}"/>
+                <a16:creationId xmlns:a16="http://schemas.microsoft.com/office/drawing/2014/main" id="{17D40928-D462-4635-A93A-376878DBB8BD}"/>
               </a:ext>
             </a:extLst>
           </p:cNvPr>
@@ -6425,7 +6425,7 @@
           <p:cNvPr id="27" name="">
             <a:extLst xmlns:a="http://schemas.openxmlformats.org/drawingml/2006/main">
               <a:ext uri="{FF2B5EF4-FFF2-40B4-BE49-F238E27FC236}">
-                <a16:creationId xmlns:a16="http://schemas.microsoft.com/office/drawing/2014/main" id="{7C7ABCD7-9BD1-4CB8-902D-3F6DBF932373}"/>
+                <a16:creationId xmlns:a16="http://schemas.microsoft.com/office/drawing/2014/main" id="{D7AEFB5E-3B7A-4BBD-8175-7FD01A3ED915}"/>
               </a:ext>
             </a:extLst>
           </p:cNvPr>
@@ -6475,7 +6475,7 @@
           <p:cNvPr id="28" name="">
             <a:extLst xmlns:a="http://schemas.openxmlformats.org/drawingml/2006/main">
               <a:ext uri="{FF2B5EF4-FFF2-40B4-BE49-F238E27FC236}">
-                <a16:creationId xmlns:a16="http://schemas.microsoft.com/office/drawing/2014/main" id="{3B8106C4-F9BC-43BF-9EFD-26B380AED62F}"/>
+                <a16:creationId xmlns:a16="http://schemas.microsoft.com/office/drawing/2014/main" id="{74B1920A-3471-452A-85E2-D6442609536D}"/>
               </a:ext>
             </a:extLst>
           </p:cNvPr>
@@ -6506,7 +6506,7 @@
           <p:cNvPr id="29" name="">
             <a:extLst xmlns:a="http://schemas.openxmlformats.org/drawingml/2006/main">
               <a:ext uri="{FF2B5EF4-FFF2-40B4-BE49-F238E27FC236}">
-                <a16:creationId xmlns:a16="http://schemas.microsoft.com/office/drawing/2014/main" id="{C3925B03-690E-4698-934E-2ED4BE494930}"/>
+                <a16:creationId xmlns:a16="http://schemas.microsoft.com/office/drawing/2014/main" id="{56886E2D-E215-4622-B486-92CE84BD1906}"/>
               </a:ext>
             </a:extLst>
           </p:cNvPr>
@@ -6556,7 +6556,7 @@
           <p:cNvPr id="30" name="">
             <a:extLst xmlns:a="http://schemas.openxmlformats.org/drawingml/2006/main">
               <a:ext uri="{FF2B5EF4-FFF2-40B4-BE49-F238E27FC236}">
-                <a16:creationId xmlns:a16="http://schemas.microsoft.com/office/drawing/2014/main" id="{41B436F5-C622-4C9C-925E-BCE263E3D7B4}"/>
+                <a16:creationId xmlns:a16="http://schemas.microsoft.com/office/drawing/2014/main" id="{420B7529-B4D0-4CCD-863B-7581DF2CF3CE}"/>
               </a:ext>
             </a:extLst>
           </p:cNvPr>
@@ -6587,7 +6587,7 @@
           <p:cNvPr id="31" name="">
             <a:extLst xmlns:a="http://schemas.openxmlformats.org/drawingml/2006/main">
               <a:ext uri="{FF2B5EF4-FFF2-40B4-BE49-F238E27FC236}">
-                <a16:creationId xmlns:a16="http://schemas.microsoft.com/office/drawing/2014/main" id="{62BEAC60-83D3-4777-8AD1-FE0F50093DA0}"/>
+                <a16:creationId xmlns:a16="http://schemas.microsoft.com/office/drawing/2014/main" id="{96AD7582-D9BA-49BC-B8C2-1D18F2C78374}"/>
               </a:ext>
             </a:extLst>
           </p:cNvPr>
@@ -6635,7 +6635,7 @@
     </p:spTree>
     <p:extLst>
       <p:ext uri="{BB962C8B-B14F-4D97-AF65-F5344CB8AC3E}">
-        <p14:creationId xmlns:p14="http://schemas.microsoft.com/office/powerpoint/2010/main" val="428488597"/>
+        <p14:creationId xmlns:p14="http://schemas.microsoft.com/office/powerpoint/2010/main" val="858552774"/>
       </p:ext>
     </p:extLst>
   </p:cSld>
@@ -6666,7 +6666,7 @@
           <p:cNvPr id="1" name="">
             <a:extLst xmlns:a="http://schemas.openxmlformats.org/drawingml/2006/main">
               <a:ext uri="{FF2B5EF4-FFF2-40B4-BE49-F238E27FC236}">
-                <a16:creationId xmlns:a16="http://schemas.microsoft.com/office/drawing/2014/main" id="{DDA428A8-C101-4A12-A8AC-D6A04179F46F}"/>
+                <a16:creationId xmlns:a16="http://schemas.microsoft.com/office/drawing/2014/main" id="{BB039AEE-9299-40FD-8F0A-F9D5E5F47E85}"/>
               </a:ext>
             </a:extLst>
           </p:cNvPr>
@@ -6720,7 +6720,7 @@
           <p:cNvPr id="2" name="">
             <a:extLst xmlns:a="http://schemas.openxmlformats.org/drawingml/2006/main">
               <a:ext uri="{FF2B5EF4-FFF2-40B4-BE49-F238E27FC236}">
-                <a16:creationId xmlns:a16="http://schemas.microsoft.com/office/drawing/2014/main" id="{9815A021-22D8-4C94-BA14-394317DE51A2}"/>
+                <a16:creationId xmlns:a16="http://schemas.microsoft.com/office/drawing/2014/main" id="{09FBA477-601D-4404-8403-ED2C8011D632}"/>
               </a:ext>
             </a:extLst>
           </p:cNvPr>
@@ -6751,7 +6751,7 @@
           <p:cNvPr id="3" name="">
             <a:extLst xmlns:a="http://schemas.openxmlformats.org/drawingml/2006/main">
               <a:ext uri="{FF2B5EF4-FFF2-40B4-BE49-F238E27FC236}">
-                <a16:creationId xmlns:a16="http://schemas.microsoft.com/office/drawing/2014/main" id="{AE88BB81-71C8-4C3F-A005-F7484EA2BD48}"/>
+                <a16:creationId xmlns:a16="http://schemas.microsoft.com/office/drawing/2014/main" id="{76AD89C0-EB5B-401A-B679-5BBB383E73E8}"/>
               </a:ext>
             </a:extLst>
           </p:cNvPr>
@@ -6801,7 +6801,7 @@
           <p:cNvPr id="4" name="">
             <a:extLst xmlns:a="http://schemas.openxmlformats.org/drawingml/2006/main">
               <a:ext uri="{FF2B5EF4-FFF2-40B4-BE49-F238E27FC236}">
-                <a16:creationId xmlns:a16="http://schemas.microsoft.com/office/drawing/2014/main" id="{F48CA37B-F98D-4825-B292-DEEFFDE5F63A}"/>
+                <a16:creationId xmlns:a16="http://schemas.microsoft.com/office/drawing/2014/main" id="{F98DC767-1EAB-4D79-867C-277C42E9FBD4}"/>
               </a:ext>
             </a:extLst>
           </p:cNvPr>
@@ -6851,7 +6851,7 @@
           <p:cNvPr id="5" name="">
             <a:extLst xmlns:a="http://schemas.openxmlformats.org/drawingml/2006/main">
               <a:ext uri="{FF2B5EF4-FFF2-40B4-BE49-F238E27FC236}">
-                <a16:creationId xmlns:a16="http://schemas.microsoft.com/office/drawing/2014/main" id="{7692B573-E986-4225-9BA6-EFB82CA40B7E}"/>
+                <a16:creationId xmlns:a16="http://schemas.microsoft.com/office/drawing/2014/main" id="{BE0B009E-4130-4B84-9BDA-106E08D84406}"/>
               </a:ext>
             </a:extLst>
           </p:cNvPr>
@@ -6901,7 +6901,7 @@
           <p:cNvPr id="6" name="">
             <a:extLst xmlns:a="http://schemas.openxmlformats.org/drawingml/2006/main">
               <a:ext uri="{FF2B5EF4-FFF2-40B4-BE49-F238E27FC236}">
-                <a16:creationId xmlns:a16="http://schemas.microsoft.com/office/drawing/2014/main" id="{835D9340-9750-4F61-8620-55854D2A39FF}"/>
+                <a16:creationId xmlns:a16="http://schemas.microsoft.com/office/drawing/2014/main" id="{EC896242-3F2B-4468-8798-5BE491496722}"/>
               </a:ext>
             </a:extLst>
           </p:cNvPr>
@@ -6936,7 +6936,7 @@
           <p:cNvPr id="7" name="">
             <a:extLst xmlns:a="http://schemas.openxmlformats.org/drawingml/2006/main">
               <a:ext uri="{FF2B5EF4-FFF2-40B4-BE49-F238E27FC236}">
-                <a16:creationId xmlns:a16="http://schemas.microsoft.com/office/drawing/2014/main" id="{80B6EEC8-2C57-4EDB-9394-E4E865399101}"/>
+                <a16:creationId xmlns:a16="http://schemas.microsoft.com/office/drawing/2014/main" id="{1118368A-A478-483D-A8C7-7B68BC2618AC}"/>
               </a:ext>
             </a:extLst>
           </p:cNvPr>
@@ -6986,7 +6986,7 @@
           <p:cNvPr id="8" name="">
             <a:extLst xmlns:a="http://schemas.openxmlformats.org/drawingml/2006/main">
               <a:ext uri="{FF2B5EF4-FFF2-40B4-BE49-F238E27FC236}">
-                <a16:creationId xmlns:a16="http://schemas.microsoft.com/office/drawing/2014/main" id="{F20A5EE6-3F8E-4C27-970D-EF127A6D6089}"/>
+                <a16:creationId xmlns:a16="http://schemas.microsoft.com/office/drawing/2014/main" id="{BC315BF7-8EC2-4E8D-AE5C-AF1513445190}"/>
               </a:ext>
             </a:extLst>
           </p:cNvPr>
@@ -7036,7 +7036,7 @@
           <p:cNvPr id="9" name="">
             <a:extLst xmlns:a="http://schemas.openxmlformats.org/drawingml/2006/main">
               <a:ext uri="{FF2B5EF4-FFF2-40B4-BE49-F238E27FC236}">
-                <a16:creationId xmlns:a16="http://schemas.microsoft.com/office/drawing/2014/main" id="{F443166D-65F0-445E-83F8-CA952CA38AB3}"/>
+                <a16:creationId xmlns:a16="http://schemas.microsoft.com/office/drawing/2014/main" id="{1D15F8F4-07E3-4DE4-B1FC-C3D04C730EEC}"/>
               </a:ext>
             </a:extLst>
           </p:cNvPr>
@@ -7071,7 +7071,7 @@
           <p:cNvPr id="10" name="">
             <a:extLst xmlns:a="http://schemas.openxmlformats.org/drawingml/2006/main">
               <a:ext uri="{FF2B5EF4-FFF2-40B4-BE49-F238E27FC236}">
-                <a16:creationId xmlns:a16="http://schemas.microsoft.com/office/drawing/2014/main" id="{8260389F-7F6E-4237-B355-67BAB8825A5D}"/>
+                <a16:creationId xmlns:a16="http://schemas.microsoft.com/office/drawing/2014/main" id="{0B7ADA4C-7C71-4479-A2F5-B3EF14398A12}"/>
               </a:ext>
             </a:extLst>
           </p:cNvPr>
@@ -7121,7 +7121,7 @@
           <p:cNvPr id="11" name="">
             <a:extLst xmlns:a="http://schemas.openxmlformats.org/drawingml/2006/main">
               <a:ext uri="{FF2B5EF4-FFF2-40B4-BE49-F238E27FC236}">
-                <a16:creationId xmlns:a16="http://schemas.microsoft.com/office/drawing/2014/main" id="{07D6B300-CBAE-4BE0-9DDD-CE6D23CB456E}"/>
+                <a16:creationId xmlns:a16="http://schemas.microsoft.com/office/drawing/2014/main" id="{CEA8E91C-01BA-4C49-BA3D-8F302D9A8749}"/>
               </a:ext>
             </a:extLst>
           </p:cNvPr>
@@ -7171,7 +7171,7 @@
           <p:cNvPr id="12" name="">
             <a:extLst xmlns:a="http://schemas.openxmlformats.org/drawingml/2006/main">
               <a:ext uri="{FF2B5EF4-FFF2-40B4-BE49-F238E27FC236}">
-                <a16:creationId xmlns:a16="http://schemas.microsoft.com/office/drawing/2014/main" id="{FA5A7641-92A4-43C7-A74E-2C9CF21549BA}"/>
+                <a16:creationId xmlns:a16="http://schemas.microsoft.com/office/drawing/2014/main" id="{EA89AA52-A143-4D5A-97C2-34EC24426F42}"/>
               </a:ext>
             </a:extLst>
           </p:cNvPr>
@@ -7206,7 +7206,7 @@
           <p:cNvPr id="13" name="">
             <a:extLst xmlns:a="http://schemas.openxmlformats.org/drawingml/2006/main">
               <a:ext uri="{FF2B5EF4-FFF2-40B4-BE49-F238E27FC236}">
-                <a16:creationId xmlns:a16="http://schemas.microsoft.com/office/drawing/2014/main" id="{5B12B935-91CF-45C4-B532-B554DA1D0D4F}"/>
+                <a16:creationId xmlns:a16="http://schemas.microsoft.com/office/drawing/2014/main" id="{638B48A3-8180-4078-BC68-F697CF7217D2}"/>
               </a:ext>
             </a:extLst>
           </p:cNvPr>
@@ -7256,7 +7256,7 @@
           <p:cNvPr id="14" name="">
             <a:extLst xmlns:a="http://schemas.openxmlformats.org/drawingml/2006/main">
               <a:ext uri="{FF2B5EF4-FFF2-40B4-BE49-F238E27FC236}">
-                <a16:creationId xmlns:a16="http://schemas.microsoft.com/office/drawing/2014/main" id="{9226D32E-59DE-4E61-926E-8D0E99522736}"/>
+                <a16:creationId xmlns:a16="http://schemas.microsoft.com/office/drawing/2014/main" id="{4B345026-6146-4167-85E2-EA5E0C8D0537}"/>
               </a:ext>
             </a:extLst>
           </p:cNvPr>
@@ -7306,7 +7306,7 @@
           <p:cNvPr id="15" name="">
             <a:extLst xmlns:a="http://schemas.openxmlformats.org/drawingml/2006/main">
               <a:ext uri="{FF2B5EF4-FFF2-40B4-BE49-F238E27FC236}">
-                <a16:creationId xmlns:a16="http://schemas.microsoft.com/office/drawing/2014/main" id="{4ABDD83A-0836-4833-B744-D22B90068C99}"/>
+                <a16:creationId xmlns:a16="http://schemas.microsoft.com/office/drawing/2014/main" id="{3881F571-A0E7-4BCA-A1A3-E65EB823ECE9}"/>
               </a:ext>
             </a:extLst>
           </p:cNvPr>
@@ -7341,7 +7341,7 @@
           <p:cNvPr id="16" name="">
             <a:extLst xmlns:a="http://schemas.openxmlformats.org/drawingml/2006/main">
               <a:ext uri="{FF2B5EF4-FFF2-40B4-BE49-F238E27FC236}">
-                <a16:creationId xmlns:a16="http://schemas.microsoft.com/office/drawing/2014/main" id="{A4F55C86-9E51-4DE2-8C87-EB5CADCE6866}"/>
+                <a16:creationId xmlns:a16="http://schemas.microsoft.com/office/drawing/2014/main" id="{B7F35536-0742-4093-B029-982517AAC3C7}"/>
               </a:ext>
             </a:extLst>
           </p:cNvPr>
@@ -7391,7 +7391,7 @@
           <p:cNvPr id="17" name="">
             <a:extLst xmlns:a="http://schemas.openxmlformats.org/drawingml/2006/main">
               <a:ext uri="{FF2B5EF4-FFF2-40B4-BE49-F238E27FC236}">
-                <a16:creationId xmlns:a16="http://schemas.microsoft.com/office/drawing/2014/main" id="{078365FD-B187-4632-921B-6F62D3D236E8}"/>
+                <a16:creationId xmlns:a16="http://schemas.microsoft.com/office/drawing/2014/main" id="{1BDFFCA5-252D-402F-A030-3520846975C6}"/>
               </a:ext>
             </a:extLst>
           </p:cNvPr>
@@ -7441,7 +7441,7 @@
           <p:cNvPr id="18" name="">
             <a:extLst xmlns:a="http://schemas.openxmlformats.org/drawingml/2006/main">
               <a:ext uri="{FF2B5EF4-FFF2-40B4-BE49-F238E27FC236}">
-                <a16:creationId xmlns:a16="http://schemas.microsoft.com/office/drawing/2014/main" id="{2C28610D-91C2-440E-B6D1-6CA61BC9CBDC}"/>
+                <a16:creationId xmlns:a16="http://schemas.microsoft.com/office/drawing/2014/main" id="{A34DC639-D8AC-4844-9199-FC23D4CF4354}"/>
               </a:ext>
             </a:extLst>
           </p:cNvPr>
@@ -7476,7 +7476,7 @@
           <p:cNvPr id="19" name="">
             <a:extLst xmlns:a="http://schemas.openxmlformats.org/drawingml/2006/main">
               <a:ext uri="{FF2B5EF4-FFF2-40B4-BE49-F238E27FC236}">
-                <a16:creationId xmlns:a16="http://schemas.microsoft.com/office/drawing/2014/main" id="{EA89494E-AE11-49FB-BD17-88EF719D0949}"/>
+                <a16:creationId xmlns:a16="http://schemas.microsoft.com/office/drawing/2014/main" id="{A260D921-28D8-45E2-980C-013D4039C952}"/>
               </a:ext>
             </a:extLst>
           </p:cNvPr>
@@ -7509,7 +7509,7 @@
           <p:cNvPr id="20" name="">
             <a:extLst xmlns:a="http://schemas.openxmlformats.org/drawingml/2006/main">
               <a:ext uri="{FF2B5EF4-FFF2-40B4-BE49-F238E27FC236}">
-                <a16:creationId xmlns:a16="http://schemas.microsoft.com/office/drawing/2014/main" id="{EB3E72B2-F55F-4CC6-9ED7-0897400173DC}"/>
+                <a16:creationId xmlns:a16="http://schemas.microsoft.com/office/drawing/2014/main" id="{FBD25248-23DA-4855-ADC4-847CD14013D9}"/>
               </a:ext>
             </a:extLst>
           </p:cNvPr>
@@ -7559,7 +7559,7 @@
           <p:cNvPr id="21" name="">
             <a:extLst xmlns:a="http://schemas.openxmlformats.org/drawingml/2006/main">
               <a:ext uri="{FF2B5EF4-FFF2-40B4-BE49-F238E27FC236}">
-                <a16:creationId xmlns:a16="http://schemas.microsoft.com/office/drawing/2014/main" id="{71DD4D22-46B9-4013-9301-00AE6354054E}"/>
+                <a16:creationId xmlns:a16="http://schemas.microsoft.com/office/drawing/2014/main" id="{9A279149-6001-41FF-8690-1844ACDD37E4}"/>
               </a:ext>
             </a:extLst>
           </p:cNvPr>
@@ -7607,7 +7607,7 @@
     </p:spTree>
     <p:extLst>
       <p:ext uri="{BB962C8B-B14F-4D97-AF65-F5344CB8AC3E}">
-        <p14:creationId xmlns:p14="http://schemas.microsoft.com/office/powerpoint/2010/main" val="1976404399"/>
+        <p14:creationId xmlns:p14="http://schemas.microsoft.com/office/powerpoint/2010/main" val="2021795542"/>
       </p:ext>
     </p:extLst>
   </p:cSld>
@@ -7638,7 +7638,7 @@
           <p:cNvPr id="1" name="">
             <a:extLst xmlns:a="http://schemas.openxmlformats.org/drawingml/2006/main">
               <a:ext uri="{FF2B5EF4-FFF2-40B4-BE49-F238E27FC236}">
-                <a16:creationId xmlns:a16="http://schemas.microsoft.com/office/drawing/2014/main" id="{69CCCD38-D36B-431B-9AA1-D1908F6F9B42}"/>
+                <a16:creationId xmlns:a16="http://schemas.microsoft.com/office/drawing/2014/main" id="{0EEB62CE-7512-450A-986C-E0F7776B038A}"/>
               </a:ext>
             </a:extLst>
           </p:cNvPr>
@@ -7692,7 +7692,7 @@
           <p:cNvPr id="2" name="">
             <a:extLst xmlns:a="http://schemas.openxmlformats.org/drawingml/2006/main">
               <a:ext uri="{FF2B5EF4-FFF2-40B4-BE49-F238E27FC236}">
-                <a16:creationId xmlns:a16="http://schemas.microsoft.com/office/drawing/2014/main" id="{4C207C0C-266B-4845-8618-A3297FE18D17}"/>
+                <a16:creationId xmlns:a16="http://schemas.microsoft.com/office/drawing/2014/main" id="{F3799D0C-E9E2-4309-812A-1A530537FB33}"/>
               </a:ext>
             </a:extLst>
           </p:cNvPr>
@@ -7723,7 +7723,7 @@
           <p:cNvPr id="3" name="">
             <a:extLst xmlns:a="http://schemas.openxmlformats.org/drawingml/2006/main">
               <a:ext uri="{FF2B5EF4-FFF2-40B4-BE49-F238E27FC236}">
-                <a16:creationId xmlns:a16="http://schemas.microsoft.com/office/drawing/2014/main" id="{765F3A67-A4E6-4B00-8873-89BFA549171C}"/>
+                <a16:creationId xmlns:a16="http://schemas.microsoft.com/office/drawing/2014/main" id="{8244F8C4-92BD-4F61-8FC2-29887650F90D}"/>
               </a:ext>
             </a:extLst>
           </p:cNvPr>
@@ -7773,7 +7773,7 @@
           <p:cNvPr id="4" name="">
             <a:extLst xmlns:a="http://schemas.openxmlformats.org/drawingml/2006/main">
               <a:ext uri="{FF2B5EF4-FFF2-40B4-BE49-F238E27FC236}">
-                <a16:creationId xmlns:a16="http://schemas.microsoft.com/office/drawing/2014/main" id="{46D2C347-0AA7-43FF-B8B2-4A47BB92F08B}"/>
+                <a16:creationId xmlns:a16="http://schemas.microsoft.com/office/drawing/2014/main" id="{A4EA5BA5-F057-46DB-A712-07A8151756A6}"/>
               </a:ext>
             </a:extLst>
           </p:cNvPr>
@@ -7823,7 +7823,7 @@
           <p:cNvPr id="5" name="">
             <a:extLst xmlns:a="http://schemas.openxmlformats.org/drawingml/2006/main">
               <a:ext uri="{FF2B5EF4-FFF2-40B4-BE49-F238E27FC236}">
-                <a16:creationId xmlns:a16="http://schemas.microsoft.com/office/drawing/2014/main" id="{8356C289-763D-43B4-813D-DF8047B50931}"/>
+                <a16:creationId xmlns:a16="http://schemas.microsoft.com/office/drawing/2014/main" id="{304B804C-8556-41A9-AE5D-9771DB010BF8}"/>
               </a:ext>
             </a:extLst>
           </p:cNvPr>
@@ -7873,7 +7873,7 @@
           <p:cNvPr id="6" name="">
             <a:extLst xmlns:a="http://schemas.openxmlformats.org/drawingml/2006/main">
               <a:ext uri="{FF2B5EF4-FFF2-40B4-BE49-F238E27FC236}">
-                <a16:creationId xmlns:a16="http://schemas.microsoft.com/office/drawing/2014/main" id="{5D940146-8C07-4721-A862-420CC3ECF05E}"/>
+                <a16:creationId xmlns:a16="http://schemas.microsoft.com/office/drawing/2014/main" id="{B978C44C-3DEE-4237-895C-E1DC0CEE3699}"/>
               </a:ext>
             </a:extLst>
           </p:cNvPr>
@@ -7908,7 +7908,7 @@
           <p:cNvPr id="7" name="">
             <a:extLst xmlns:a="http://schemas.openxmlformats.org/drawingml/2006/main">
               <a:ext uri="{FF2B5EF4-FFF2-40B4-BE49-F238E27FC236}">
-                <a16:creationId xmlns:a16="http://schemas.microsoft.com/office/drawing/2014/main" id="{C3157C3C-51A8-4104-B27F-039E5E5B2296}"/>
+                <a16:creationId xmlns:a16="http://schemas.microsoft.com/office/drawing/2014/main" id="{D02CB829-DA21-40ED-976A-EB5045915E65}"/>
               </a:ext>
             </a:extLst>
           </p:cNvPr>
@@ -7941,7 +7941,7 @@
           <p:cNvPr id="8" name="">
             <a:extLst xmlns:a="http://schemas.openxmlformats.org/drawingml/2006/main">
               <a:ext uri="{FF2B5EF4-FFF2-40B4-BE49-F238E27FC236}">
-                <a16:creationId xmlns:a16="http://schemas.microsoft.com/office/drawing/2014/main" id="{B66801DD-9FA8-43A9-BB73-C42B0E69ABE9}"/>
+                <a16:creationId xmlns:a16="http://schemas.microsoft.com/office/drawing/2014/main" id="{D691F12B-2CB9-4C45-AB10-3B6BE0F17852}"/>
               </a:ext>
             </a:extLst>
           </p:cNvPr>
@@ -7991,7 +7991,7 @@
           <p:cNvPr id="9" name="">
             <a:extLst xmlns:a="http://schemas.openxmlformats.org/drawingml/2006/main">
               <a:ext uri="{FF2B5EF4-FFF2-40B4-BE49-F238E27FC236}">
-                <a16:creationId xmlns:a16="http://schemas.microsoft.com/office/drawing/2014/main" id="{A257780A-89AC-4E9A-B67C-3B17A5845F96}"/>
+                <a16:creationId xmlns:a16="http://schemas.microsoft.com/office/drawing/2014/main" id="{37E62DE3-7542-4DD2-8AD9-C0A7795AD541}"/>
               </a:ext>
             </a:extLst>
           </p:cNvPr>
@@ -8029,7 +8029,7 @@
           <p:cNvPr id="10" name="">
             <a:extLst xmlns:a="http://schemas.openxmlformats.org/drawingml/2006/main">
               <a:ext uri="{FF2B5EF4-FFF2-40B4-BE49-F238E27FC236}">
-                <a16:creationId xmlns:a16="http://schemas.microsoft.com/office/drawing/2014/main" id="{39AF8F4D-D222-4CB9-BF01-5548838ABF62}"/>
+                <a16:creationId xmlns:a16="http://schemas.microsoft.com/office/drawing/2014/main" id="{8586DA9D-F7CB-4EA4-A73F-7B0B87012E86}"/>
               </a:ext>
             </a:extLst>
           </p:cNvPr>
@@ -8060,7 +8060,7 @@
           <p:cNvPr id="11" name="">
             <a:extLst xmlns:a="http://schemas.openxmlformats.org/drawingml/2006/main">
               <a:ext uri="{FF2B5EF4-FFF2-40B4-BE49-F238E27FC236}">
-                <a16:creationId xmlns:a16="http://schemas.microsoft.com/office/drawing/2014/main" id="{81AF0626-E556-4780-A757-F467218EC73D}"/>
+                <a16:creationId xmlns:a16="http://schemas.microsoft.com/office/drawing/2014/main" id="{B59E99DE-4128-49B9-A605-B60DFE3129ED}"/>
               </a:ext>
             </a:extLst>
           </p:cNvPr>
@@ -8110,7 +8110,7 @@
           <p:cNvPr id="12" name="">
             <a:extLst xmlns:a="http://schemas.openxmlformats.org/drawingml/2006/main">
               <a:ext uri="{FF2B5EF4-FFF2-40B4-BE49-F238E27FC236}">
-                <a16:creationId xmlns:a16="http://schemas.microsoft.com/office/drawing/2014/main" id="{A4C65915-DC7B-4838-B85E-7D43209C80B5}"/>
+                <a16:creationId xmlns:a16="http://schemas.microsoft.com/office/drawing/2014/main" id="{7E679491-595C-4165-9FF1-BC2B2451F1C5}"/>
               </a:ext>
             </a:extLst>
           </p:cNvPr>
@@ -8141,7 +8141,7 @@
           <p:cNvPr id="13" name="">
             <a:extLst xmlns:a="http://schemas.openxmlformats.org/drawingml/2006/main">
               <a:ext uri="{FF2B5EF4-FFF2-40B4-BE49-F238E27FC236}">
-                <a16:creationId xmlns:a16="http://schemas.microsoft.com/office/drawing/2014/main" id="{22A4426F-FF24-44ED-9396-BCE8A7399706}"/>
+                <a16:creationId xmlns:a16="http://schemas.microsoft.com/office/drawing/2014/main" id="{F97C1B52-3734-4040-B4CD-B7F3989E6619}"/>
               </a:ext>
             </a:extLst>
           </p:cNvPr>
@@ -8191,7 +8191,7 @@
           <p:cNvPr id="14" name="">
             <a:extLst xmlns:a="http://schemas.openxmlformats.org/drawingml/2006/main">
               <a:ext uri="{FF2B5EF4-FFF2-40B4-BE49-F238E27FC236}">
-                <a16:creationId xmlns:a16="http://schemas.microsoft.com/office/drawing/2014/main" id="{942C9842-32A5-4F10-855E-A9B260E22593}"/>
+                <a16:creationId xmlns:a16="http://schemas.microsoft.com/office/drawing/2014/main" id="{6B523FB1-BF07-4E92-9D01-8704AB8BC458}"/>
               </a:ext>
             </a:extLst>
           </p:cNvPr>
@@ -8222,7 +8222,7 @@
           <p:cNvPr id="15" name="">
             <a:extLst xmlns:a="http://schemas.openxmlformats.org/drawingml/2006/main">
               <a:ext uri="{FF2B5EF4-FFF2-40B4-BE49-F238E27FC236}">
-                <a16:creationId xmlns:a16="http://schemas.microsoft.com/office/drawing/2014/main" id="{4FB2F706-E4E8-4E1E-8619-1BDCDE22533E}"/>
+                <a16:creationId xmlns:a16="http://schemas.microsoft.com/office/drawing/2014/main" id="{429D3819-6CA1-4D72-840B-809D091B5D6D}"/>
               </a:ext>
             </a:extLst>
           </p:cNvPr>
@@ -8272,7 +8272,7 @@
           <p:cNvPr id="16" name="">
             <a:extLst xmlns:a="http://schemas.openxmlformats.org/drawingml/2006/main">
               <a:ext uri="{FF2B5EF4-FFF2-40B4-BE49-F238E27FC236}">
-                <a16:creationId xmlns:a16="http://schemas.microsoft.com/office/drawing/2014/main" id="{DE24C281-7145-4522-BFC7-C0FAD053D952}"/>
+                <a16:creationId xmlns:a16="http://schemas.microsoft.com/office/drawing/2014/main" id="{63A3A829-FFB2-4898-A04A-36A23F2D063B}"/>
               </a:ext>
             </a:extLst>
           </p:cNvPr>
@@ -8303,7 +8303,7 @@
           <p:cNvPr id="17" name="">
             <a:extLst xmlns:a="http://schemas.openxmlformats.org/drawingml/2006/main">
               <a:ext uri="{FF2B5EF4-FFF2-40B4-BE49-F238E27FC236}">
-                <a16:creationId xmlns:a16="http://schemas.microsoft.com/office/drawing/2014/main" id="{2B740863-30A9-492A-9842-DD60FAE3F63D}"/>
+                <a16:creationId xmlns:a16="http://schemas.microsoft.com/office/drawing/2014/main" id="{CB0A32A4-BCD4-4188-9706-BAB2D858B8AC}"/>
               </a:ext>
             </a:extLst>
           </p:cNvPr>
@@ -8353,7 +8353,7 @@
           <p:cNvPr id="18" name="">
             <a:extLst xmlns:a="http://schemas.openxmlformats.org/drawingml/2006/main">
               <a:ext uri="{FF2B5EF4-FFF2-40B4-BE49-F238E27FC236}">
-                <a16:creationId xmlns:a16="http://schemas.microsoft.com/office/drawing/2014/main" id="{C4C694CE-22F0-407C-86EC-C435C50A1E41}"/>
+                <a16:creationId xmlns:a16="http://schemas.microsoft.com/office/drawing/2014/main" id="{12386955-0BAC-4D1E-9E62-3DC7FAF32CDC}"/>
               </a:ext>
             </a:extLst>
           </p:cNvPr>
@@ -8384,7 +8384,7 @@
           <p:cNvPr id="19" name="">
             <a:extLst xmlns:a="http://schemas.openxmlformats.org/drawingml/2006/main">
               <a:ext uri="{FF2B5EF4-FFF2-40B4-BE49-F238E27FC236}">
-                <a16:creationId xmlns:a16="http://schemas.microsoft.com/office/drawing/2014/main" id="{710A3C83-39C1-433C-ABF6-20FEB2750546}"/>
+                <a16:creationId xmlns:a16="http://schemas.microsoft.com/office/drawing/2014/main" id="{10280F83-CD99-4056-86FE-A45A14B5187D}"/>
               </a:ext>
             </a:extLst>
           </p:cNvPr>
@@ -8434,7 +8434,7 @@
           <p:cNvPr id="20" name="">
             <a:extLst xmlns:a="http://schemas.openxmlformats.org/drawingml/2006/main">
               <a:ext uri="{FF2B5EF4-FFF2-40B4-BE49-F238E27FC236}">
-                <a16:creationId xmlns:a16="http://schemas.microsoft.com/office/drawing/2014/main" id="{6417E5CB-61E5-4998-8D69-816D3A9BD15F}"/>
+                <a16:creationId xmlns:a16="http://schemas.microsoft.com/office/drawing/2014/main" id="{8E8B42FA-8C38-45FB-B60E-B659D243A1D3}"/>
               </a:ext>
             </a:extLst>
           </p:cNvPr>
@@ -8465,7 +8465,7 @@
           <p:cNvPr id="21" name="">
             <a:extLst xmlns:a="http://schemas.openxmlformats.org/drawingml/2006/main">
               <a:ext uri="{FF2B5EF4-FFF2-40B4-BE49-F238E27FC236}">
-                <a16:creationId xmlns:a16="http://schemas.microsoft.com/office/drawing/2014/main" id="{F8D3A0C5-54F7-4E02-B736-FF991C9F7CB6}"/>
+                <a16:creationId xmlns:a16="http://schemas.microsoft.com/office/drawing/2014/main" id="{1F89C37E-84E5-48FB-AA15-14BF30B181E9}"/>
               </a:ext>
             </a:extLst>
           </p:cNvPr>
@@ -8513,7 +8513,7 @@
     </p:spTree>
     <p:extLst>
       <p:ext uri="{BB962C8B-B14F-4D97-AF65-F5344CB8AC3E}">
-        <p14:creationId xmlns:p14="http://schemas.microsoft.com/office/powerpoint/2010/main" val="904498610"/>
+        <p14:creationId xmlns:p14="http://schemas.microsoft.com/office/powerpoint/2010/main" val="499991980"/>
       </p:ext>
     </p:extLst>
   </p:cSld>
@@ -8544,7 +8544,7 @@
           <p:cNvPr id="1" name="">
             <a:extLst xmlns:a="http://schemas.openxmlformats.org/drawingml/2006/main">
               <a:ext uri="{FF2B5EF4-FFF2-40B4-BE49-F238E27FC236}">
-                <a16:creationId xmlns:a16="http://schemas.microsoft.com/office/drawing/2014/main" id="{82D0B2CE-777F-40FF-91DA-17E4B53AEEA5}"/>
+                <a16:creationId xmlns:a16="http://schemas.microsoft.com/office/drawing/2014/main" id="{4E8D0D3B-CC95-4296-B69F-B7EAC421C5C9}"/>
               </a:ext>
             </a:extLst>
           </p:cNvPr>
@@ -8598,7 +8598,7 @@
           <p:cNvPr id="2" name="">
             <a:extLst xmlns:a="http://schemas.openxmlformats.org/drawingml/2006/main">
               <a:ext uri="{FF2B5EF4-FFF2-40B4-BE49-F238E27FC236}">
-                <a16:creationId xmlns:a16="http://schemas.microsoft.com/office/drawing/2014/main" id="{808CD342-E05E-4F34-94BA-8539C8026B7C}"/>
+                <a16:creationId xmlns:a16="http://schemas.microsoft.com/office/drawing/2014/main" id="{462DB14A-13C9-4461-B18F-9DD70424E336}"/>
               </a:ext>
             </a:extLst>
           </p:cNvPr>
@@ -8629,7 +8629,7 @@
           <p:cNvPr id="3" name="">
             <a:extLst xmlns:a="http://schemas.openxmlformats.org/drawingml/2006/main">
               <a:ext uri="{FF2B5EF4-FFF2-40B4-BE49-F238E27FC236}">
-                <a16:creationId xmlns:a16="http://schemas.microsoft.com/office/drawing/2014/main" id="{24D8B46E-822F-4DFF-907C-EC3921CD1181}"/>
+                <a16:creationId xmlns:a16="http://schemas.microsoft.com/office/drawing/2014/main" id="{4BD5E752-9D74-40AB-AAC7-D08D09D1F4D5}"/>
               </a:ext>
             </a:extLst>
           </p:cNvPr>
@@ -8679,7 +8679,7 @@
           <p:cNvPr id="4" name="">
             <a:extLst xmlns:a="http://schemas.openxmlformats.org/drawingml/2006/main">
               <a:ext uri="{FF2B5EF4-FFF2-40B4-BE49-F238E27FC236}">
-                <a16:creationId xmlns:a16="http://schemas.microsoft.com/office/drawing/2014/main" id="{7A791577-A885-4498-810F-CA4402A85287}"/>
+                <a16:creationId xmlns:a16="http://schemas.microsoft.com/office/drawing/2014/main" id="{654F1679-EA27-4EC7-AD13-A12DBCB123F5}"/>
               </a:ext>
             </a:extLst>
           </p:cNvPr>
@@ -8729,7 +8729,7 @@
           <p:cNvPr id="5" name="">
             <a:extLst xmlns:a="http://schemas.openxmlformats.org/drawingml/2006/main">
               <a:ext uri="{FF2B5EF4-FFF2-40B4-BE49-F238E27FC236}">
-                <a16:creationId xmlns:a16="http://schemas.microsoft.com/office/drawing/2014/main" id="{1A3291F9-5035-4BC8-98C1-581A57815A7E}"/>
+                <a16:creationId xmlns:a16="http://schemas.microsoft.com/office/drawing/2014/main" id="{5EA102A0-7F13-47EF-871E-895F443CFB8D}"/>
               </a:ext>
             </a:extLst>
           </p:cNvPr>
@@ -8779,7 +8779,7 @@
           <p:cNvPr id="6" name="">
             <a:extLst xmlns:a="http://schemas.openxmlformats.org/drawingml/2006/main">
               <a:ext uri="{FF2B5EF4-FFF2-40B4-BE49-F238E27FC236}">
-                <a16:creationId xmlns:a16="http://schemas.microsoft.com/office/drawing/2014/main" id="{B5BB917C-5086-4D73-B177-8CBF98A95CDB}"/>
+                <a16:creationId xmlns:a16="http://schemas.microsoft.com/office/drawing/2014/main" id="{45D1EFE5-67DE-4544-B143-CBCFDD631E5B}"/>
               </a:ext>
             </a:extLst>
           </p:cNvPr>
@@ -8814,7 +8814,7 @@
           <p:cNvPr id="7" name="">
             <a:extLst xmlns:a="http://schemas.openxmlformats.org/drawingml/2006/main">
               <a:ext uri="{FF2B5EF4-FFF2-40B4-BE49-F238E27FC236}">
-                <a16:creationId xmlns:a16="http://schemas.microsoft.com/office/drawing/2014/main" id="{C0BD9D3C-6441-43C9-9F3A-A83D204C026F}"/>
+                <a16:creationId xmlns:a16="http://schemas.microsoft.com/office/drawing/2014/main" id="{FFC3D8F9-3B3F-46FF-AB72-17D803C43043}"/>
               </a:ext>
             </a:extLst>
           </p:cNvPr>
@@ -8864,7 +8864,7 @@
           <p:cNvPr id="8" name="">
             <a:extLst xmlns:a="http://schemas.openxmlformats.org/drawingml/2006/main">
               <a:ext uri="{FF2B5EF4-FFF2-40B4-BE49-F238E27FC236}">
-                <a16:creationId xmlns:a16="http://schemas.microsoft.com/office/drawing/2014/main" id="{78A51943-871A-455D-99BD-20B2A8905FB2}"/>
+                <a16:creationId xmlns:a16="http://schemas.microsoft.com/office/drawing/2014/main" id="{5DED4F96-C90B-4CE7-BB11-15E6C66AD05F}"/>
               </a:ext>
             </a:extLst>
           </p:cNvPr>
@@ -8914,7 +8914,7 @@
           <p:cNvPr id="9" name="">
             <a:extLst xmlns:a="http://schemas.openxmlformats.org/drawingml/2006/main">
               <a:ext uri="{FF2B5EF4-FFF2-40B4-BE49-F238E27FC236}">
-                <a16:creationId xmlns:a16="http://schemas.microsoft.com/office/drawing/2014/main" id="{6C03D209-FDCB-4D03-9B59-CCDCF2672FFC}"/>
+                <a16:creationId xmlns:a16="http://schemas.microsoft.com/office/drawing/2014/main" id="{95FAEC87-B59B-44D3-A885-46B48651EBED}"/>
               </a:ext>
             </a:extLst>
           </p:cNvPr>
@@ -8949,7 +8949,7 @@
           <p:cNvPr id="10" name="">
             <a:extLst xmlns:a="http://schemas.openxmlformats.org/drawingml/2006/main">
               <a:ext uri="{FF2B5EF4-FFF2-40B4-BE49-F238E27FC236}">
-                <a16:creationId xmlns:a16="http://schemas.microsoft.com/office/drawing/2014/main" id="{5F32554B-21E6-483E-A76D-A042C2346B42}"/>
+                <a16:creationId xmlns:a16="http://schemas.microsoft.com/office/drawing/2014/main" id="{1E368313-CF19-473E-A430-C8C5CA0B3128}"/>
               </a:ext>
             </a:extLst>
           </p:cNvPr>
@@ -8999,7 +8999,7 @@
           <p:cNvPr id="11" name="">
             <a:extLst xmlns:a="http://schemas.openxmlformats.org/drawingml/2006/main">
               <a:ext uri="{FF2B5EF4-FFF2-40B4-BE49-F238E27FC236}">
-                <a16:creationId xmlns:a16="http://schemas.microsoft.com/office/drawing/2014/main" id="{FE584184-3E2E-4FBF-B567-CCC794BA4EAD}"/>
+                <a16:creationId xmlns:a16="http://schemas.microsoft.com/office/drawing/2014/main" id="{A57037A9-45FE-4167-A3AD-266DED9AA8FC}"/>
               </a:ext>
             </a:extLst>
           </p:cNvPr>
@@ -9049,7 +9049,7 @@
           <p:cNvPr id="12" name="">
             <a:extLst xmlns:a="http://schemas.openxmlformats.org/drawingml/2006/main">
               <a:ext uri="{FF2B5EF4-FFF2-40B4-BE49-F238E27FC236}">
-                <a16:creationId xmlns:a16="http://schemas.microsoft.com/office/drawing/2014/main" id="{2F5089E8-80F7-4A7D-9E54-FCFB71A8805D}"/>
+                <a16:creationId xmlns:a16="http://schemas.microsoft.com/office/drawing/2014/main" id="{1A18C871-CAEF-4877-8E18-79A7A91E31FB}"/>
               </a:ext>
             </a:extLst>
           </p:cNvPr>
@@ -9084,7 +9084,7 @@
           <p:cNvPr id="13" name="">
             <a:extLst xmlns:a="http://schemas.openxmlformats.org/drawingml/2006/main">
               <a:ext uri="{FF2B5EF4-FFF2-40B4-BE49-F238E27FC236}">
-                <a16:creationId xmlns:a16="http://schemas.microsoft.com/office/drawing/2014/main" id="{3DD3047B-AAA4-44D9-AC1F-5930D6E2D79F}"/>
+                <a16:creationId xmlns:a16="http://schemas.microsoft.com/office/drawing/2014/main" id="{87D6FDB4-A2B4-4421-BDBE-728EE4F47106}"/>
               </a:ext>
             </a:extLst>
           </p:cNvPr>
@@ -9134,7 +9134,7 @@
           <p:cNvPr id="14" name="">
             <a:extLst xmlns:a="http://schemas.openxmlformats.org/drawingml/2006/main">
               <a:ext uri="{FF2B5EF4-FFF2-40B4-BE49-F238E27FC236}">
-                <a16:creationId xmlns:a16="http://schemas.microsoft.com/office/drawing/2014/main" id="{C7C916BE-932B-4EC7-BE6F-5B30F09C901F}"/>
+                <a16:creationId xmlns:a16="http://schemas.microsoft.com/office/drawing/2014/main" id="{A66377CF-B6A5-4343-9A63-4E585EC80999}"/>
               </a:ext>
             </a:extLst>
           </p:cNvPr>
@@ -9184,7 +9184,7 @@
           <p:cNvPr id="15" name="">
             <a:extLst xmlns:a="http://schemas.openxmlformats.org/drawingml/2006/main">
               <a:ext uri="{FF2B5EF4-FFF2-40B4-BE49-F238E27FC236}">
-                <a16:creationId xmlns:a16="http://schemas.microsoft.com/office/drawing/2014/main" id="{182505D7-7CF2-4E44-9092-6348E490C91F}"/>
+                <a16:creationId xmlns:a16="http://schemas.microsoft.com/office/drawing/2014/main" id="{20A5D16E-0BFF-4CC6-8F11-F9A48BB6ED7D}"/>
               </a:ext>
             </a:extLst>
           </p:cNvPr>
@@ -9219,7 +9219,7 @@
           <p:cNvPr id="16" name="">
             <a:extLst xmlns:a="http://schemas.openxmlformats.org/drawingml/2006/main">
               <a:ext uri="{FF2B5EF4-FFF2-40B4-BE49-F238E27FC236}">
-                <a16:creationId xmlns:a16="http://schemas.microsoft.com/office/drawing/2014/main" id="{4CDAB5F6-7B55-4482-A460-F82F4E02CE81}"/>
+                <a16:creationId xmlns:a16="http://schemas.microsoft.com/office/drawing/2014/main" id="{6A62860D-6BF8-4770-85DD-08CBAE5A16BD}"/>
               </a:ext>
             </a:extLst>
           </p:cNvPr>
@@ -9269,7 +9269,7 @@
           <p:cNvPr id="17" name="">
             <a:extLst xmlns:a="http://schemas.openxmlformats.org/drawingml/2006/main">
               <a:ext uri="{FF2B5EF4-FFF2-40B4-BE49-F238E27FC236}">
-                <a16:creationId xmlns:a16="http://schemas.microsoft.com/office/drawing/2014/main" id="{ADA30031-2604-473A-B946-02C5967F0D3E}"/>
+                <a16:creationId xmlns:a16="http://schemas.microsoft.com/office/drawing/2014/main" id="{65EDA222-404F-415F-8EF1-EA7690CF3F2C}"/>
               </a:ext>
             </a:extLst>
           </p:cNvPr>
@@ -9319,7 +9319,7 @@
           <p:cNvPr id="18" name="">
             <a:extLst xmlns:a="http://schemas.openxmlformats.org/drawingml/2006/main">
               <a:ext uri="{FF2B5EF4-FFF2-40B4-BE49-F238E27FC236}">
-                <a16:creationId xmlns:a16="http://schemas.microsoft.com/office/drawing/2014/main" id="{CC6AEB81-0FF4-4A53-864E-5B6615DBC341}"/>
+                <a16:creationId xmlns:a16="http://schemas.microsoft.com/office/drawing/2014/main" id="{693F5D09-ABB0-458D-95B2-0F6C9C02D1B6}"/>
               </a:ext>
             </a:extLst>
           </p:cNvPr>
@@ -9354,7 +9354,7 @@
           <p:cNvPr id="19" name="">
             <a:extLst xmlns:a="http://schemas.openxmlformats.org/drawingml/2006/main">
               <a:ext uri="{FF2B5EF4-FFF2-40B4-BE49-F238E27FC236}">
-                <a16:creationId xmlns:a16="http://schemas.microsoft.com/office/drawing/2014/main" id="{9A4C5605-EA7C-4908-9FFF-D9137B83902C}"/>
+                <a16:creationId xmlns:a16="http://schemas.microsoft.com/office/drawing/2014/main" id="{302D67C3-78E3-4174-9C5B-A1B31EE3D9E7}"/>
               </a:ext>
             </a:extLst>
           </p:cNvPr>
@@ -9387,7 +9387,7 @@
           <p:cNvPr id="20" name="">
             <a:extLst xmlns:a="http://schemas.openxmlformats.org/drawingml/2006/main">
               <a:ext uri="{FF2B5EF4-FFF2-40B4-BE49-F238E27FC236}">
-                <a16:creationId xmlns:a16="http://schemas.microsoft.com/office/drawing/2014/main" id="{7089B722-65E4-40DC-AF02-4CB8775A2A02}"/>
+                <a16:creationId xmlns:a16="http://schemas.microsoft.com/office/drawing/2014/main" id="{A4B8F3F0-FD32-4FEB-940D-9A3075420998}"/>
               </a:ext>
             </a:extLst>
           </p:cNvPr>
@@ -9437,7 +9437,7 @@
           <p:cNvPr id="21" name="">
             <a:extLst xmlns:a="http://schemas.openxmlformats.org/drawingml/2006/main">
               <a:ext uri="{FF2B5EF4-FFF2-40B4-BE49-F238E27FC236}">
-                <a16:creationId xmlns:a16="http://schemas.microsoft.com/office/drawing/2014/main" id="{227107DC-8A57-4FC8-BA5E-1F7BD6A51718}"/>
+                <a16:creationId xmlns:a16="http://schemas.microsoft.com/office/drawing/2014/main" id="{52001BCC-FF03-4DC5-B494-2EAA245B43F0}"/>
               </a:ext>
             </a:extLst>
           </p:cNvPr>
@@ -9485,7 +9485,7 @@
     </p:spTree>
     <p:extLst>
       <p:ext uri="{BB962C8B-B14F-4D97-AF65-F5344CB8AC3E}">
-        <p14:creationId xmlns:p14="http://schemas.microsoft.com/office/powerpoint/2010/main" val="2137997693"/>
+        <p14:creationId xmlns:p14="http://schemas.microsoft.com/office/powerpoint/2010/main" val="2071462715"/>
       </p:ext>
     </p:extLst>
   </p:cSld>
@@ -9516,7 +9516,7 @@
           <p:cNvPr id="1" name="">
             <a:extLst xmlns:a="http://schemas.openxmlformats.org/drawingml/2006/main">
               <a:ext uri="{FF2B5EF4-FFF2-40B4-BE49-F238E27FC236}">
-                <a16:creationId xmlns:a16="http://schemas.microsoft.com/office/drawing/2014/main" id="{3B2AC44F-6569-4954-A2EF-7FC70307F035}"/>
+                <a16:creationId xmlns:a16="http://schemas.microsoft.com/office/drawing/2014/main" id="{05752A49-B971-4DBF-AD89-C1DB2CE316B7}"/>
               </a:ext>
             </a:extLst>
           </p:cNvPr>
@@ -9570,7 +9570,7 @@
           <p:cNvPr id="2" name="">
             <a:extLst xmlns:a="http://schemas.openxmlformats.org/drawingml/2006/main">
               <a:ext uri="{FF2B5EF4-FFF2-40B4-BE49-F238E27FC236}">
-                <a16:creationId xmlns:a16="http://schemas.microsoft.com/office/drawing/2014/main" id="{16D00D12-7761-41FA-8D05-D631D4F4F664}"/>
+                <a16:creationId xmlns:a16="http://schemas.microsoft.com/office/drawing/2014/main" id="{486A705F-1C92-4226-AAE1-CA02B3B1097D}"/>
               </a:ext>
             </a:extLst>
           </p:cNvPr>
@@ -9601,7 +9601,7 @@
           <p:cNvPr id="3" name="">
             <a:extLst xmlns:a="http://schemas.openxmlformats.org/drawingml/2006/main">
               <a:ext uri="{FF2B5EF4-FFF2-40B4-BE49-F238E27FC236}">
-                <a16:creationId xmlns:a16="http://schemas.microsoft.com/office/drawing/2014/main" id="{5D796FF9-67B7-4A7B-A5C2-02392FE5395B}"/>
+                <a16:creationId xmlns:a16="http://schemas.microsoft.com/office/drawing/2014/main" id="{3B8658E8-52D6-41F7-A4E3-F642D4C06D55}"/>
               </a:ext>
             </a:extLst>
           </p:cNvPr>
@@ -9651,7 +9651,7 @@
           <p:cNvPr id="4" name="">
             <a:extLst xmlns:a="http://schemas.openxmlformats.org/drawingml/2006/main">
               <a:ext uri="{FF2B5EF4-FFF2-40B4-BE49-F238E27FC236}">
-                <a16:creationId xmlns:a16="http://schemas.microsoft.com/office/drawing/2014/main" id="{9E353B5D-F0CD-461C-BB84-D803E461214C}"/>
+                <a16:creationId xmlns:a16="http://schemas.microsoft.com/office/drawing/2014/main" id="{FBC8D995-77D2-4ED6-BFEA-B1154377D0A2}"/>
               </a:ext>
             </a:extLst>
           </p:cNvPr>
@@ -9686,7 +9686,7 @@
           <p:cNvPr id="5" name="">
             <a:extLst xmlns:a="http://schemas.openxmlformats.org/drawingml/2006/main">
               <a:ext uri="{FF2B5EF4-FFF2-40B4-BE49-F238E27FC236}">
-                <a16:creationId xmlns:a16="http://schemas.microsoft.com/office/drawing/2014/main" id="{4CE7D0B0-E49A-4035-A323-0286038F36CB}"/>
+                <a16:creationId xmlns:a16="http://schemas.microsoft.com/office/drawing/2014/main" id="{534E6BE4-D2F9-4F1A-82CF-C716DB3B1E25}"/>
               </a:ext>
             </a:extLst>
           </p:cNvPr>
@@ -9753,7 +9753,7 @@
           <p:cNvPr id="6" name="">
             <a:extLst xmlns:a="http://schemas.openxmlformats.org/drawingml/2006/main">
               <a:ext uri="{FF2B5EF4-FFF2-40B4-BE49-F238E27FC236}">
-                <a16:creationId xmlns:a16="http://schemas.microsoft.com/office/drawing/2014/main" id="{F4D16B4D-F0E9-47EE-8806-B6D730160E91}"/>
+                <a16:creationId xmlns:a16="http://schemas.microsoft.com/office/drawing/2014/main" id="{FCCCB7F4-901E-4586-976B-1E4F81F47948}"/>
               </a:ext>
             </a:extLst>
           </p:cNvPr>
@@ -9803,7 +9803,7 @@
           <p:cNvPr id="7" name="">
             <a:extLst xmlns:a="http://schemas.openxmlformats.org/drawingml/2006/main">
               <a:ext uri="{FF2B5EF4-FFF2-40B4-BE49-F238E27FC236}">
-                <a16:creationId xmlns:a16="http://schemas.microsoft.com/office/drawing/2014/main" id="{AA967EC0-7A10-49A3-95E9-6CDC01EC4B73}"/>
+                <a16:creationId xmlns:a16="http://schemas.microsoft.com/office/drawing/2014/main" id="{0036890E-3302-4C00-89F3-B5D21A2AAA21}"/>
               </a:ext>
             </a:extLst>
           </p:cNvPr>
@@ -9838,7 +9838,7 @@
           <p:cNvPr id="8" name="">
             <a:extLst xmlns:a="http://schemas.openxmlformats.org/drawingml/2006/main">
               <a:ext uri="{FF2B5EF4-FFF2-40B4-BE49-F238E27FC236}">
-                <a16:creationId xmlns:a16="http://schemas.microsoft.com/office/drawing/2014/main" id="{8EEBD2E0-F7AD-461E-B05B-5166F747E5F9}"/>
+                <a16:creationId xmlns:a16="http://schemas.microsoft.com/office/drawing/2014/main" id="{3BF56010-3027-4225-8ECD-F26D000E2ECD}"/>
               </a:ext>
             </a:extLst>
           </p:cNvPr>
@@ -9888,7 +9888,7 @@
           <p:cNvPr id="9" name="">
             <a:extLst xmlns:a="http://schemas.openxmlformats.org/drawingml/2006/main">
               <a:ext uri="{FF2B5EF4-FFF2-40B4-BE49-F238E27FC236}">
-                <a16:creationId xmlns:a16="http://schemas.microsoft.com/office/drawing/2014/main" id="{60B228E3-3F38-46CA-8EE3-0428289004E9}"/>
+                <a16:creationId xmlns:a16="http://schemas.microsoft.com/office/drawing/2014/main" id="{A22DCD3B-3C70-4D31-AB6F-58C1B4FB9F7B}"/>
               </a:ext>
             </a:extLst>
           </p:cNvPr>
@@ -9938,7 +9938,7 @@
           <p:cNvPr id="10" name="">
             <a:extLst xmlns:a="http://schemas.openxmlformats.org/drawingml/2006/main">
               <a:ext uri="{FF2B5EF4-FFF2-40B4-BE49-F238E27FC236}">
-                <a16:creationId xmlns:a16="http://schemas.microsoft.com/office/drawing/2014/main" id="{A4621216-0B07-4A45-B8EC-0A822980BDD8}"/>
+                <a16:creationId xmlns:a16="http://schemas.microsoft.com/office/drawing/2014/main" id="{C8FB1246-3058-4667-9A22-4F72EB371E02}"/>
               </a:ext>
             </a:extLst>
           </p:cNvPr>
@@ -9973,7 +9973,7 @@
           <p:cNvPr id="11" name="">
             <a:extLst xmlns:a="http://schemas.openxmlformats.org/drawingml/2006/main">
               <a:ext uri="{FF2B5EF4-FFF2-40B4-BE49-F238E27FC236}">
-                <a16:creationId xmlns:a16="http://schemas.microsoft.com/office/drawing/2014/main" id="{6C4BEA32-A74F-421D-8E87-A39ADE5D3EE8}"/>
+                <a16:creationId xmlns:a16="http://schemas.microsoft.com/office/drawing/2014/main" id="{3AACDE22-7B21-4ADC-9441-A39787C801E0}"/>
               </a:ext>
             </a:extLst>
           </p:cNvPr>
@@ -10023,7 +10023,7 @@
           <p:cNvPr id="12" name="">
             <a:extLst xmlns:a="http://schemas.openxmlformats.org/drawingml/2006/main">
               <a:ext uri="{FF2B5EF4-FFF2-40B4-BE49-F238E27FC236}">
-                <a16:creationId xmlns:a16="http://schemas.microsoft.com/office/drawing/2014/main" id="{C4E5E828-5DAD-4F13-8A70-E3D86487F790}"/>
+                <a16:creationId xmlns:a16="http://schemas.microsoft.com/office/drawing/2014/main" id="{EC08E6E9-0CC0-46AD-81F8-F803351C3520}"/>
               </a:ext>
             </a:extLst>
           </p:cNvPr>
@@ -10073,7 +10073,7 @@
           <p:cNvPr id="13" name="">
             <a:extLst xmlns:a="http://schemas.openxmlformats.org/drawingml/2006/main">
               <a:ext uri="{FF2B5EF4-FFF2-40B4-BE49-F238E27FC236}">
-                <a16:creationId xmlns:a16="http://schemas.microsoft.com/office/drawing/2014/main" id="{4ACE79CF-3FD4-4B7F-B30C-1BBBA2419E2B}"/>
+                <a16:creationId xmlns:a16="http://schemas.microsoft.com/office/drawing/2014/main" id="{D260066F-AA36-424D-9A57-066B2526E1D5}"/>
               </a:ext>
             </a:extLst>
           </p:cNvPr>
@@ -10108,7 +10108,7 @@
           <p:cNvPr id="14" name="">
             <a:extLst xmlns:a="http://schemas.openxmlformats.org/drawingml/2006/main">
               <a:ext uri="{FF2B5EF4-FFF2-40B4-BE49-F238E27FC236}">
-                <a16:creationId xmlns:a16="http://schemas.microsoft.com/office/drawing/2014/main" id="{F9AA0C3F-ECFA-4724-9D7A-A74C01A2B44F}"/>
+                <a16:creationId xmlns:a16="http://schemas.microsoft.com/office/drawing/2014/main" id="{2C698F18-6CD9-4ABE-B54E-B318D824277B}"/>
               </a:ext>
             </a:extLst>
           </p:cNvPr>
@@ -10158,7 +10158,7 @@
           <p:cNvPr id="15" name="">
             <a:extLst xmlns:a="http://schemas.openxmlformats.org/drawingml/2006/main">
               <a:ext uri="{FF2B5EF4-FFF2-40B4-BE49-F238E27FC236}">
-                <a16:creationId xmlns:a16="http://schemas.microsoft.com/office/drawing/2014/main" id="{3F50A6C8-C2A7-4027-9B22-76B8F07199DA}"/>
+                <a16:creationId xmlns:a16="http://schemas.microsoft.com/office/drawing/2014/main" id="{D7A8B1E4-79B1-46DE-9DD0-3EC2234641F2}"/>
               </a:ext>
             </a:extLst>
           </p:cNvPr>
@@ -10208,7 +10208,7 @@
           <p:cNvPr id="16" name="">
             <a:extLst xmlns:a="http://schemas.openxmlformats.org/drawingml/2006/main">
               <a:ext uri="{FF2B5EF4-FFF2-40B4-BE49-F238E27FC236}">
-                <a16:creationId xmlns:a16="http://schemas.microsoft.com/office/drawing/2014/main" id="{AF002DAB-8331-4014-A7DA-2C64B892511D}"/>
+                <a16:creationId xmlns:a16="http://schemas.microsoft.com/office/drawing/2014/main" id="{AC7FD21F-72A0-4780-83DD-B44053F1DE9D}"/>
               </a:ext>
             </a:extLst>
           </p:cNvPr>
@@ -10243,7 +10243,7 @@
           <p:cNvPr id="17" name="">
             <a:extLst xmlns:a="http://schemas.openxmlformats.org/drawingml/2006/main">
               <a:ext uri="{FF2B5EF4-FFF2-40B4-BE49-F238E27FC236}">
-                <a16:creationId xmlns:a16="http://schemas.microsoft.com/office/drawing/2014/main" id="{BC2A3C32-B60F-4A81-A2F5-50C1B5C167F8}"/>
+                <a16:creationId xmlns:a16="http://schemas.microsoft.com/office/drawing/2014/main" id="{D1A5275C-859F-45DE-AF00-092907E6125A}"/>
               </a:ext>
             </a:extLst>
           </p:cNvPr>
@@ -10293,7 +10293,7 @@
           <p:cNvPr id="18" name="">
             <a:extLst xmlns:a="http://schemas.openxmlformats.org/drawingml/2006/main">
               <a:ext uri="{FF2B5EF4-FFF2-40B4-BE49-F238E27FC236}">
-                <a16:creationId xmlns:a16="http://schemas.microsoft.com/office/drawing/2014/main" id="{E0730300-1BDC-4FF2-AF37-BD5A85E9B54A}"/>
+                <a16:creationId xmlns:a16="http://schemas.microsoft.com/office/drawing/2014/main" id="{BA7DF47E-C468-441A-A31E-A5AED4B85777}"/>
               </a:ext>
             </a:extLst>
           </p:cNvPr>
@@ -10341,7 +10341,7 @@
     </p:spTree>
     <p:extLst>
       <p:ext uri="{BB962C8B-B14F-4D97-AF65-F5344CB8AC3E}">
-        <p14:creationId xmlns:p14="http://schemas.microsoft.com/office/powerpoint/2010/main" val="555818510"/>
+        <p14:creationId xmlns:p14="http://schemas.microsoft.com/office/powerpoint/2010/main" val="1739272591"/>
       </p:ext>
     </p:extLst>
   </p:cSld>
@@ -10372,7 +10372,7 @@
           <p:cNvPr id="1" name="">
             <a:extLst xmlns:a="http://schemas.openxmlformats.org/drawingml/2006/main">
               <a:ext uri="{FF2B5EF4-FFF2-40B4-BE49-F238E27FC236}">
-                <a16:creationId xmlns:a16="http://schemas.microsoft.com/office/drawing/2014/main" id="{CBB2C40F-7624-49DE-A094-919B58D62109}"/>
+                <a16:creationId xmlns:a16="http://schemas.microsoft.com/office/drawing/2014/main" id="{0CC5CA15-6009-46B3-8A2A-A1D6E55F2545}"/>
               </a:ext>
             </a:extLst>
           </p:cNvPr>
@@ -10426,7 +10426,7 @@
           <p:cNvPr id="2" name="">
             <a:extLst xmlns:a="http://schemas.openxmlformats.org/drawingml/2006/main">
               <a:ext uri="{FF2B5EF4-FFF2-40B4-BE49-F238E27FC236}">
-                <a16:creationId xmlns:a16="http://schemas.microsoft.com/office/drawing/2014/main" id="{EC6B6B22-1473-4CDB-B159-0EF7EE2F19C6}"/>
+                <a16:creationId xmlns:a16="http://schemas.microsoft.com/office/drawing/2014/main" id="{BC1CBCF0-BBCC-4F54-9EB0-DFEE38ECD961}"/>
               </a:ext>
             </a:extLst>
           </p:cNvPr>
@@ -10457,7 +10457,7 @@
           <p:cNvPr id="3" name="">
             <a:extLst xmlns:a="http://schemas.openxmlformats.org/drawingml/2006/main">
               <a:ext uri="{FF2B5EF4-FFF2-40B4-BE49-F238E27FC236}">
-                <a16:creationId xmlns:a16="http://schemas.microsoft.com/office/drawing/2014/main" id="{129A85C1-FA45-4A3D-BD52-434D0FA881F6}"/>
+                <a16:creationId xmlns:a16="http://schemas.microsoft.com/office/drawing/2014/main" id="{EA32FD55-EC5B-419E-8E25-83CD2AD921E5}"/>
               </a:ext>
             </a:extLst>
           </p:cNvPr>
@@ -10507,7 +10507,7 @@
           <p:cNvPr id="4" name="">
             <a:extLst xmlns:a="http://schemas.openxmlformats.org/drawingml/2006/main">
               <a:ext uri="{FF2B5EF4-FFF2-40B4-BE49-F238E27FC236}">
-                <a16:creationId xmlns:a16="http://schemas.microsoft.com/office/drawing/2014/main" id="{46A98603-C27C-4F3D-A87A-C9297E1D0BD8}"/>
+                <a16:creationId xmlns:a16="http://schemas.microsoft.com/office/drawing/2014/main" id="{0620FF4F-7CBD-4579-8997-37D4600A038A}"/>
               </a:ext>
             </a:extLst>
           </p:cNvPr>
@@ -10542,7 +10542,7 @@
           <p:cNvPr id="5" name="">
             <a:extLst xmlns:a="http://schemas.openxmlformats.org/drawingml/2006/main">
               <a:ext uri="{FF2B5EF4-FFF2-40B4-BE49-F238E27FC236}">
-                <a16:creationId xmlns:a16="http://schemas.microsoft.com/office/drawing/2014/main" id="{DF7286EB-C4B6-433D-882E-CA6629995928}"/>
+                <a16:creationId xmlns:a16="http://schemas.microsoft.com/office/drawing/2014/main" id="{70006662-5D5F-4216-BC05-EDB2B6E396B7}"/>
               </a:ext>
             </a:extLst>
           </p:cNvPr>
@@ -10575,7 +10575,7 @@
           <p:cNvPr id="6" name="">
             <a:extLst xmlns:a="http://schemas.openxmlformats.org/drawingml/2006/main">
               <a:ext uri="{FF2B5EF4-FFF2-40B4-BE49-F238E27FC236}">
-                <a16:creationId xmlns:a16="http://schemas.microsoft.com/office/drawing/2014/main" id="{A3DEC5A5-BD8F-409D-89B5-020FF35DB7A5}"/>
+                <a16:creationId xmlns:a16="http://schemas.microsoft.com/office/drawing/2014/main" id="{53F7B9A6-3BAB-4E8A-8B22-E7840F19A560}"/>
               </a:ext>
             </a:extLst>
           </p:cNvPr>
@@ -10625,7 +10625,7 @@
           <p:cNvPr id="7" name="">
             <a:extLst xmlns:a="http://schemas.openxmlformats.org/drawingml/2006/main">
               <a:ext uri="{FF2B5EF4-FFF2-40B4-BE49-F238E27FC236}">
-                <a16:creationId xmlns:a16="http://schemas.microsoft.com/office/drawing/2014/main" id="{DDF873ED-F1F8-4478-B37F-DDF0A9A7889F}"/>
+                <a16:creationId xmlns:a16="http://schemas.microsoft.com/office/drawing/2014/main" id="{2CEAD16D-89EB-427A-9BCB-B91FEBAD0C52}"/>
               </a:ext>
             </a:extLst>
           </p:cNvPr>
@@ -10675,7 +10675,7 @@
           <p:cNvPr id="8" name="">
             <a:extLst xmlns:a="http://schemas.openxmlformats.org/drawingml/2006/main">
               <a:ext uri="{FF2B5EF4-FFF2-40B4-BE49-F238E27FC236}">
-                <a16:creationId xmlns:a16="http://schemas.microsoft.com/office/drawing/2014/main" id="{B0501B1A-AD04-4D56-8AD5-5C3D1A1F03B0}"/>
+                <a16:creationId xmlns:a16="http://schemas.microsoft.com/office/drawing/2014/main" id="{108CA3D3-B5D3-413B-AB2E-8D890A32A820}"/>
               </a:ext>
             </a:extLst>
           </p:cNvPr>
@@ -10710,7 +10710,7 @@
           <p:cNvPr id="9" name="">
             <a:extLst xmlns:a="http://schemas.openxmlformats.org/drawingml/2006/main">
               <a:ext uri="{FF2B5EF4-FFF2-40B4-BE49-F238E27FC236}">
-                <a16:creationId xmlns:a16="http://schemas.microsoft.com/office/drawing/2014/main" id="{BF058815-6954-4210-8201-2334E1F617C3}"/>
+                <a16:creationId xmlns:a16="http://schemas.microsoft.com/office/drawing/2014/main" id="{B8FE8A6B-19D7-4F62-9B8E-E50E33381177}"/>
               </a:ext>
             </a:extLst>
           </p:cNvPr>
@@ -10760,7 +10760,7 @@
           <p:cNvPr id="10" name="">
             <a:extLst xmlns:a="http://schemas.openxmlformats.org/drawingml/2006/main">
               <a:ext uri="{FF2B5EF4-FFF2-40B4-BE49-F238E27FC236}">
-                <a16:creationId xmlns:a16="http://schemas.microsoft.com/office/drawing/2014/main" id="{02A31520-E776-47FC-BFCD-C0B20AB95BED}"/>
+                <a16:creationId xmlns:a16="http://schemas.microsoft.com/office/drawing/2014/main" id="{84AA1DB5-8C1B-41F0-86F8-9220C211C814}"/>
               </a:ext>
             </a:extLst>
           </p:cNvPr>
@@ -10810,7 +10810,7 @@
           <p:cNvPr id="11" name="">
             <a:extLst xmlns:a="http://schemas.openxmlformats.org/drawingml/2006/main">
               <a:ext uri="{FF2B5EF4-FFF2-40B4-BE49-F238E27FC236}">
-                <a16:creationId xmlns:a16="http://schemas.microsoft.com/office/drawing/2014/main" id="{74B9F0DD-0222-42B9-B190-4124F75B1AAE}"/>
+                <a16:creationId xmlns:a16="http://schemas.microsoft.com/office/drawing/2014/main" id="{C8DCC745-6FDF-4F22-9BAE-9EF5D2C43B8F}"/>
               </a:ext>
             </a:extLst>
           </p:cNvPr>
@@ -10845,7 +10845,7 @@
           <p:cNvPr id="12" name="">
             <a:extLst xmlns:a="http://schemas.openxmlformats.org/drawingml/2006/main">
               <a:ext uri="{FF2B5EF4-FFF2-40B4-BE49-F238E27FC236}">
-                <a16:creationId xmlns:a16="http://schemas.microsoft.com/office/drawing/2014/main" id="{9B674AC4-6D0E-40C2-ACCE-E905CA8918CA}"/>
+                <a16:creationId xmlns:a16="http://schemas.microsoft.com/office/drawing/2014/main" id="{ED8F0243-84AB-419F-9DE8-1E914AFEFC79}"/>
               </a:ext>
             </a:extLst>
           </p:cNvPr>
@@ -10895,7 +10895,7 @@
           <p:cNvPr id="13" name="">
             <a:extLst xmlns:a="http://schemas.openxmlformats.org/drawingml/2006/main">
               <a:ext uri="{FF2B5EF4-FFF2-40B4-BE49-F238E27FC236}">
-                <a16:creationId xmlns:a16="http://schemas.microsoft.com/office/drawing/2014/main" id="{CA839842-E38F-4A4F-9D17-B57660DDF040}"/>
+                <a16:creationId xmlns:a16="http://schemas.microsoft.com/office/drawing/2014/main" id="{FAAE3C7E-E75F-4F97-A76B-2F6F8C46D37D}"/>
               </a:ext>
             </a:extLst>
           </p:cNvPr>
@@ -10945,7 +10945,7 @@
           <p:cNvPr id="14" name="">
             <a:extLst xmlns:a="http://schemas.openxmlformats.org/drawingml/2006/main">
               <a:ext uri="{FF2B5EF4-FFF2-40B4-BE49-F238E27FC236}">
-                <a16:creationId xmlns:a16="http://schemas.microsoft.com/office/drawing/2014/main" id="{BDF7D942-BDF3-4241-917C-F44CE740C6D0}"/>
+                <a16:creationId xmlns:a16="http://schemas.microsoft.com/office/drawing/2014/main" id="{5EF0782C-E0A3-46CC-B889-3D8D5FDC9298}"/>
               </a:ext>
             </a:extLst>
           </p:cNvPr>
@@ -10980,7 +10980,7 @@
           <p:cNvPr id="15" name="">
             <a:extLst xmlns:a="http://schemas.openxmlformats.org/drawingml/2006/main">
               <a:ext uri="{FF2B5EF4-FFF2-40B4-BE49-F238E27FC236}">
-                <a16:creationId xmlns:a16="http://schemas.microsoft.com/office/drawing/2014/main" id="{32467950-3664-400A-BCBB-E9674378C4B5}"/>
+                <a16:creationId xmlns:a16="http://schemas.microsoft.com/office/drawing/2014/main" id="{391506FE-D200-4953-8FC2-C37983ABD9EA}"/>
               </a:ext>
             </a:extLst>
           </p:cNvPr>
@@ -11030,7 +11030,7 @@
           <p:cNvPr id="16" name="">
             <a:extLst xmlns:a="http://schemas.openxmlformats.org/drawingml/2006/main">
               <a:ext uri="{FF2B5EF4-FFF2-40B4-BE49-F238E27FC236}">
-                <a16:creationId xmlns:a16="http://schemas.microsoft.com/office/drawing/2014/main" id="{FE51F2A0-96A3-47BE-98A1-96C46732CC42}"/>
+                <a16:creationId xmlns:a16="http://schemas.microsoft.com/office/drawing/2014/main" id="{3F0C9609-5D61-45DF-BB29-060310D91984}"/>
               </a:ext>
             </a:extLst>
           </p:cNvPr>
@@ -11080,7 +11080,7 @@
           <p:cNvPr id="17" name="">
             <a:extLst xmlns:a="http://schemas.openxmlformats.org/drawingml/2006/main">
               <a:ext uri="{FF2B5EF4-FFF2-40B4-BE49-F238E27FC236}">
-                <a16:creationId xmlns:a16="http://schemas.microsoft.com/office/drawing/2014/main" id="{6D517F4F-8B01-4246-BD29-6C6BECF272BC}"/>
+                <a16:creationId xmlns:a16="http://schemas.microsoft.com/office/drawing/2014/main" id="{43181E4F-5F8A-4821-B882-14945439A3E6}"/>
               </a:ext>
             </a:extLst>
           </p:cNvPr>
@@ -11115,7 +11115,7 @@
           <p:cNvPr id="18" name="">
             <a:extLst xmlns:a="http://schemas.openxmlformats.org/drawingml/2006/main">
               <a:ext uri="{FF2B5EF4-FFF2-40B4-BE49-F238E27FC236}">
-                <a16:creationId xmlns:a16="http://schemas.microsoft.com/office/drawing/2014/main" id="{F1F2EA1A-371C-43D8-9E25-86118B32F6AC}"/>
+                <a16:creationId xmlns:a16="http://schemas.microsoft.com/office/drawing/2014/main" id="{52B647A7-5FA9-4EEB-9782-4B88416DA0CB}"/>
               </a:ext>
             </a:extLst>
           </p:cNvPr>
@@ -11165,7 +11165,7 @@
           <p:cNvPr id="19" name="">
             <a:extLst xmlns:a="http://schemas.openxmlformats.org/drawingml/2006/main">
               <a:ext uri="{FF2B5EF4-FFF2-40B4-BE49-F238E27FC236}">
-                <a16:creationId xmlns:a16="http://schemas.microsoft.com/office/drawing/2014/main" id="{B380FBA4-28DC-400B-AF72-9DA8EA8DEA3E}"/>
+                <a16:creationId xmlns:a16="http://schemas.microsoft.com/office/drawing/2014/main" id="{B3F3F462-58DD-43FB-B80E-C457DA4C6FDD}"/>
               </a:ext>
             </a:extLst>
           </p:cNvPr>
@@ -11213,7 +11213,7 @@
     </p:spTree>
     <p:extLst>
       <p:ext uri="{BB962C8B-B14F-4D97-AF65-F5344CB8AC3E}">
-        <p14:creationId xmlns:p14="http://schemas.microsoft.com/office/powerpoint/2010/main" val="288513331"/>
+        <p14:creationId xmlns:p14="http://schemas.microsoft.com/office/powerpoint/2010/main" val="152949982"/>
       </p:ext>
     </p:extLst>
   </p:cSld>
@@ -11244,7 +11244,7 @@
           <p:cNvPr id="1" name="">
             <a:extLst xmlns:a="http://schemas.openxmlformats.org/drawingml/2006/main">
               <a:ext uri="{FF2B5EF4-FFF2-40B4-BE49-F238E27FC236}">
-                <a16:creationId xmlns:a16="http://schemas.microsoft.com/office/drawing/2014/main" id="{D8ACED99-C370-49D0-BBFB-DACD212BF8FB}"/>
+                <a16:creationId xmlns:a16="http://schemas.microsoft.com/office/drawing/2014/main" id="{F8C20530-D519-4590-A82A-223FF8D7D7FD}"/>
               </a:ext>
             </a:extLst>
           </p:cNvPr>
@@ -11298,7 +11298,7 @@
           <p:cNvPr id="2" name="">
             <a:extLst xmlns:a="http://schemas.openxmlformats.org/drawingml/2006/main">
               <a:ext uri="{FF2B5EF4-FFF2-40B4-BE49-F238E27FC236}">
-                <a16:creationId xmlns:a16="http://schemas.microsoft.com/office/drawing/2014/main" id="{7F0C3860-FB26-4F15-BEC9-D04639085E3D}"/>
+                <a16:creationId xmlns:a16="http://schemas.microsoft.com/office/drawing/2014/main" id="{361E8858-CD2D-455C-8D9B-70FE5F4CE63B}"/>
               </a:ext>
             </a:extLst>
           </p:cNvPr>
@@ -11329,7 +11329,7 @@
           <p:cNvPr id="3" name="">
             <a:extLst xmlns:a="http://schemas.openxmlformats.org/drawingml/2006/main">
               <a:ext uri="{FF2B5EF4-FFF2-40B4-BE49-F238E27FC236}">
-                <a16:creationId xmlns:a16="http://schemas.microsoft.com/office/drawing/2014/main" id="{D5C980C4-E070-489E-B986-45D327E7FBD0}"/>
+                <a16:creationId xmlns:a16="http://schemas.microsoft.com/office/drawing/2014/main" id="{C8443431-432D-48CA-BC19-4611D87E09BB}"/>
               </a:ext>
             </a:extLst>
           </p:cNvPr>
@@ -11379,7 +11379,7 @@
           <p:cNvPr id="4" name="">
             <a:extLst xmlns:a="http://schemas.openxmlformats.org/drawingml/2006/main">
               <a:ext uri="{FF2B5EF4-FFF2-40B4-BE49-F238E27FC236}">
-                <a16:creationId xmlns:a16="http://schemas.microsoft.com/office/drawing/2014/main" id="{66ADF9F4-F218-4815-A58C-F6F85A599EEA}"/>
+                <a16:creationId xmlns:a16="http://schemas.microsoft.com/office/drawing/2014/main" id="{B8EE6A57-EC4A-4C98-9A8F-628DE29B690B}"/>
               </a:ext>
             </a:extLst>
           </p:cNvPr>
@@ -11429,7 +11429,7 @@
           <p:cNvPr id="5" name="">
             <a:extLst xmlns:a="http://schemas.openxmlformats.org/drawingml/2006/main">
               <a:ext uri="{FF2B5EF4-FFF2-40B4-BE49-F238E27FC236}">
-                <a16:creationId xmlns:a16="http://schemas.microsoft.com/office/drawing/2014/main" id="{30C2442F-2F6B-4177-A985-7BA6BADD25F2}"/>
+                <a16:creationId xmlns:a16="http://schemas.microsoft.com/office/drawing/2014/main" id="{A56B1C4F-281A-45E0-B9A4-9E94D2A661E9}"/>
               </a:ext>
             </a:extLst>
           </p:cNvPr>
@@ -11479,7 +11479,7 @@
           <p:cNvPr id="6" name="">
             <a:extLst xmlns:a="http://schemas.openxmlformats.org/drawingml/2006/main">
               <a:ext uri="{FF2B5EF4-FFF2-40B4-BE49-F238E27FC236}">
-                <a16:creationId xmlns:a16="http://schemas.microsoft.com/office/drawing/2014/main" id="{E13B58F2-8243-4F96-9ECE-5FF436185C37}"/>
+                <a16:creationId xmlns:a16="http://schemas.microsoft.com/office/drawing/2014/main" id="{9D1D23AC-DF78-4BC1-85D7-6E575D82FF4D}"/>
               </a:ext>
             </a:extLst>
           </p:cNvPr>
@@ -11514,7 +11514,7 @@
           <p:cNvPr id="7" name="">
             <a:extLst xmlns:a="http://schemas.openxmlformats.org/drawingml/2006/main">
               <a:ext uri="{FF2B5EF4-FFF2-40B4-BE49-F238E27FC236}">
-                <a16:creationId xmlns:a16="http://schemas.microsoft.com/office/drawing/2014/main" id="{C339120E-F9A3-4496-B9AA-F9C5E40579CB}"/>
+                <a16:creationId xmlns:a16="http://schemas.microsoft.com/office/drawing/2014/main" id="{DF27EEF2-6CBE-46FA-97E9-F624B338A2A2}"/>
               </a:ext>
             </a:extLst>
           </p:cNvPr>
@@ -11547,7 +11547,7 @@
           <p:cNvPr id="8" name="">
             <a:extLst xmlns:a="http://schemas.openxmlformats.org/drawingml/2006/main">
               <a:ext uri="{FF2B5EF4-FFF2-40B4-BE49-F238E27FC236}">
-                <a16:creationId xmlns:a16="http://schemas.microsoft.com/office/drawing/2014/main" id="{198D71A6-7999-4210-85C0-D00B428589FC}"/>
+                <a16:creationId xmlns:a16="http://schemas.microsoft.com/office/drawing/2014/main" id="{85E8EC9C-5DAD-47B2-86F7-4902AFDA35A1}"/>
               </a:ext>
             </a:extLst>
           </p:cNvPr>
@@ -11597,7 +11597,7 @@
           <p:cNvPr id="9" name="">
             <a:extLst xmlns:a="http://schemas.openxmlformats.org/drawingml/2006/main">
               <a:ext uri="{FF2B5EF4-FFF2-40B4-BE49-F238E27FC236}">
-                <a16:creationId xmlns:a16="http://schemas.microsoft.com/office/drawing/2014/main" id="{60024A13-AB9C-4D8C-8E8F-F840ECF170F1}"/>
+                <a16:creationId xmlns:a16="http://schemas.microsoft.com/office/drawing/2014/main" id="{D01E91CD-87EA-4D5A-A6B7-9BEB62550147}"/>
               </a:ext>
             </a:extLst>
           </p:cNvPr>
@@ -11703,7 +11703,7 @@
           <p:cNvPr id="10" name="">
             <a:extLst xmlns:a="http://schemas.openxmlformats.org/drawingml/2006/main">
               <a:ext uri="{FF2B5EF4-FFF2-40B4-BE49-F238E27FC236}">
-                <a16:creationId xmlns:a16="http://schemas.microsoft.com/office/drawing/2014/main" id="{7112DA65-EA93-4448-A952-4CED28F18BFD}"/>
+                <a16:creationId xmlns:a16="http://schemas.microsoft.com/office/drawing/2014/main" id="{CE5BA5E9-96DC-4591-99AF-616939067755}"/>
               </a:ext>
             </a:extLst>
           </p:cNvPr>
@@ -11738,7 +11738,7 @@
           <p:cNvPr id="11" name="">
             <a:extLst xmlns:a="http://schemas.openxmlformats.org/drawingml/2006/main">
               <a:ext uri="{FF2B5EF4-FFF2-40B4-BE49-F238E27FC236}">
-                <a16:creationId xmlns:a16="http://schemas.microsoft.com/office/drawing/2014/main" id="{46A11A04-49AA-4122-9453-A1E1136537C2}"/>
+                <a16:creationId xmlns:a16="http://schemas.microsoft.com/office/drawing/2014/main" id="{4472EB7F-94EE-413C-9EE7-03A55A8B33FE}"/>
               </a:ext>
             </a:extLst>
           </p:cNvPr>
@@ -11771,7 +11771,7 @@
           <p:cNvPr id="12" name="">
             <a:extLst xmlns:a="http://schemas.openxmlformats.org/drawingml/2006/main">
               <a:ext uri="{FF2B5EF4-FFF2-40B4-BE49-F238E27FC236}">
-                <a16:creationId xmlns:a16="http://schemas.microsoft.com/office/drawing/2014/main" id="{2A48E334-54D7-42E7-A7F6-31D867C69D1E}"/>
+                <a16:creationId xmlns:a16="http://schemas.microsoft.com/office/drawing/2014/main" id="{B7102D83-60DB-41EB-8326-1C74B29445D6}"/>
               </a:ext>
             </a:extLst>
           </p:cNvPr>
@@ -11821,7 +11821,7 @@
           <p:cNvPr id="13" name="">
             <a:extLst xmlns:a="http://schemas.openxmlformats.org/drawingml/2006/main">
               <a:ext uri="{FF2B5EF4-FFF2-40B4-BE49-F238E27FC236}">
-                <a16:creationId xmlns:a16="http://schemas.microsoft.com/office/drawing/2014/main" id="{D349EE7E-83EE-42EB-B08A-368B5927E0D4}"/>
+                <a16:creationId xmlns:a16="http://schemas.microsoft.com/office/drawing/2014/main" id="{77C09D27-044F-4CAC-92E9-3C654459F28D}"/>
               </a:ext>
             </a:extLst>
           </p:cNvPr>
@@ -11910,7 +11910,7 @@
           <p:cNvPr id="14" name="">
             <a:extLst xmlns:a="http://schemas.openxmlformats.org/drawingml/2006/main">
               <a:ext uri="{FF2B5EF4-FFF2-40B4-BE49-F238E27FC236}">
-                <a16:creationId xmlns:a16="http://schemas.microsoft.com/office/drawing/2014/main" id="{8DD5E4DB-D77F-4509-BB92-8ED156766093}"/>
+                <a16:creationId xmlns:a16="http://schemas.microsoft.com/office/drawing/2014/main" id="{8FAC995C-50A1-4751-9015-9BEC1B38923B}"/>
               </a:ext>
             </a:extLst>
           </p:cNvPr>
@@ -11945,7 +11945,7 @@
           <p:cNvPr id="15" name="">
             <a:extLst xmlns:a="http://schemas.openxmlformats.org/drawingml/2006/main">
               <a:ext uri="{FF2B5EF4-FFF2-40B4-BE49-F238E27FC236}">
-                <a16:creationId xmlns:a16="http://schemas.microsoft.com/office/drawing/2014/main" id="{6EBA664C-86D6-4265-A7C2-E2903611BB81}"/>
+                <a16:creationId xmlns:a16="http://schemas.microsoft.com/office/drawing/2014/main" id="{739A326A-76AA-437A-86EA-10FB92197DFC}"/>
               </a:ext>
             </a:extLst>
           </p:cNvPr>
@@ -11978,7 +11978,7 @@
           <p:cNvPr id="16" name="">
             <a:extLst xmlns:a="http://schemas.openxmlformats.org/drawingml/2006/main">
               <a:ext uri="{FF2B5EF4-FFF2-40B4-BE49-F238E27FC236}">
-                <a16:creationId xmlns:a16="http://schemas.microsoft.com/office/drawing/2014/main" id="{1DDE511F-8102-4D68-A5BC-D86F79A882B4}"/>
+                <a16:creationId xmlns:a16="http://schemas.microsoft.com/office/drawing/2014/main" id="{51F00AC9-F1D0-4447-A984-81274B9503A3}"/>
               </a:ext>
             </a:extLst>
           </p:cNvPr>
@@ -12028,7 +12028,7 @@
           <p:cNvPr id="17" name="">
             <a:extLst xmlns:a="http://schemas.openxmlformats.org/drawingml/2006/main">
               <a:ext uri="{FF2B5EF4-FFF2-40B4-BE49-F238E27FC236}">
-                <a16:creationId xmlns:a16="http://schemas.microsoft.com/office/drawing/2014/main" id="{B73CEA30-7174-449E-A971-32E8FA72CEBD}"/>
+                <a16:creationId xmlns:a16="http://schemas.microsoft.com/office/drawing/2014/main" id="{3106A8F3-9052-4B72-992E-1C412371A1A1}"/>
               </a:ext>
             </a:extLst>
           </p:cNvPr>
@@ -12117,7 +12117,7 @@
           <p:cNvPr id="18" name="">
             <a:extLst xmlns:a="http://schemas.openxmlformats.org/drawingml/2006/main">
               <a:ext uri="{FF2B5EF4-FFF2-40B4-BE49-F238E27FC236}">
-                <a16:creationId xmlns:a16="http://schemas.microsoft.com/office/drawing/2014/main" id="{29D38877-22B4-4DC4-8E27-3A9286900ECA}"/>
+                <a16:creationId xmlns:a16="http://schemas.microsoft.com/office/drawing/2014/main" id="{9D5E116B-E501-458A-9901-1739F8392779}"/>
               </a:ext>
             </a:extLst>
           </p:cNvPr>
@@ -12152,7 +12152,7 @@
           <p:cNvPr id="19" name="">
             <a:extLst xmlns:a="http://schemas.openxmlformats.org/drawingml/2006/main">
               <a:ext uri="{FF2B5EF4-FFF2-40B4-BE49-F238E27FC236}">
-                <a16:creationId xmlns:a16="http://schemas.microsoft.com/office/drawing/2014/main" id="{76E5366E-9257-4E44-AA27-9B9533AB64C9}"/>
+                <a16:creationId xmlns:a16="http://schemas.microsoft.com/office/drawing/2014/main" id="{94F72280-5483-4204-8489-A1ECCB0A4417}"/>
               </a:ext>
             </a:extLst>
           </p:cNvPr>
@@ -12185,7 +12185,7 @@
           <p:cNvPr id="20" name="">
             <a:extLst xmlns:a="http://schemas.openxmlformats.org/drawingml/2006/main">
               <a:ext uri="{FF2B5EF4-FFF2-40B4-BE49-F238E27FC236}">
-                <a16:creationId xmlns:a16="http://schemas.microsoft.com/office/drawing/2014/main" id="{2360DFDC-BF8E-47A3-94D0-2B4AA92B641D}"/>
+                <a16:creationId xmlns:a16="http://schemas.microsoft.com/office/drawing/2014/main" id="{09B90AFD-BC59-4A83-AA07-C97C8B6FE529}"/>
               </a:ext>
             </a:extLst>
           </p:cNvPr>
@@ -12235,7 +12235,7 @@
           <p:cNvPr id="21" name="">
             <a:extLst xmlns:a="http://schemas.openxmlformats.org/drawingml/2006/main">
               <a:ext uri="{FF2B5EF4-FFF2-40B4-BE49-F238E27FC236}">
-                <a16:creationId xmlns:a16="http://schemas.microsoft.com/office/drawing/2014/main" id="{1C4FCE9C-CC4B-435E-9A3D-F43D8E6056AE}"/>
+                <a16:creationId xmlns:a16="http://schemas.microsoft.com/office/drawing/2014/main" id="{5BB84AEA-A1B2-4898-9F63-0FCF549E7C89}"/>
               </a:ext>
             </a:extLst>
           </p:cNvPr>
@@ -12307,7 +12307,7 @@
           <p:cNvPr id="22" name="">
             <a:extLst xmlns:a="http://schemas.openxmlformats.org/drawingml/2006/main">
               <a:ext uri="{FF2B5EF4-FFF2-40B4-BE49-F238E27FC236}">
-                <a16:creationId xmlns:a16="http://schemas.microsoft.com/office/drawing/2014/main" id="{1569BBFE-922A-4D01-A6AD-58AE563D981E}"/>
+                <a16:creationId xmlns:a16="http://schemas.microsoft.com/office/drawing/2014/main" id="{D03175B5-FA1C-4FA6-9342-641D771398C0}"/>
               </a:ext>
             </a:extLst>
           </p:cNvPr>
@@ -12342,7 +12342,7 @@
           <p:cNvPr id="23" name="">
             <a:extLst xmlns:a="http://schemas.openxmlformats.org/drawingml/2006/main">
               <a:ext uri="{FF2B5EF4-FFF2-40B4-BE49-F238E27FC236}">
-                <a16:creationId xmlns:a16="http://schemas.microsoft.com/office/drawing/2014/main" id="{5C0CBF98-3232-4416-BBE5-35BC6737B0F3}"/>
+                <a16:creationId xmlns:a16="http://schemas.microsoft.com/office/drawing/2014/main" id="{F267A933-506E-41CC-AF3B-BB536CDB6A96}"/>
               </a:ext>
             </a:extLst>
           </p:cNvPr>
@@ -12375,7 +12375,7 @@
           <p:cNvPr id="24" name="">
             <a:extLst xmlns:a="http://schemas.openxmlformats.org/drawingml/2006/main">
               <a:ext uri="{FF2B5EF4-FFF2-40B4-BE49-F238E27FC236}">
-                <a16:creationId xmlns:a16="http://schemas.microsoft.com/office/drawing/2014/main" id="{A0411BE8-7DEA-4192-8E6C-A417C7F0DE3D}"/>
+                <a16:creationId xmlns:a16="http://schemas.microsoft.com/office/drawing/2014/main" id="{CB21ADEE-5B95-4CDD-A218-BC078A35E8EB}"/>
               </a:ext>
             </a:extLst>
           </p:cNvPr>
@@ -12425,7 +12425,7 @@
           <p:cNvPr id="25" name="">
             <a:extLst xmlns:a="http://schemas.openxmlformats.org/drawingml/2006/main">
               <a:ext uri="{FF2B5EF4-FFF2-40B4-BE49-F238E27FC236}">
-                <a16:creationId xmlns:a16="http://schemas.microsoft.com/office/drawing/2014/main" id="{F4DFECCE-A491-4E11-99B4-E73911C4EA49}"/>
+                <a16:creationId xmlns:a16="http://schemas.microsoft.com/office/drawing/2014/main" id="{1C229F23-98B1-465D-A280-AF9F62112ECA}"/>
               </a:ext>
             </a:extLst>
           </p:cNvPr>
@@ -12514,7 +12514,7 @@
           <p:cNvPr id="26" name="">
             <a:extLst xmlns:a="http://schemas.openxmlformats.org/drawingml/2006/main">
               <a:ext uri="{FF2B5EF4-FFF2-40B4-BE49-F238E27FC236}">
-                <a16:creationId xmlns:a16="http://schemas.microsoft.com/office/drawing/2014/main" id="{267D57C6-0655-4C92-88B1-6E3BA41315A2}"/>
+                <a16:creationId xmlns:a16="http://schemas.microsoft.com/office/drawing/2014/main" id="{E955CF81-D84E-470B-81E7-CB2A46F32917}"/>
               </a:ext>
             </a:extLst>
           </p:cNvPr>
@@ -12549,7 +12549,7 @@
           <p:cNvPr id="27" name="">
             <a:extLst xmlns:a="http://schemas.openxmlformats.org/drawingml/2006/main">
               <a:ext uri="{FF2B5EF4-FFF2-40B4-BE49-F238E27FC236}">
-                <a16:creationId xmlns:a16="http://schemas.microsoft.com/office/drawing/2014/main" id="{026346D5-3E3D-499D-8913-4A5B5B96D9F1}"/>
+                <a16:creationId xmlns:a16="http://schemas.microsoft.com/office/drawing/2014/main" id="{3EC1B4BC-1F7E-4F10-9571-B533726CD5B2}"/>
               </a:ext>
             </a:extLst>
           </p:cNvPr>
@@ -12582,7 +12582,7 @@
           <p:cNvPr id="28" name="">
             <a:extLst xmlns:a="http://schemas.openxmlformats.org/drawingml/2006/main">
               <a:ext uri="{FF2B5EF4-FFF2-40B4-BE49-F238E27FC236}">
-                <a16:creationId xmlns:a16="http://schemas.microsoft.com/office/drawing/2014/main" id="{4F8B471B-4113-46B7-8691-BF3D530E5E37}"/>
+                <a16:creationId xmlns:a16="http://schemas.microsoft.com/office/drawing/2014/main" id="{78273560-DE88-4B64-BDE6-6E95CA4B9A14}"/>
               </a:ext>
             </a:extLst>
           </p:cNvPr>
@@ -12632,7 +12632,7 @@
           <p:cNvPr id="29" name="">
             <a:extLst xmlns:a="http://schemas.openxmlformats.org/drawingml/2006/main">
               <a:ext uri="{FF2B5EF4-FFF2-40B4-BE49-F238E27FC236}">
-                <a16:creationId xmlns:a16="http://schemas.microsoft.com/office/drawing/2014/main" id="{FE3A8D35-A9DB-4A3D-AEF6-1E72E4BD20AD}"/>
+                <a16:creationId xmlns:a16="http://schemas.microsoft.com/office/drawing/2014/main" id="{26422405-0438-4023-8C0C-70A98C33AAD9}"/>
               </a:ext>
             </a:extLst>
           </p:cNvPr>
@@ -12719,7 +12719,7 @@
     </p:spTree>
     <p:extLst>
       <p:ext uri="{BB962C8B-B14F-4D97-AF65-F5344CB8AC3E}">
-        <p14:creationId xmlns:p14="http://schemas.microsoft.com/office/powerpoint/2010/main" val="1881285522"/>
+        <p14:creationId xmlns:p14="http://schemas.microsoft.com/office/powerpoint/2010/main" val="2036915317"/>
       </p:ext>
     </p:extLst>
   </p:cSld>
@@ -12750,7 +12750,7 @@
           <p:cNvPr id="1" name="">
             <a:extLst xmlns:a="http://schemas.openxmlformats.org/drawingml/2006/main">
               <a:ext uri="{FF2B5EF4-FFF2-40B4-BE49-F238E27FC236}">
-                <a16:creationId xmlns:a16="http://schemas.microsoft.com/office/drawing/2014/main" id="{F935CB9F-E2CF-47E0-8DBD-578B4E9645A1}"/>
+                <a16:creationId xmlns:a16="http://schemas.microsoft.com/office/drawing/2014/main" id="{9A121D7C-67DA-4DD7-B556-4F47153608BF}"/>
               </a:ext>
             </a:extLst>
           </p:cNvPr>
@@ -12804,7 +12804,7 @@
           <p:cNvPr id="2" name="">
             <a:extLst xmlns:a="http://schemas.openxmlformats.org/drawingml/2006/main">
               <a:ext uri="{FF2B5EF4-FFF2-40B4-BE49-F238E27FC236}">
-                <a16:creationId xmlns:a16="http://schemas.microsoft.com/office/drawing/2014/main" id="{5D428098-F76E-4B52-B7F0-929A4974810C}"/>
+                <a16:creationId xmlns:a16="http://schemas.microsoft.com/office/drawing/2014/main" id="{28FCE8E6-6002-468B-909F-AA9E6F6D316D}"/>
               </a:ext>
             </a:extLst>
           </p:cNvPr>
@@ -12835,7 +12835,7 @@
           <p:cNvPr id="3" name="">
             <a:extLst xmlns:a="http://schemas.openxmlformats.org/drawingml/2006/main">
               <a:ext uri="{FF2B5EF4-FFF2-40B4-BE49-F238E27FC236}">
-                <a16:creationId xmlns:a16="http://schemas.microsoft.com/office/drawing/2014/main" id="{C34A9CD5-E1CC-454F-8084-7C935DBC5093}"/>
+                <a16:creationId xmlns:a16="http://schemas.microsoft.com/office/drawing/2014/main" id="{F372A979-F2CB-4000-8153-5369C1A8A313}"/>
               </a:ext>
             </a:extLst>
           </p:cNvPr>
@@ -12885,7 +12885,7 @@
           <p:cNvPr id="4" name="">
             <a:extLst xmlns:a="http://schemas.openxmlformats.org/drawingml/2006/main">
               <a:ext uri="{FF2B5EF4-FFF2-40B4-BE49-F238E27FC236}">
-                <a16:creationId xmlns:a16="http://schemas.microsoft.com/office/drawing/2014/main" id="{DA49E56B-E7AF-4E1D-8AF1-25880A82B659}"/>
+                <a16:creationId xmlns:a16="http://schemas.microsoft.com/office/drawing/2014/main" id="{330804DE-8887-4C82-B985-9813A83A6601}"/>
               </a:ext>
             </a:extLst>
           </p:cNvPr>
@@ -12935,7 +12935,7 @@
           <p:cNvPr id="5" name="">
             <a:extLst xmlns:a="http://schemas.openxmlformats.org/drawingml/2006/main">
               <a:ext uri="{FF2B5EF4-FFF2-40B4-BE49-F238E27FC236}">
-                <a16:creationId xmlns:a16="http://schemas.microsoft.com/office/drawing/2014/main" id="{72395DE9-2747-4493-8259-C53FEF221B10}"/>
+                <a16:creationId xmlns:a16="http://schemas.microsoft.com/office/drawing/2014/main" id="{AD5C2CE8-5AEE-4C69-AB46-307C41BBDB73}"/>
               </a:ext>
             </a:extLst>
           </p:cNvPr>
@@ -12985,7 +12985,7 @@
           <p:cNvPr id="6" name="">
             <a:extLst xmlns:a="http://schemas.openxmlformats.org/drawingml/2006/main">
               <a:ext uri="{FF2B5EF4-FFF2-40B4-BE49-F238E27FC236}">
-                <a16:creationId xmlns:a16="http://schemas.microsoft.com/office/drawing/2014/main" id="{C560C28F-D024-4997-BEC1-6DD628898C4B}"/>
+                <a16:creationId xmlns:a16="http://schemas.microsoft.com/office/drawing/2014/main" id="{A339C6B5-1DCA-47B8-80A6-2E99E07A6CF3}"/>
               </a:ext>
             </a:extLst>
           </p:cNvPr>
@@ -13020,7 +13020,7 @@
           <p:cNvPr id="7" name="">
             <a:extLst xmlns:a="http://schemas.openxmlformats.org/drawingml/2006/main">
               <a:ext uri="{FF2B5EF4-FFF2-40B4-BE49-F238E27FC236}">
-                <a16:creationId xmlns:a16="http://schemas.microsoft.com/office/drawing/2014/main" id="{763B4E2D-CDC7-4F23-9D62-3367CCB377F4}"/>
+                <a16:creationId xmlns:a16="http://schemas.microsoft.com/office/drawing/2014/main" id="{D50AA485-7D62-40B5-A74C-42F8F7FD1B74}"/>
               </a:ext>
             </a:extLst>
           </p:cNvPr>
@@ -13070,7 +13070,7 @@
           <p:cNvPr id="8" name="">
             <a:extLst xmlns:a="http://schemas.openxmlformats.org/drawingml/2006/main">
               <a:ext uri="{FF2B5EF4-FFF2-40B4-BE49-F238E27FC236}">
-                <a16:creationId xmlns:a16="http://schemas.microsoft.com/office/drawing/2014/main" id="{D28EE8CC-6337-415D-885F-4C63CBA3778B}"/>
+                <a16:creationId xmlns:a16="http://schemas.microsoft.com/office/drawing/2014/main" id="{F80418DB-34F3-458A-AA28-39A700DD40FF}"/>
               </a:ext>
             </a:extLst>
           </p:cNvPr>
@@ -13120,7 +13120,7 @@
           <p:cNvPr id="9" name="">
             <a:extLst xmlns:a="http://schemas.openxmlformats.org/drawingml/2006/main">
               <a:ext uri="{FF2B5EF4-FFF2-40B4-BE49-F238E27FC236}">
-                <a16:creationId xmlns:a16="http://schemas.microsoft.com/office/drawing/2014/main" id="{F5B351B7-C623-4B09-A2BC-8F6B7E0DC207}"/>
+                <a16:creationId xmlns:a16="http://schemas.microsoft.com/office/drawing/2014/main" id="{B033FBF8-74A6-4CE0-8E85-649DDBA8809D}"/>
               </a:ext>
             </a:extLst>
           </p:cNvPr>
@@ -13155,7 +13155,7 @@
           <p:cNvPr id="10" name="">
             <a:extLst xmlns:a="http://schemas.openxmlformats.org/drawingml/2006/main">
               <a:ext uri="{FF2B5EF4-FFF2-40B4-BE49-F238E27FC236}">
-                <a16:creationId xmlns:a16="http://schemas.microsoft.com/office/drawing/2014/main" id="{4A681497-53AA-49EE-AFA0-2AAFCE4BB43E}"/>
+                <a16:creationId xmlns:a16="http://schemas.microsoft.com/office/drawing/2014/main" id="{BC7BDD54-459B-45BB-809B-828AA705137F}"/>
               </a:ext>
             </a:extLst>
           </p:cNvPr>
@@ -13205,7 +13205,7 @@
           <p:cNvPr id="11" name="">
             <a:extLst xmlns:a="http://schemas.openxmlformats.org/drawingml/2006/main">
               <a:ext uri="{FF2B5EF4-FFF2-40B4-BE49-F238E27FC236}">
-                <a16:creationId xmlns:a16="http://schemas.microsoft.com/office/drawing/2014/main" id="{FA72566C-8F1E-4B8F-BCC9-AED219B64550}"/>
+                <a16:creationId xmlns:a16="http://schemas.microsoft.com/office/drawing/2014/main" id="{A81DBD70-2067-4797-BDF0-B8F9D7712EA7}"/>
               </a:ext>
             </a:extLst>
           </p:cNvPr>
@@ -13255,7 +13255,7 @@
           <p:cNvPr id="12" name="">
             <a:extLst xmlns:a="http://schemas.openxmlformats.org/drawingml/2006/main">
               <a:ext uri="{FF2B5EF4-FFF2-40B4-BE49-F238E27FC236}">
-                <a16:creationId xmlns:a16="http://schemas.microsoft.com/office/drawing/2014/main" id="{8C43CB5F-5898-442E-BFBC-76BC88EA9F0C}"/>
+                <a16:creationId xmlns:a16="http://schemas.microsoft.com/office/drawing/2014/main" id="{C9EB3222-75B1-4FB8-930E-2BADC1B615FC}"/>
               </a:ext>
             </a:extLst>
           </p:cNvPr>
@@ -13290,7 +13290,7 @@
           <p:cNvPr id="13" name="">
             <a:extLst xmlns:a="http://schemas.openxmlformats.org/drawingml/2006/main">
               <a:ext uri="{FF2B5EF4-FFF2-40B4-BE49-F238E27FC236}">
-                <a16:creationId xmlns:a16="http://schemas.microsoft.com/office/drawing/2014/main" id="{78DE4126-D3BB-4BBA-8E35-7D6D8DFC1CFD}"/>
+                <a16:creationId xmlns:a16="http://schemas.microsoft.com/office/drawing/2014/main" id="{BC81EE4C-03B6-4DA2-B739-1655368389C4}"/>
               </a:ext>
             </a:extLst>
           </p:cNvPr>
@@ -13340,7 +13340,7 @@
           <p:cNvPr id="14" name="">
             <a:extLst xmlns:a="http://schemas.openxmlformats.org/drawingml/2006/main">
               <a:ext uri="{FF2B5EF4-FFF2-40B4-BE49-F238E27FC236}">
-                <a16:creationId xmlns:a16="http://schemas.microsoft.com/office/drawing/2014/main" id="{19B7A7A0-DD20-40E1-ADCB-59CCE690BE30}"/>
+                <a16:creationId xmlns:a16="http://schemas.microsoft.com/office/drawing/2014/main" id="{F5E31F2C-1926-4C0C-A9FF-EA293574A372}"/>
               </a:ext>
             </a:extLst>
           </p:cNvPr>
@@ -13390,7 +13390,7 @@
           <p:cNvPr id="15" name="">
             <a:extLst xmlns:a="http://schemas.openxmlformats.org/drawingml/2006/main">
               <a:ext uri="{FF2B5EF4-FFF2-40B4-BE49-F238E27FC236}">
-                <a16:creationId xmlns:a16="http://schemas.microsoft.com/office/drawing/2014/main" id="{9232F786-0A44-4717-A3ED-7BD0DE926E27}"/>
+                <a16:creationId xmlns:a16="http://schemas.microsoft.com/office/drawing/2014/main" id="{5089D3B1-C961-410F-AFF8-6641E7917672}"/>
               </a:ext>
             </a:extLst>
           </p:cNvPr>
@@ -13425,7 +13425,7 @@
           <p:cNvPr id="16" name="">
             <a:extLst xmlns:a="http://schemas.openxmlformats.org/drawingml/2006/main">
               <a:ext uri="{FF2B5EF4-FFF2-40B4-BE49-F238E27FC236}">
-                <a16:creationId xmlns:a16="http://schemas.microsoft.com/office/drawing/2014/main" id="{6ACF2644-0CEC-4DCD-934B-0241141DDA12}"/>
+                <a16:creationId xmlns:a16="http://schemas.microsoft.com/office/drawing/2014/main" id="{4216C3C5-FA22-4615-ABB3-D58D3FD70871}"/>
               </a:ext>
             </a:extLst>
           </p:cNvPr>
@@ -13458,7 +13458,7 @@
           <p:cNvPr id="17" name="">
             <a:extLst xmlns:a="http://schemas.openxmlformats.org/drawingml/2006/main">
               <a:ext uri="{FF2B5EF4-FFF2-40B4-BE49-F238E27FC236}">
-                <a16:creationId xmlns:a16="http://schemas.microsoft.com/office/drawing/2014/main" id="{E67EC93F-B4A7-42D3-BE84-3C9D2F745F5C}"/>
+                <a16:creationId xmlns:a16="http://schemas.microsoft.com/office/drawing/2014/main" id="{3C5E45B0-D818-48E2-A2F4-4237211E574F}"/>
               </a:ext>
             </a:extLst>
           </p:cNvPr>
@@ -13508,7 +13508,7 @@
           <p:cNvPr id="18" name="">
             <a:extLst xmlns:a="http://schemas.openxmlformats.org/drawingml/2006/main">
               <a:ext uri="{FF2B5EF4-FFF2-40B4-BE49-F238E27FC236}">
-                <a16:creationId xmlns:a16="http://schemas.microsoft.com/office/drawing/2014/main" id="{740F529C-0727-466C-A193-2FFD81FDB69C}"/>
+                <a16:creationId xmlns:a16="http://schemas.microsoft.com/office/drawing/2014/main" id="{BEB495D2-332D-4392-8CB3-EE8D5D113584}"/>
               </a:ext>
             </a:extLst>
           </p:cNvPr>
@@ -13558,7 +13558,7 @@
           <p:cNvPr id="19" name="">
             <a:extLst xmlns:a="http://schemas.openxmlformats.org/drawingml/2006/main">
               <a:ext uri="{FF2B5EF4-FFF2-40B4-BE49-F238E27FC236}">
-                <a16:creationId xmlns:a16="http://schemas.microsoft.com/office/drawing/2014/main" id="{EF882CA4-3106-49A8-B4F6-D691038CB6E6}"/>
+                <a16:creationId xmlns:a16="http://schemas.microsoft.com/office/drawing/2014/main" id="{5D2A034C-7129-48BE-94FD-DA56FB61DAF0}"/>
               </a:ext>
             </a:extLst>
           </p:cNvPr>
@@ -13593,7 +13593,7 @@
           <p:cNvPr id="20" name="">
             <a:extLst xmlns:a="http://schemas.openxmlformats.org/drawingml/2006/main">
               <a:ext uri="{FF2B5EF4-FFF2-40B4-BE49-F238E27FC236}">
-                <a16:creationId xmlns:a16="http://schemas.microsoft.com/office/drawing/2014/main" id="{5DFFD531-41BD-4F0F-9D63-A89A45F48965}"/>
+                <a16:creationId xmlns:a16="http://schemas.microsoft.com/office/drawing/2014/main" id="{0482AE7A-F476-4ED7-BFF2-BBD0E8BC623A}"/>
               </a:ext>
             </a:extLst>
           </p:cNvPr>
@@ -13626,7 +13626,7 @@
           <p:cNvPr id="21" name="">
             <a:extLst xmlns:a="http://schemas.openxmlformats.org/drawingml/2006/main">
               <a:ext uri="{FF2B5EF4-FFF2-40B4-BE49-F238E27FC236}">
-                <a16:creationId xmlns:a16="http://schemas.microsoft.com/office/drawing/2014/main" id="{6747E2DC-5873-4009-BBF7-CCB1E93EF391}"/>
+                <a16:creationId xmlns:a16="http://schemas.microsoft.com/office/drawing/2014/main" id="{17B6CE6F-D576-4449-9EC7-FDB421A769DD}"/>
               </a:ext>
             </a:extLst>
           </p:cNvPr>
@@ -13676,7 +13676,7 @@
           <p:cNvPr id="22" name="">
             <a:extLst xmlns:a="http://schemas.openxmlformats.org/drawingml/2006/main">
               <a:ext uri="{FF2B5EF4-FFF2-40B4-BE49-F238E27FC236}">
-                <a16:creationId xmlns:a16="http://schemas.microsoft.com/office/drawing/2014/main" id="{604312EC-5C36-423D-A909-BA1AA83035A6}"/>
+                <a16:creationId xmlns:a16="http://schemas.microsoft.com/office/drawing/2014/main" id="{8BAE05A9-35C1-4232-92E8-825616277807}"/>
               </a:ext>
             </a:extLst>
           </p:cNvPr>
@@ -13714,7 +13714,7 @@
           <p:cNvPr id="23" name="">
             <a:extLst xmlns:a="http://schemas.openxmlformats.org/drawingml/2006/main">
               <a:ext uri="{FF2B5EF4-FFF2-40B4-BE49-F238E27FC236}">
-                <a16:creationId xmlns:a16="http://schemas.microsoft.com/office/drawing/2014/main" id="{839A903A-6F37-4FDD-9452-BABF8775855F}"/>
+                <a16:creationId xmlns:a16="http://schemas.microsoft.com/office/drawing/2014/main" id="{B42015EA-2FC5-4677-94C1-30F425776D93}"/>
               </a:ext>
             </a:extLst>
           </p:cNvPr>
@@ -13745,7 +13745,7 @@
           <p:cNvPr id="24" name="">
             <a:extLst xmlns:a="http://schemas.openxmlformats.org/drawingml/2006/main">
               <a:ext uri="{FF2B5EF4-FFF2-40B4-BE49-F238E27FC236}">
-                <a16:creationId xmlns:a16="http://schemas.microsoft.com/office/drawing/2014/main" id="{7730491F-8149-4293-9593-A452B6431721}"/>
+                <a16:creationId xmlns:a16="http://schemas.microsoft.com/office/drawing/2014/main" id="{B5B25A50-46B1-4419-8F25-E65AA1DC9024}"/>
               </a:ext>
             </a:extLst>
           </p:cNvPr>
@@ -13795,7 +13795,7 @@
           <p:cNvPr id="25" name="">
             <a:extLst xmlns:a="http://schemas.openxmlformats.org/drawingml/2006/main">
               <a:ext uri="{FF2B5EF4-FFF2-40B4-BE49-F238E27FC236}">
-                <a16:creationId xmlns:a16="http://schemas.microsoft.com/office/drawing/2014/main" id="{C60E1458-11AC-4D93-BB4A-66B0944CF499}"/>
+                <a16:creationId xmlns:a16="http://schemas.microsoft.com/office/drawing/2014/main" id="{8CFCDD95-7012-45D9-92ED-689ED0495789}"/>
               </a:ext>
             </a:extLst>
           </p:cNvPr>
@@ -13826,7 +13826,7 @@
           <p:cNvPr id="26" name="">
             <a:extLst xmlns:a="http://schemas.openxmlformats.org/drawingml/2006/main">
               <a:ext uri="{FF2B5EF4-FFF2-40B4-BE49-F238E27FC236}">
-                <a16:creationId xmlns:a16="http://schemas.microsoft.com/office/drawing/2014/main" id="{6BCD9676-96F2-44E7-924E-B7B0A8B9F5FD}"/>
+                <a16:creationId xmlns:a16="http://schemas.microsoft.com/office/drawing/2014/main" id="{5D2D218F-FE4A-4718-95BA-26408082845E}"/>
               </a:ext>
             </a:extLst>
           </p:cNvPr>
@@ -13876,7 +13876,7 @@
           <p:cNvPr id="27" name="">
             <a:extLst xmlns:a="http://schemas.openxmlformats.org/drawingml/2006/main">
               <a:ext uri="{FF2B5EF4-FFF2-40B4-BE49-F238E27FC236}">
-                <a16:creationId xmlns:a16="http://schemas.microsoft.com/office/drawing/2014/main" id="{1959E1F5-44B3-4849-8E91-21FAFC07DC08}"/>
+                <a16:creationId xmlns:a16="http://schemas.microsoft.com/office/drawing/2014/main" id="{F5B0413A-3ADA-455F-906D-4A0587F9B64B}"/>
               </a:ext>
             </a:extLst>
           </p:cNvPr>
@@ -13907,7 +13907,7 @@
           <p:cNvPr id="28" name="">
             <a:extLst xmlns:a="http://schemas.openxmlformats.org/drawingml/2006/main">
               <a:ext uri="{FF2B5EF4-FFF2-40B4-BE49-F238E27FC236}">
-                <a16:creationId xmlns:a16="http://schemas.microsoft.com/office/drawing/2014/main" id="{7C675C51-F823-408A-B6C0-DEF59AFDF128}"/>
+                <a16:creationId xmlns:a16="http://schemas.microsoft.com/office/drawing/2014/main" id="{40B35D3C-83B1-4701-86C0-9BA77B3C8E7B}"/>
               </a:ext>
             </a:extLst>
           </p:cNvPr>
@@ -13957,7 +13957,7 @@
           <p:cNvPr id="29" name="">
             <a:extLst xmlns:a="http://schemas.openxmlformats.org/drawingml/2006/main">
               <a:ext uri="{FF2B5EF4-FFF2-40B4-BE49-F238E27FC236}">
-                <a16:creationId xmlns:a16="http://schemas.microsoft.com/office/drawing/2014/main" id="{EEB68F2F-725D-4A75-901B-94A6DC8566CD}"/>
+                <a16:creationId xmlns:a16="http://schemas.microsoft.com/office/drawing/2014/main" id="{81742129-578D-48C8-B09F-09CACB0EFFCE}"/>
               </a:ext>
             </a:extLst>
           </p:cNvPr>
@@ -13992,7 +13992,7 @@
           <p:cNvPr id="30" name="">
             <a:extLst xmlns:a="http://schemas.openxmlformats.org/drawingml/2006/main">
               <a:ext uri="{FF2B5EF4-FFF2-40B4-BE49-F238E27FC236}">
-                <a16:creationId xmlns:a16="http://schemas.microsoft.com/office/drawing/2014/main" id="{BE2C6E13-E8B2-4FD6-A9DE-CAA0772B2459}"/>
+                <a16:creationId xmlns:a16="http://schemas.microsoft.com/office/drawing/2014/main" id="{3775AD5D-5F2C-4DCC-87ED-CE724F63B2DD}"/>
               </a:ext>
             </a:extLst>
           </p:cNvPr>
@@ -14025,7 +14025,7 @@
           <p:cNvPr id="31" name="">
             <a:extLst xmlns:a="http://schemas.openxmlformats.org/drawingml/2006/main">
               <a:ext uri="{FF2B5EF4-FFF2-40B4-BE49-F238E27FC236}">
-                <a16:creationId xmlns:a16="http://schemas.microsoft.com/office/drawing/2014/main" id="{FBB4B028-9BF8-4003-BFFC-6A913D390611}"/>
+                <a16:creationId xmlns:a16="http://schemas.microsoft.com/office/drawing/2014/main" id="{9EDC07EB-FBD9-4BDF-8E05-17D7BEB8515A}"/>
               </a:ext>
             </a:extLst>
           </p:cNvPr>
@@ -14075,7 +14075,7 @@
           <p:cNvPr id="32" name="">
             <a:extLst xmlns:a="http://schemas.openxmlformats.org/drawingml/2006/main">
               <a:ext uri="{FF2B5EF4-FFF2-40B4-BE49-F238E27FC236}">
-                <a16:creationId xmlns:a16="http://schemas.microsoft.com/office/drawing/2014/main" id="{19BDEDB3-9E73-41FE-8CCB-7E8C948B636B}"/>
+                <a16:creationId xmlns:a16="http://schemas.microsoft.com/office/drawing/2014/main" id="{ADF6A264-E1C8-4F7B-8333-F15E1B187BF7}"/>
               </a:ext>
             </a:extLst>
           </p:cNvPr>
@@ -14113,7 +14113,7 @@
           <p:cNvPr id="33" name="">
             <a:extLst xmlns:a="http://schemas.openxmlformats.org/drawingml/2006/main">
               <a:ext uri="{FF2B5EF4-FFF2-40B4-BE49-F238E27FC236}">
-                <a16:creationId xmlns:a16="http://schemas.microsoft.com/office/drawing/2014/main" id="{3CE2C664-D552-488D-A5CF-166C0334D1B1}"/>
+                <a16:creationId xmlns:a16="http://schemas.microsoft.com/office/drawing/2014/main" id="{0F6C13F6-DCB4-4320-83EB-1A28C542311B}"/>
               </a:ext>
             </a:extLst>
           </p:cNvPr>
@@ -14144,7 +14144,7 @@
           <p:cNvPr id="34" name="">
             <a:extLst xmlns:a="http://schemas.openxmlformats.org/drawingml/2006/main">
               <a:ext uri="{FF2B5EF4-FFF2-40B4-BE49-F238E27FC236}">
-                <a16:creationId xmlns:a16="http://schemas.microsoft.com/office/drawing/2014/main" id="{3EFAD390-4024-42CC-8C7B-97DA4DAAF648}"/>
+                <a16:creationId xmlns:a16="http://schemas.microsoft.com/office/drawing/2014/main" id="{C36F35CB-7B5A-4436-8CA4-B5CF047A56BA}"/>
               </a:ext>
             </a:extLst>
           </p:cNvPr>
@@ -14194,7 +14194,7 @@
           <p:cNvPr id="35" name="">
             <a:extLst xmlns:a="http://schemas.openxmlformats.org/drawingml/2006/main">
               <a:ext uri="{FF2B5EF4-FFF2-40B4-BE49-F238E27FC236}">
-                <a16:creationId xmlns:a16="http://schemas.microsoft.com/office/drawing/2014/main" id="{CC07E6AD-E047-4FE9-8072-C54FE97D9CE3}"/>
+                <a16:creationId xmlns:a16="http://schemas.microsoft.com/office/drawing/2014/main" id="{262F294E-0BC9-4323-94B1-5F737ABBF2DF}"/>
               </a:ext>
             </a:extLst>
           </p:cNvPr>
@@ -14225,7 +14225,7 @@
           <p:cNvPr id="36" name="">
             <a:extLst xmlns:a="http://schemas.openxmlformats.org/drawingml/2006/main">
               <a:ext uri="{FF2B5EF4-FFF2-40B4-BE49-F238E27FC236}">
-                <a16:creationId xmlns:a16="http://schemas.microsoft.com/office/drawing/2014/main" id="{B6A65BE2-8571-48A1-B89A-00036D2E4B31}"/>
+                <a16:creationId xmlns:a16="http://schemas.microsoft.com/office/drawing/2014/main" id="{BF273B32-1D2E-49D9-B4E1-6E3C975C693E}"/>
               </a:ext>
             </a:extLst>
           </p:cNvPr>
@@ -14275,7 +14275,7 @@
           <p:cNvPr id="37" name="">
             <a:extLst xmlns:a="http://schemas.openxmlformats.org/drawingml/2006/main">
               <a:ext uri="{FF2B5EF4-FFF2-40B4-BE49-F238E27FC236}">
-                <a16:creationId xmlns:a16="http://schemas.microsoft.com/office/drawing/2014/main" id="{DD2840D9-B0B0-49E6-8E84-DAAB06A90A67}"/>
+                <a16:creationId xmlns:a16="http://schemas.microsoft.com/office/drawing/2014/main" id="{B88CD47A-385E-4CB5-836A-13325A7BA6E1}"/>
               </a:ext>
             </a:extLst>
           </p:cNvPr>
@@ -14306,7 +14306,7 @@
           <p:cNvPr id="38" name="">
             <a:extLst xmlns:a="http://schemas.openxmlformats.org/drawingml/2006/main">
               <a:ext uri="{FF2B5EF4-FFF2-40B4-BE49-F238E27FC236}">
-                <a16:creationId xmlns:a16="http://schemas.microsoft.com/office/drawing/2014/main" id="{31B22A00-C493-4511-8887-EAAB941C209E}"/>
+                <a16:creationId xmlns:a16="http://schemas.microsoft.com/office/drawing/2014/main" id="{217968BC-441E-4C65-ABEE-124C9603DB40}"/>
               </a:ext>
             </a:extLst>
           </p:cNvPr>
@@ -14354,7 +14354,7 @@
     </p:spTree>
     <p:extLst>
       <p:ext uri="{BB962C8B-B14F-4D97-AF65-F5344CB8AC3E}">
-        <p14:creationId xmlns:p14="http://schemas.microsoft.com/office/powerpoint/2010/main" val="174591958"/>
+        <p14:creationId xmlns:p14="http://schemas.microsoft.com/office/powerpoint/2010/main" val="2035269649"/>
       </p:ext>
     </p:extLst>
   </p:cSld>
@@ -14385,7 +14385,7 @@
           <p:cNvPr id="1" name="">
             <a:extLst xmlns:a="http://schemas.openxmlformats.org/drawingml/2006/main">
               <a:ext uri="{FF2B5EF4-FFF2-40B4-BE49-F238E27FC236}">
-                <a16:creationId xmlns:a16="http://schemas.microsoft.com/office/drawing/2014/main" id="{9DFF490E-37F9-4239-A60E-2E8885BEB7B6}"/>
+                <a16:creationId xmlns:a16="http://schemas.microsoft.com/office/drawing/2014/main" id="{1648370B-630E-4EB1-B656-0D35698B19DF}"/>
               </a:ext>
             </a:extLst>
           </p:cNvPr>
@@ -14439,7 +14439,7 @@
           <p:cNvPr id="2" name="">
             <a:extLst xmlns:a="http://schemas.openxmlformats.org/drawingml/2006/main">
               <a:ext uri="{FF2B5EF4-FFF2-40B4-BE49-F238E27FC236}">
-                <a16:creationId xmlns:a16="http://schemas.microsoft.com/office/drawing/2014/main" id="{6765457F-0D76-409C-88FB-35ADE5F4332E}"/>
+                <a16:creationId xmlns:a16="http://schemas.microsoft.com/office/drawing/2014/main" id="{4B3EF5AA-7848-49CA-B868-5D8FB8CDE551}"/>
               </a:ext>
             </a:extLst>
           </p:cNvPr>
@@ -14470,7 +14470,7 @@
           <p:cNvPr id="3" name="">
             <a:extLst xmlns:a="http://schemas.openxmlformats.org/drawingml/2006/main">
               <a:ext uri="{FF2B5EF4-FFF2-40B4-BE49-F238E27FC236}">
-                <a16:creationId xmlns:a16="http://schemas.microsoft.com/office/drawing/2014/main" id="{44152C5E-0256-4666-A613-62E5C401E615}"/>
+                <a16:creationId xmlns:a16="http://schemas.microsoft.com/office/drawing/2014/main" id="{1347E7C0-74F3-4817-9661-6D0FA593FE20}"/>
               </a:ext>
             </a:extLst>
           </p:cNvPr>
@@ -14520,7 +14520,7 @@
           <p:cNvPr id="4" name="">
             <a:extLst xmlns:a="http://schemas.openxmlformats.org/drawingml/2006/main">
               <a:ext uri="{FF2B5EF4-FFF2-40B4-BE49-F238E27FC236}">
-                <a16:creationId xmlns:a16="http://schemas.microsoft.com/office/drawing/2014/main" id="{D83BABC6-ECD7-460C-8C7D-B4A9C6395B23}"/>
+                <a16:creationId xmlns:a16="http://schemas.microsoft.com/office/drawing/2014/main" id="{9FD3741F-44E9-444D-B8A7-17F6E0037AA0}"/>
               </a:ext>
             </a:extLst>
           </p:cNvPr>
@@ -14570,7 +14570,7 @@
           <p:cNvPr id="5" name="">
             <a:extLst xmlns:a="http://schemas.openxmlformats.org/drawingml/2006/main">
               <a:ext uri="{FF2B5EF4-FFF2-40B4-BE49-F238E27FC236}">
-                <a16:creationId xmlns:a16="http://schemas.microsoft.com/office/drawing/2014/main" id="{D48860E8-872D-4292-A5C4-F8058CF1C46E}"/>
+                <a16:creationId xmlns:a16="http://schemas.microsoft.com/office/drawing/2014/main" id="{B14FE32B-4D26-468C-96A9-4D3448C8EBC4}"/>
               </a:ext>
             </a:extLst>
           </p:cNvPr>
@@ -14620,7 +14620,7 @@
           <p:cNvPr id="6" name="">
             <a:extLst xmlns:a="http://schemas.openxmlformats.org/drawingml/2006/main">
               <a:ext uri="{FF2B5EF4-FFF2-40B4-BE49-F238E27FC236}">
-                <a16:creationId xmlns:a16="http://schemas.microsoft.com/office/drawing/2014/main" id="{0EA42927-1F32-42CE-8D3F-D4228269A008}"/>
+                <a16:creationId xmlns:a16="http://schemas.microsoft.com/office/drawing/2014/main" id="{B5E5FEAA-6A73-4D76-B424-319A3FBFF903}"/>
               </a:ext>
             </a:extLst>
           </p:cNvPr>
@@ -14655,7 +14655,7 @@
           <p:cNvPr id="7" name="">
             <a:extLst xmlns:a="http://schemas.openxmlformats.org/drawingml/2006/main">
               <a:ext uri="{FF2B5EF4-FFF2-40B4-BE49-F238E27FC236}">
-                <a16:creationId xmlns:a16="http://schemas.microsoft.com/office/drawing/2014/main" id="{06719717-6A54-49AD-8941-74A365E2A23B}"/>
+                <a16:creationId xmlns:a16="http://schemas.microsoft.com/office/drawing/2014/main" id="{99A62715-BEB8-46BF-A2AA-74AE3B606379}"/>
               </a:ext>
             </a:extLst>
           </p:cNvPr>
@@ -14705,7 +14705,7 @@
           <p:cNvPr id="8" name="">
             <a:extLst xmlns:a="http://schemas.openxmlformats.org/drawingml/2006/main">
               <a:ext uri="{FF2B5EF4-FFF2-40B4-BE49-F238E27FC236}">
-                <a16:creationId xmlns:a16="http://schemas.microsoft.com/office/drawing/2014/main" id="{C26943F1-6928-43CC-9BFE-61A96D1544B0}"/>
+                <a16:creationId xmlns:a16="http://schemas.microsoft.com/office/drawing/2014/main" id="{08CC2173-89F4-470A-A98E-D1BB32426DE6}"/>
               </a:ext>
             </a:extLst>
           </p:cNvPr>
@@ -14755,7 +14755,7 @@
           <p:cNvPr id="9" name="">
             <a:extLst xmlns:a="http://schemas.openxmlformats.org/drawingml/2006/main">
               <a:ext uri="{FF2B5EF4-FFF2-40B4-BE49-F238E27FC236}">
-                <a16:creationId xmlns:a16="http://schemas.microsoft.com/office/drawing/2014/main" id="{827941DA-C0C5-4CD9-BFFA-45FD4A22C8A8}"/>
+                <a16:creationId xmlns:a16="http://schemas.microsoft.com/office/drawing/2014/main" id="{3FB31934-5A71-424D-9B8B-082366D3C60A}"/>
               </a:ext>
             </a:extLst>
           </p:cNvPr>
@@ -14790,7 +14790,7 @@
           <p:cNvPr id="10" name="">
             <a:extLst xmlns:a="http://schemas.openxmlformats.org/drawingml/2006/main">
               <a:ext uri="{FF2B5EF4-FFF2-40B4-BE49-F238E27FC236}">
-                <a16:creationId xmlns:a16="http://schemas.microsoft.com/office/drawing/2014/main" id="{694DEF71-E05C-4DBD-919B-301DD9B747BA}"/>
+                <a16:creationId xmlns:a16="http://schemas.microsoft.com/office/drawing/2014/main" id="{9D43C52A-6B52-4626-96DB-428AAD51E899}"/>
               </a:ext>
             </a:extLst>
           </p:cNvPr>
@@ -14840,7 +14840,7 @@
           <p:cNvPr id="11" name="">
             <a:extLst xmlns:a="http://schemas.openxmlformats.org/drawingml/2006/main">
               <a:ext uri="{FF2B5EF4-FFF2-40B4-BE49-F238E27FC236}">
-                <a16:creationId xmlns:a16="http://schemas.microsoft.com/office/drawing/2014/main" id="{FC61C4F6-C4C9-4E50-8F18-9D8A59DC1C0E}"/>
+                <a16:creationId xmlns:a16="http://schemas.microsoft.com/office/drawing/2014/main" id="{A515BA53-CAE9-4CD6-9160-B1191CD31EF4}"/>
               </a:ext>
             </a:extLst>
           </p:cNvPr>
@@ -14890,7 +14890,7 @@
           <p:cNvPr id="12" name="">
             <a:extLst xmlns:a="http://schemas.openxmlformats.org/drawingml/2006/main">
               <a:ext uri="{FF2B5EF4-FFF2-40B4-BE49-F238E27FC236}">
-                <a16:creationId xmlns:a16="http://schemas.microsoft.com/office/drawing/2014/main" id="{AD32190B-214C-4742-B8A3-0D69E0B5BE81}"/>
+                <a16:creationId xmlns:a16="http://schemas.microsoft.com/office/drawing/2014/main" id="{7FB1223E-033E-4B30-939C-40E5FCE1C719}"/>
               </a:ext>
             </a:extLst>
           </p:cNvPr>
@@ -14925,7 +14925,7 @@
           <p:cNvPr id="13" name="">
             <a:extLst xmlns:a="http://schemas.openxmlformats.org/drawingml/2006/main">
               <a:ext uri="{FF2B5EF4-FFF2-40B4-BE49-F238E27FC236}">
-                <a16:creationId xmlns:a16="http://schemas.microsoft.com/office/drawing/2014/main" id="{6DA29591-1738-4597-A087-63B780BAEFBF}"/>
+                <a16:creationId xmlns:a16="http://schemas.microsoft.com/office/drawing/2014/main" id="{638B6BBC-698C-412B-BCE0-A0B94F589DBB}"/>
               </a:ext>
             </a:extLst>
           </p:cNvPr>
@@ -14975,7 +14975,7 @@
           <p:cNvPr id="14" name="">
             <a:extLst xmlns:a="http://schemas.openxmlformats.org/drawingml/2006/main">
               <a:ext uri="{FF2B5EF4-FFF2-40B4-BE49-F238E27FC236}">
-                <a16:creationId xmlns:a16="http://schemas.microsoft.com/office/drawing/2014/main" id="{95C72279-EF92-49A0-AA56-4CF5C18A6831}"/>
+                <a16:creationId xmlns:a16="http://schemas.microsoft.com/office/drawing/2014/main" id="{0784390F-6109-431A-95B2-89F15168AE9F}"/>
               </a:ext>
             </a:extLst>
           </p:cNvPr>
@@ -15025,7 +15025,7 @@
           <p:cNvPr id="15" name="">
             <a:extLst xmlns:a="http://schemas.openxmlformats.org/drawingml/2006/main">
               <a:ext uri="{FF2B5EF4-FFF2-40B4-BE49-F238E27FC236}">
-                <a16:creationId xmlns:a16="http://schemas.microsoft.com/office/drawing/2014/main" id="{F9B34F91-5970-4DAE-BB44-217361F59594}"/>
+                <a16:creationId xmlns:a16="http://schemas.microsoft.com/office/drawing/2014/main" id="{411DE085-A21D-4C1E-AA86-D7A74AAAA6FD}"/>
               </a:ext>
             </a:extLst>
           </p:cNvPr>
@@ -15060,7 +15060,7 @@
           <p:cNvPr id="16" name="">
             <a:extLst xmlns:a="http://schemas.openxmlformats.org/drawingml/2006/main">
               <a:ext uri="{FF2B5EF4-FFF2-40B4-BE49-F238E27FC236}">
-                <a16:creationId xmlns:a16="http://schemas.microsoft.com/office/drawing/2014/main" id="{084DBD1E-DABD-45F2-AF00-A41D5188CECA}"/>
+                <a16:creationId xmlns:a16="http://schemas.microsoft.com/office/drawing/2014/main" id="{EAC6AF74-1764-4E3B-8E6D-45470436E068}"/>
               </a:ext>
             </a:extLst>
           </p:cNvPr>
@@ -15093,7 +15093,7 @@
           <p:cNvPr id="17" name="">
             <a:extLst xmlns:a="http://schemas.openxmlformats.org/drawingml/2006/main">
               <a:ext uri="{FF2B5EF4-FFF2-40B4-BE49-F238E27FC236}">
-                <a16:creationId xmlns:a16="http://schemas.microsoft.com/office/drawing/2014/main" id="{7A700BAE-3895-466D-A3F5-B58944BD1BC4}"/>
+                <a16:creationId xmlns:a16="http://schemas.microsoft.com/office/drawing/2014/main" id="{954FEC7A-39ED-4CB6-A7C5-00D976B64B62}"/>
               </a:ext>
             </a:extLst>
           </p:cNvPr>
@@ -15143,7 +15143,7 @@
           <p:cNvPr id="18" name="">
             <a:extLst xmlns:a="http://schemas.openxmlformats.org/drawingml/2006/main">
               <a:ext uri="{FF2B5EF4-FFF2-40B4-BE49-F238E27FC236}">
-                <a16:creationId xmlns:a16="http://schemas.microsoft.com/office/drawing/2014/main" id="{9A652BAE-560F-47BE-9203-AA851F39B313}"/>
+                <a16:creationId xmlns:a16="http://schemas.microsoft.com/office/drawing/2014/main" id="{DDF72364-5945-4581-ABCE-0E8CFEE4015B}"/>
               </a:ext>
             </a:extLst>
           </p:cNvPr>
@@ -15193,7 +15193,7 @@
           <p:cNvPr id="19" name="">
             <a:extLst xmlns:a="http://schemas.openxmlformats.org/drawingml/2006/main">
               <a:ext uri="{FF2B5EF4-FFF2-40B4-BE49-F238E27FC236}">
-                <a16:creationId xmlns:a16="http://schemas.microsoft.com/office/drawing/2014/main" id="{493BE628-3467-4722-8F0B-6B1AC424893A}"/>
+                <a16:creationId xmlns:a16="http://schemas.microsoft.com/office/drawing/2014/main" id="{31429C0C-1118-4744-8BC9-EE73501FCF2C}"/>
               </a:ext>
             </a:extLst>
           </p:cNvPr>
@@ -15228,7 +15228,7 @@
           <p:cNvPr id="20" name="">
             <a:extLst xmlns:a="http://schemas.openxmlformats.org/drawingml/2006/main">
               <a:ext uri="{FF2B5EF4-FFF2-40B4-BE49-F238E27FC236}">
-                <a16:creationId xmlns:a16="http://schemas.microsoft.com/office/drawing/2014/main" id="{0F456D70-7C86-4B6E-B020-78FACF6FFD5F}"/>
+                <a16:creationId xmlns:a16="http://schemas.microsoft.com/office/drawing/2014/main" id="{EF751E65-C051-48A3-A2B0-17438A4507EC}"/>
               </a:ext>
             </a:extLst>
           </p:cNvPr>
@@ -15261,7 +15261,7 @@
           <p:cNvPr id="21" name="">
             <a:extLst xmlns:a="http://schemas.openxmlformats.org/drawingml/2006/main">
               <a:ext uri="{FF2B5EF4-FFF2-40B4-BE49-F238E27FC236}">
-                <a16:creationId xmlns:a16="http://schemas.microsoft.com/office/drawing/2014/main" id="{D412D5CB-94EC-46CF-8D6E-F2635E916FFA}"/>
+                <a16:creationId xmlns:a16="http://schemas.microsoft.com/office/drawing/2014/main" id="{3940A663-67D9-4259-8D32-AE54124B4854}"/>
               </a:ext>
             </a:extLst>
           </p:cNvPr>
@@ -15311,7 +15311,7 @@
           <p:cNvPr id="22" name="">
             <a:extLst xmlns:a="http://schemas.openxmlformats.org/drawingml/2006/main">
               <a:ext uri="{FF2B5EF4-FFF2-40B4-BE49-F238E27FC236}">
-                <a16:creationId xmlns:a16="http://schemas.microsoft.com/office/drawing/2014/main" id="{3DBCF23A-88FF-4AB8-A02B-8BACE1E4D099}"/>
+                <a16:creationId xmlns:a16="http://schemas.microsoft.com/office/drawing/2014/main" id="{0C2B93B4-B545-4501-AEB9-3F8DE8B67A15}"/>
               </a:ext>
             </a:extLst>
           </p:cNvPr>
@@ -15349,7 +15349,7 @@
           <p:cNvPr id="23" name="">
             <a:extLst xmlns:a="http://schemas.openxmlformats.org/drawingml/2006/main">
               <a:ext uri="{FF2B5EF4-FFF2-40B4-BE49-F238E27FC236}">
-                <a16:creationId xmlns:a16="http://schemas.microsoft.com/office/drawing/2014/main" id="{8DE53B08-8B00-4137-A692-D155FBE0E50B}"/>
+                <a16:creationId xmlns:a16="http://schemas.microsoft.com/office/drawing/2014/main" id="{BB28AA97-5DE5-4212-B844-B191B1785371}"/>
               </a:ext>
             </a:extLst>
           </p:cNvPr>
@@ -15380,7 +15380,7 @@
           <p:cNvPr id="24" name="">
             <a:extLst xmlns:a="http://schemas.openxmlformats.org/drawingml/2006/main">
               <a:ext uri="{FF2B5EF4-FFF2-40B4-BE49-F238E27FC236}">
-                <a16:creationId xmlns:a16="http://schemas.microsoft.com/office/drawing/2014/main" id="{245B5B9E-6F2B-4523-BA01-496FCB1BD823}"/>
+                <a16:creationId xmlns:a16="http://schemas.microsoft.com/office/drawing/2014/main" id="{FDF44A53-973F-41B2-A627-2ED10A356E4C}"/>
               </a:ext>
             </a:extLst>
           </p:cNvPr>
@@ -15430,7 +15430,7 @@
           <p:cNvPr id="25" name="">
             <a:extLst xmlns:a="http://schemas.openxmlformats.org/drawingml/2006/main">
               <a:ext uri="{FF2B5EF4-FFF2-40B4-BE49-F238E27FC236}">
-                <a16:creationId xmlns:a16="http://schemas.microsoft.com/office/drawing/2014/main" id="{012EDEE8-5A24-46C3-A41A-CBF5609288D0}"/>
+                <a16:creationId xmlns:a16="http://schemas.microsoft.com/office/drawing/2014/main" id="{F66D1378-90BB-40EB-9AAF-DE0993C9FABA}"/>
               </a:ext>
             </a:extLst>
           </p:cNvPr>
@@ -15461,7 +15461,7 @@
           <p:cNvPr id="26" name="">
             <a:extLst xmlns:a="http://schemas.openxmlformats.org/drawingml/2006/main">
               <a:ext uri="{FF2B5EF4-FFF2-40B4-BE49-F238E27FC236}">
-                <a16:creationId xmlns:a16="http://schemas.microsoft.com/office/drawing/2014/main" id="{2F21668B-CA0C-47C0-9795-F3650318EB60}"/>
+                <a16:creationId xmlns:a16="http://schemas.microsoft.com/office/drawing/2014/main" id="{FDB8CB6B-2A4D-4B22-8CDB-7E0AEC83CF5C}"/>
               </a:ext>
             </a:extLst>
           </p:cNvPr>
@@ -15511,7 +15511,7 @@
           <p:cNvPr id="27" name="">
             <a:extLst xmlns:a="http://schemas.openxmlformats.org/drawingml/2006/main">
               <a:ext uri="{FF2B5EF4-FFF2-40B4-BE49-F238E27FC236}">
-                <a16:creationId xmlns:a16="http://schemas.microsoft.com/office/drawing/2014/main" id="{845EA266-65F1-4D32-89B5-E34DA7A5D1EC}"/>
+                <a16:creationId xmlns:a16="http://schemas.microsoft.com/office/drawing/2014/main" id="{A7DF3257-F9C9-4EA5-8681-604D003349C2}"/>
               </a:ext>
             </a:extLst>
           </p:cNvPr>
@@ -15542,7 +15542,7 @@
           <p:cNvPr id="28" name="">
             <a:extLst xmlns:a="http://schemas.openxmlformats.org/drawingml/2006/main">
               <a:ext uri="{FF2B5EF4-FFF2-40B4-BE49-F238E27FC236}">
-                <a16:creationId xmlns:a16="http://schemas.microsoft.com/office/drawing/2014/main" id="{05B0483B-B6EF-4DD1-A708-3E3B8BD86697}"/>
+                <a16:creationId xmlns:a16="http://schemas.microsoft.com/office/drawing/2014/main" id="{C7664793-2A9E-430B-8F2A-E80644758702}"/>
               </a:ext>
             </a:extLst>
           </p:cNvPr>
@@ -15592,7 +15592,7 @@
           <p:cNvPr id="29" name="">
             <a:extLst xmlns:a="http://schemas.openxmlformats.org/drawingml/2006/main">
               <a:ext uri="{FF2B5EF4-FFF2-40B4-BE49-F238E27FC236}">
-                <a16:creationId xmlns:a16="http://schemas.microsoft.com/office/drawing/2014/main" id="{5D076A71-D156-4019-9B84-25303B38D7BF}"/>
+                <a16:creationId xmlns:a16="http://schemas.microsoft.com/office/drawing/2014/main" id="{050720A4-D300-4019-933A-C9191A1A6772}"/>
               </a:ext>
             </a:extLst>
           </p:cNvPr>
@@ -15627,7 +15627,7 @@
           <p:cNvPr id="30" name="">
             <a:extLst xmlns:a="http://schemas.openxmlformats.org/drawingml/2006/main">
               <a:ext uri="{FF2B5EF4-FFF2-40B4-BE49-F238E27FC236}">
-                <a16:creationId xmlns:a16="http://schemas.microsoft.com/office/drawing/2014/main" id="{5024FE6D-7875-4E03-953D-39E7FFF4AF09}"/>
+                <a16:creationId xmlns:a16="http://schemas.microsoft.com/office/drawing/2014/main" id="{E48B8D77-1D2A-4A38-BDD8-5D1DD8C076EF}"/>
               </a:ext>
             </a:extLst>
           </p:cNvPr>
@@ -15660,7 +15660,7 @@
           <p:cNvPr id="31" name="">
             <a:extLst xmlns:a="http://schemas.openxmlformats.org/drawingml/2006/main">
               <a:ext uri="{FF2B5EF4-FFF2-40B4-BE49-F238E27FC236}">
-                <a16:creationId xmlns:a16="http://schemas.microsoft.com/office/drawing/2014/main" id="{93205E46-6BE7-4980-A4A8-D2FE2507F5D1}"/>
+                <a16:creationId xmlns:a16="http://schemas.microsoft.com/office/drawing/2014/main" id="{A22D4F80-F2CF-4233-988A-58462F8B392C}"/>
               </a:ext>
             </a:extLst>
           </p:cNvPr>
@@ -15710,7 +15710,7 @@
           <p:cNvPr id="32" name="">
             <a:extLst xmlns:a="http://schemas.openxmlformats.org/drawingml/2006/main">
               <a:ext uri="{FF2B5EF4-FFF2-40B4-BE49-F238E27FC236}">
-                <a16:creationId xmlns:a16="http://schemas.microsoft.com/office/drawing/2014/main" id="{BC20438D-2C2D-40E4-9613-C5E9F0845DD9}"/>
+                <a16:creationId xmlns:a16="http://schemas.microsoft.com/office/drawing/2014/main" id="{CA1CF97F-566C-4CE7-A4C8-718A60C36C38}"/>
               </a:ext>
             </a:extLst>
           </p:cNvPr>
@@ -15748,7 +15748,7 @@
           <p:cNvPr id="33" name="">
             <a:extLst xmlns:a="http://schemas.openxmlformats.org/drawingml/2006/main">
               <a:ext uri="{FF2B5EF4-FFF2-40B4-BE49-F238E27FC236}">
-                <a16:creationId xmlns:a16="http://schemas.microsoft.com/office/drawing/2014/main" id="{F41145D2-E44D-4F8C-A454-63A7B3ABAC42}"/>
+                <a16:creationId xmlns:a16="http://schemas.microsoft.com/office/drawing/2014/main" id="{98741F7D-A2B6-4392-B59A-84E0016AA2A5}"/>
               </a:ext>
             </a:extLst>
           </p:cNvPr>
@@ -15779,7 +15779,7 @@
           <p:cNvPr id="34" name="">
             <a:extLst xmlns:a="http://schemas.openxmlformats.org/drawingml/2006/main">
               <a:ext uri="{FF2B5EF4-FFF2-40B4-BE49-F238E27FC236}">
-                <a16:creationId xmlns:a16="http://schemas.microsoft.com/office/drawing/2014/main" id="{4C3D7CE9-A66E-4508-BB43-BAA73E6C20E7}"/>
+                <a16:creationId xmlns:a16="http://schemas.microsoft.com/office/drawing/2014/main" id="{057C8FD5-3CD7-401A-B6ED-1EFDDB333C8D}"/>
               </a:ext>
             </a:extLst>
           </p:cNvPr>
@@ -15829,7 +15829,7 @@
           <p:cNvPr id="35" name="">
             <a:extLst xmlns:a="http://schemas.openxmlformats.org/drawingml/2006/main">
               <a:ext uri="{FF2B5EF4-FFF2-40B4-BE49-F238E27FC236}">
-                <a16:creationId xmlns:a16="http://schemas.microsoft.com/office/drawing/2014/main" id="{D453EF3F-BCA0-4CC6-9DC5-F9EAF4C4D05F}"/>
+                <a16:creationId xmlns:a16="http://schemas.microsoft.com/office/drawing/2014/main" id="{F7DBF6AC-1269-42C3-8CA9-D6E013DFD5BB}"/>
               </a:ext>
             </a:extLst>
           </p:cNvPr>
@@ -15860,7 +15860,7 @@
           <p:cNvPr id="36" name="">
             <a:extLst xmlns:a="http://schemas.openxmlformats.org/drawingml/2006/main">
               <a:ext uri="{FF2B5EF4-FFF2-40B4-BE49-F238E27FC236}">
-                <a16:creationId xmlns:a16="http://schemas.microsoft.com/office/drawing/2014/main" id="{417DAA18-408F-443B-ACD0-E1AADFF6D6A0}"/>
+                <a16:creationId xmlns:a16="http://schemas.microsoft.com/office/drawing/2014/main" id="{DF37206F-7CFB-4278-8B67-2175E3AF1848}"/>
               </a:ext>
             </a:extLst>
           </p:cNvPr>
@@ -15910,7 +15910,7 @@
           <p:cNvPr id="37" name="">
             <a:extLst xmlns:a="http://schemas.openxmlformats.org/drawingml/2006/main">
               <a:ext uri="{FF2B5EF4-FFF2-40B4-BE49-F238E27FC236}">
-                <a16:creationId xmlns:a16="http://schemas.microsoft.com/office/drawing/2014/main" id="{35E10ABF-CD8B-43E0-BD4F-80F3D30447D4}"/>
+                <a16:creationId xmlns:a16="http://schemas.microsoft.com/office/drawing/2014/main" id="{7362DEFF-B602-4709-85D5-718E8EDE0C58}"/>
               </a:ext>
             </a:extLst>
           </p:cNvPr>
@@ -15941,7 +15941,7 @@
           <p:cNvPr id="38" name="">
             <a:extLst xmlns:a="http://schemas.openxmlformats.org/drawingml/2006/main">
               <a:ext uri="{FF2B5EF4-FFF2-40B4-BE49-F238E27FC236}">
-                <a16:creationId xmlns:a16="http://schemas.microsoft.com/office/drawing/2014/main" id="{273A594D-CE3F-489F-9FAD-24DB1C4C9E9A}"/>
+                <a16:creationId xmlns:a16="http://schemas.microsoft.com/office/drawing/2014/main" id="{012F5CF9-FCF2-4624-A478-F7A0335F1F15}"/>
               </a:ext>
             </a:extLst>
           </p:cNvPr>
@@ -15991,7 +15991,7 @@
           <p:cNvPr id="39" name="">
             <a:extLst xmlns:a="http://schemas.openxmlformats.org/drawingml/2006/main">
               <a:ext uri="{FF2B5EF4-FFF2-40B4-BE49-F238E27FC236}">
-                <a16:creationId xmlns:a16="http://schemas.microsoft.com/office/drawing/2014/main" id="{C749422C-DD8C-4CA2-8DB1-1DFE67934CE2}"/>
+                <a16:creationId xmlns:a16="http://schemas.microsoft.com/office/drawing/2014/main" id="{03DBC3E2-F507-405F-B709-037DCC48BCD8}"/>
               </a:ext>
             </a:extLst>
           </p:cNvPr>
@@ -16039,7 +16039,7 @@
     </p:spTree>
     <p:extLst>
       <p:ext uri="{BB962C8B-B14F-4D97-AF65-F5344CB8AC3E}">
-        <p14:creationId xmlns:p14="http://schemas.microsoft.com/office/powerpoint/2010/main" val="1151306365"/>
+        <p14:creationId xmlns:p14="http://schemas.microsoft.com/office/powerpoint/2010/main" val="1940590566"/>
       </p:ext>
     </p:extLst>
   </p:cSld>
@@ -16070,7 +16070,7 @@
           <p:cNvPr id="1" name="">
             <a:extLst xmlns:a="http://schemas.openxmlformats.org/drawingml/2006/main">
               <a:ext uri="{FF2B5EF4-FFF2-40B4-BE49-F238E27FC236}">
-                <a16:creationId xmlns:a16="http://schemas.microsoft.com/office/drawing/2014/main" id="{914E1D20-9B47-46EC-8419-E4BD51CCF375}"/>
+                <a16:creationId xmlns:a16="http://schemas.microsoft.com/office/drawing/2014/main" id="{6006B4BF-C18D-4828-AD10-59ECCB1FD967}"/>
               </a:ext>
             </a:extLst>
           </p:cNvPr>
@@ -16124,7 +16124,7 @@
           <p:cNvPr id="2" name="">
             <a:extLst xmlns:a="http://schemas.openxmlformats.org/drawingml/2006/main">
               <a:ext uri="{FF2B5EF4-FFF2-40B4-BE49-F238E27FC236}">
-                <a16:creationId xmlns:a16="http://schemas.microsoft.com/office/drawing/2014/main" id="{D4B59CC0-8960-4CF3-8952-842E1CB7BCB0}"/>
+                <a16:creationId xmlns:a16="http://schemas.microsoft.com/office/drawing/2014/main" id="{7E0CA799-2803-4B13-8936-A19658C05437}"/>
               </a:ext>
             </a:extLst>
           </p:cNvPr>
@@ -16155,7 +16155,7 @@
           <p:cNvPr id="3" name="">
             <a:extLst xmlns:a="http://schemas.openxmlformats.org/drawingml/2006/main">
               <a:ext uri="{FF2B5EF4-FFF2-40B4-BE49-F238E27FC236}">
-                <a16:creationId xmlns:a16="http://schemas.microsoft.com/office/drawing/2014/main" id="{FE2D8617-5F72-4382-A863-FE31D98BBDB2}"/>
+                <a16:creationId xmlns:a16="http://schemas.microsoft.com/office/drawing/2014/main" id="{69BE7D75-9B66-4355-8B72-B962C88DDC59}"/>
               </a:ext>
             </a:extLst>
           </p:cNvPr>
@@ -16205,7 +16205,7 @@
           <p:cNvPr id="4" name="">
             <a:extLst xmlns:a="http://schemas.openxmlformats.org/drawingml/2006/main">
               <a:ext uri="{FF2B5EF4-FFF2-40B4-BE49-F238E27FC236}">
-                <a16:creationId xmlns:a16="http://schemas.microsoft.com/office/drawing/2014/main" id="{E0CA0E1F-04ED-4751-B6F1-5051EBF67C5B}"/>
+                <a16:creationId xmlns:a16="http://schemas.microsoft.com/office/drawing/2014/main" id="{94B630AD-8196-4DE5-99C3-F0F1FBC7D5F1}"/>
               </a:ext>
             </a:extLst>
           </p:cNvPr>
@@ -16255,7 +16255,7 @@
           <p:cNvPr id="5" name="">
             <a:extLst xmlns:a="http://schemas.openxmlformats.org/drawingml/2006/main">
               <a:ext uri="{FF2B5EF4-FFF2-40B4-BE49-F238E27FC236}">
-                <a16:creationId xmlns:a16="http://schemas.microsoft.com/office/drawing/2014/main" id="{93B7AA6B-397B-4530-BF7C-8E0E7729F3A4}"/>
+                <a16:creationId xmlns:a16="http://schemas.microsoft.com/office/drawing/2014/main" id="{8AA58B73-EF9B-4C3F-9677-204343585346}"/>
               </a:ext>
             </a:extLst>
           </p:cNvPr>
@@ -16305,7 +16305,7 @@
           <p:cNvPr id="6" name="">
             <a:extLst xmlns:a="http://schemas.openxmlformats.org/drawingml/2006/main">
               <a:ext uri="{FF2B5EF4-FFF2-40B4-BE49-F238E27FC236}">
-                <a16:creationId xmlns:a16="http://schemas.microsoft.com/office/drawing/2014/main" id="{607617F2-8FB0-4B6D-93DB-F67D842D0F3F}"/>
+                <a16:creationId xmlns:a16="http://schemas.microsoft.com/office/drawing/2014/main" id="{BA829BF7-E679-421C-A4AD-977CC55CED33}"/>
               </a:ext>
             </a:extLst>
           </p:cNvPr>
@@ -16340,7 +16340,7 @@
           <p:cNvPr id="7" name="">
             <a:extLst xmlns:a="http://schemas.openxmlformats.org/drawingml/2006/main">
               <a:ext uri="{FF2B5EF4-FFF2-40B4-BE49-F238E27FC236}">
-                <a16:creationId xmlns:a16="http://schemas.microsoft.com/office/drawing/2014/main" id="{57D996B3-9C2C-473B-B0B0-0FFE34FAD202}"/>
+                <a16:creationId xmlns:a16="http://schemas.microsoft.com/office/drawing/2014/main" id="{DB09ADC6-6AAD-4479-8276-0893C45D83F0}"/>
               </a:ext>
             </a:extLst>
           </p:cNvPr>
@@ -16390,7 +16390,7 @@
           <p:cNvPr id="8" name="">
             <a:extLst xmlns:a="http://schemas.openxmlformats.org/drawingml/2006/main">
               <a:ext uri="{FF2B5EF4-FFF2-40B4-BE49-F238E27FC236}">
-                <a16:creationId xmlns:a16="http://schemas.microsoft.com/office/drawing/2014/main" id="{5A5BCF8A-76FF-4268-A75E-00FB43689741}"/>
+                <a16:creationId xmlns:a16="http://schemas.microsoft.com/office/drawing/2014/main" id="{250467DC-1D22-4B39-938A-221721491510}"/>
               </a:ext>
             </a:extLst>
           </p:cNvPr>
@@ -16440,7 +16440,7 @@
           <p:cNvPr id="9" name="">
             <a:extLst xmlns:a="http://schemas.openxmlformats.org/drawingml/2006/main">
               <a:ext uri="{FF2B5EF4-FFF2-40B4-BE49-F238E27FC236}">
-                <a16:creationId xmlns:a16="http://schemas.microsoft.com/office/drawing/2014/main" id="{A85E26AF-B63B-4AB3-AB32-784592558BB7}"/>
+                <a16:creationId xmlns:a16="http://schemas.microsoft.com/office/drawing/2014/main" id="{E089610F-04AE-4B45-9520-D98F39FA0662}"/>
               </a:ext>
             </a:extLst>
           </p:cNvPr>
@@ -16475,7 +16475,7 @@
           <p:cNvPr id="10" name="">
             <a:extLst xmlns:a="http://schemas.openxmlformats.org/drawingml/2006/main">
               <a:ext uri="{FF2B5EF4-FFF2-40B4-BE49-F238E27FC236}">
-                <a16:creationId xmlns:a16="http://schemas.microsoft.com/office/drawing/2014/main" id="{D2732A3B-FC2E-40DF-81A7-425233CCB394}"/>
+                <a16:creationId xmlns:a16="http://schemas.microsoft.com/office/drawing/2014/main" id="{D4803205-C6FA-4DC4-AE4A-ABD089E23698}"/>
               </a:ext>
             </a:extLst>
           </p:cNvPr>
@@ -16525,7 +16525,7 @@
           <p:cNvPr id="11" name="">
             <a:extLst xmlns:a="http://schemas.openxmlformats.org/drawingml/2006/main">
               <a:ext uri="{FF2B5EF4-FFF2-40B4-BE49-F238E27FC236}">
-                <a16:creationId xmlns:a16="http://schemas.microsoft.com/office/drawing/2014/main" id="{04584789-8DA5-4641-842C-6562BC4A9ED5}"/>
+                <a16:creationId xmlns:a16="http://schemas.microsoft.com/office/drawing/2014/main" id="{4D9EE50E-4DDE-4A96-B504-07F0C2CDF8AD}"/>
               </a:ext>
             </a:extLst>
           </p:cNvPr>
@@ -16575,7 +16575,7 @@
           <p:cNvPr id="12" name="">
             <a:extLst xmlns:a="http://schemas.openxmlformats.org/drawingml/2006/main">
               <a:ext uri="{FF2B5EF4-FFF2-40B4-BE49-F238E27FC236}">
-                <a16:creationId xmlns:a16="http://schemas.microsoft.com/office/drawing/2014/main" id="{29B92C9C-AC4F-403A-B5DE-8310AB47E0A7}"/>
+                <a16:creationId xmlns:a16="http://schemas.microsoft.com/office/drawing/2014/main" id="{E8559435-E03C-48F7-9C39-82115EE4675D}"/>
               </a:ext>
             </a:extLst>
           </p:cNvPr>
@@ -16610,7 +16610,7 @@
           <p:cNvPr id="13" name="">
             <a:extLst xmlns:a="http://schemas.openxmlformats.org/drawingml/2006/main">
               <a:ext uri="{FF2B5EF4-FFF2-40B4-BE49-F238E27FC236}">
-                <a16:creationId xmlns:a16="http://schemas.microsoft.com/office/drawing/2014/main" id="{414504EF-C4FB-4322-874A-2F8B6293E43C}"/>
+                <a16:creationId xmlns:a16="http://schemas.microsoft.com/office/drawing/2014/main" id="{D2CAA1D7-3D78-4A0B-A96A-A0CC9916BBED}"/>
               </a:ext>
             </a:extLst>
           </p:cNvPr>
@@ -16660,7 +16660,7 @@
           <p:cNvPr id="14" name="">
             <a:extLst xmlns:a="http://schemas.openxmlformats.org/drawingml/2006/main">
               <a:ext uri="{FF2B5EF4-FFF2-40B4-BE49-F238E27FC236}">
-                <a16:creationId xmlns:a16="http://schemas.microsoft.com/office/drawing/2014/main" id="{F8E00683-5B6D-4EC4-8277-173E2478E297}"/>
+                <a16:creationId xmlns:a16="http://schemas.microsoft.com/office/drawing/2014/main" id="{71CC22A1-976E-4279-968E-DFDC006AFF7A}"/>
               </a:ext>
             </a:extLst>
           </p:cNvPr>
@@ -16710,7 +16710,7 @@
           <p:cNvPr id="15" name="">
             <a:extLst xmlns:a="http://schemas.openxmlformats.org/drawingml/2006/main">
               <a:ext uri="{FF2B5EF4-FFF2-40B4-BE49-F238E27FC236}">
-                <a16:creationId xmlns:a16="http://schemas.microsoft.com/office/drawing/2014/main" id="{C2F0BFE8-86FD-4BD5-96A8-8FBE152983EB}"/>
+                <a16:creationId xmlns:a16="http://schemas.microsoft.com/office/drawing/2014/main" id="{CC53C748-D25B-4C7B-9004-0C6D4986E155}"/>
               </a:ext>
             </a:extLst>
           </p:cNvPr>
@@ -16745,7 +16745,7 @@
           <p:cNvPr id="16" name="">
             <a:extLst xmlns:a="http://schemas.openxmlformats.org/drawingml/2006/main">
               <a:ext uri="{FF2B5EF4-FFF2-40B4-BE49-F238E27FC236}">
-                <a16:creationId xmlns:a16="http://schemas.microsoft.com/office/drawing/2014/main" id="{8E19708C-80EC-4DCA-8D0F-7269EAD58073}"/>
+                <a16:creationId xmlns:a16="http://schemas.microsoft.com/office/drawing/2014/main" id="{37DF5E2B-BBA7-4017-9CA4-9A632BB0D7B8}"/>
               </a:ext>
             </a:extLst>
           </p:cNvPr>
@@ -16778,7 +16778,7 @@
           <p:cNvPr id="17" name="">
             <a:extLst xmlns:a="http://schemas.openxmlformats.org/drawingml/2006/main">
               <a:ext uri="{FF2B5EF4-FFF2-40B4-BE49-F238E27FC236}">
-                <a16:creationId xmlns:a16="http://schemas.microsoft.com/office/drawing/2014/main" id="{3D4099C6-1303-4075-9A7F-A4655CA41714}"/>
+                <a16:creationId xmlns:a16="http://schemas.microsoft.com/office/drawing/2014/main" id="{FA49D57B-BBAF-4CE0-9542-0291EC2B7CEA}"/>
               </a:ext>
             </a:extLst>
           </p:cNvPr>
@@ -16828,7 +16828,7 @@
           <p:cNvPr id="18" name="">
             <a:extLst xmlns:a="http://schemas.openxmlformats.org/drawingml/2006/main">
               <a:ext uri="{FF2B5EF4-FFF2-40B4-BE49-F238E27FC236}">
-                <a16:creationId xmlns:a16="http://schemas.microsoft.com/office/drawing/2014/main" id="{A0B8F312-2DF2-4503-BFB1-B9E7D41D0EEC}"/>
+                <a16:creationId xmlns:a16="http://schemas.microsoft.com/office/drawing/2014/main" id="{C6020BF1-79B5-46B0-A402-996CAECFEE21}"/>
               </a:ext>
             </a:extLst>
           </p:cNvPr>
@@ -16878,7 +16878,7 @@
           <p:cNvPr id="19" name="">
             <a:extLst xmlns:a="http://schemas.openxmlformats.org/drawingml/2006/main">
               <a:ext uri="{FF2B5EF4-FFF2-40B4-BE49-F238E27FC236}">
-                <a16:creationId xmlns:a16="http://schemas.microsoft.com/office/drawing/2014/main" id="{197BC698-3AF5-43C9-8056-404B6787DDC5}"/>
+                <a16:creationId xmlns:a16="http://schemas.microsoft.com/office/drawing/2014/main" id="{C190DC7F-BBA3-4FC4-B1E2-4F937CC880FA}"/>
               </a:ext>
             </a:extLst>
           </p:cNvPr>
@@ -16913,7 +16913,7 @@
           <p:cNvPr id="20" name="">
             <a:extLst xmlns:a="http://schemas.openxmlformats.org/drawingml/2006/main">
               <a:ext uri="{FF2B5EF4-FFF2-40B4-BE49-F238E27FC236}">
-                <a16:creationId xmlns:a16="http://schemas.microsoft.com/office/drawing/2014/main" id="{5BDD2C02-0997-485D-AF4E-1A1C14931782}"/>
+                <a16:creationId xmlns:a16="http://schemas.microsoft.com/office/drawing/2014/main" id="{77657FA9-4D96-416B-8867-503D5F8D389F}"/>
               </a:ext>
             </a:extLst>
           </p:cNvPr>
@@ -16946,7 +16946,7 @@
           <p:cNvPr id="21" name="">
             <a:extLst xmlns:a="http://schemas.openxmlformats.org/drawingml/2006/main">
               <a:ext uri="{FF2B5EF4-FFF2-40B4-BE49-F238E27FC236}">
-                <a16:creationId xmlns:a16="http://schemas.microsoft.com/office/drawing/2014/main" id="{ED111062-118B-4E84-91A5-34CE6EEE626C}"/>
+                <a16:creationId xmlns:a16="http://schemas.microsoft.com/office/drawing/2014/main" id="{E896A15D-DE0F-4793-A548-5C326D1AF9F5}"/>
               </a:ext>
             </a:extLst>
           </p:cNvPr>
@@ -16996,7 +16996,7 @@
           <p:cNvPr id="22" name="">
             <a:extLst xmlns:a="http://schemas.openxmlformats.org/drawingml/2006/main">
               <a:ext uri="{FF2B5EF4-FFF2-40B4-BE49-F238E27FC236}">
-                <a16:creationId xmlns:a16="http://schemas.microsoft.com/office/drawing/2014/main" id="{368C92F0-7234-4DED-85A5-076C182CBFE0}"/>
+                <a16:creationId xmlns:a16="http://schemas.microsoft.com/office/drawing/2014/main" id="{981F3743-94BC-4884-A20A-76E9D781156B}"/>
               </a:ext>
             </a:extLst>
           </p:cNvPr>
@@ -17034,7 +17034,7 @@
           <p:cNvPr id="23" name="">
             <a:extLst xmlns:a="http://schemas.openxmlformats.org/drawingml/2006/main">
               <a:ext uri="{FF2B5EF4-FFF2-40B4-BE49-F238E27FC236}">
-                <a16:creationId xmlns:a16="http://schemas.microsoft.com/office/drawing/2014/main" id="{85A8F7D3-FC9B-404F-B2C3-FA00C311519F}"/>
+                <a16:creationId xmlns:a16="http://schemas.microsoft.com/office/drawing/2014/main" id="{5B5772CA-2C52-4085-93EF-8A1449E125A2}"/>
               </a:ext>
             </a:extLst>
           </p:cNvPr>
@@ -17065,7 +17065,7 @@
           <p:cNvPr id="24" name="">
             <a:extLst xmlns:a="http://schemas.openxmlformats.org/drawingml/2006/main">
               <a:ext uri="{FF2B5EF4-FFF2-40B4-BE49-F238E27FC236}">
-                <a16:creationId xmlns:a16="http://schemas.microsoft.com/office/drawing/2014/main" id="{C607EB4A-E0AF-4448-B561-5801D6655CC7}"/>
+                <a16:creationId xmlns:a16="http://schemas.microsoft.com/office/drawing/2014/main" id="{4151DFF7-0C1C-4BF2-AB78-1630BA29F35C}"/>
               </a:ext>
             </a:extLst>
           </p:cNvPr>
@@ -17115,7 +17115,7 @@
           <p:cNvPr id="25" name="">
             <a:extLst xmlns:a="http://schemas.openxmlformats.org/drawingml/2006/main">
               <a:ext uri="{FF2B5EF4-FFF2-40B4-BE49-F238E27FC236}">
-                <a16:creationId xmlns:a16="http://schemas.microsoft.com/office/drawing/2014/main" id="{66722B24-DE0A-4FE7-8B56-D8EA05E4F060}"/>
+                <a16:creationId xmlns:a16="http://schemas.microsoft.com/office/drawing/2014/main" id="{675BD920-E259-4A43-B211-5C9B7835BFDE}"/>
               </a:ext>
             </a:extLst>
           </p:cNvPr>
@@ -17146,7 +17146,7 @@
           <p:cNvPr id="26" name="">
             <a:extLst xmlns:a="http://schemas.openxmlformats.org/drawingml/2006/main">
               <a:ext uri="{FF2B5EF4-FFF2-40B4-BE49-F238E27FC236}">
-                <a16:creationId xmlns:a16="http://schemas.microsoft.com/office/drawing/2014/main" id="{6F8075BB-9006-4410-8F70-13653F2451C3}"/>
+                <a16:creationId xmlns:a16="http://schemas.microsoft.com/office/drawing/2014/main" id="{EBEC6013-2F68-46AE-8E86-6E3B95D5CA28}"/>
               </a:ext>
             </a:extLst>
           </p:cNvPr>
@@ -17196,7 +17196,7 @@
           <p:cNvPr id="27" name="">
             <a:extLst xmlns:a="http://schemas.openxmlformats.org/drawingml/2006/main">
               <a:ext uri="{FF2B5EF4-FFF2-40B4-BE49-F238E27FC236}">
-                <a16:creationId xmlns:a16="http://schemas.microsoft.com/office/drawing/2014/main" id="{03E215F0-C484-451B-BBC9-101B6244DAD5}"/>
+                <a16:creationId xmlns:a16="http://schemas.microsoft.com/office/drawing/2014/main" id="{BE80CC5F-1212-4C2D-898B-580548F572C6}"/>
               </a:ext>
             </a:extLst>
           </p:cNvPr>
@@ -17227,7 +17227,7 @@
           <p:cNvPr id="28" name="">
             <a:extLst xmlns:a="http://schemas.openxmlformats.org/drawingml/2006/main">
               <a:ext uri="{FF2B5EF4-FFF2-40B4-BE49-F238E27FC236}">
-                <a16:creationId xmlns:a16="http://schemas.microsoft.com/office/drawing/2014/main" id="{463AC686-FE71-43F3-AED7-EC71156B5041}"/>
+                <a16:creationId xmlns:a16="http://schemas.microsoft.com/office/drawing/2014/main" id="{57BBD520-40F0-4820-B8A3-AE98DB336DCD}"/>
               </a:ext>
             </a:extLst>
           </p:cNvPr>
@@ -17277,7 +17277,7 @@
           <p:cNvPr id="29" name="">
             <a:extLst xmlns:a="http://schemas.openxmlformats.org/drawingml/2006/main">
               <a:ext uri="{FF2B5EF4-FFF2-40B4-BE49-F238E27FC236}">
-                <a16:creationId xmlns:a16="http://schemas.microsoft.com/office/drawing/2014/main" id="{550D718A-6F21-4E52-AD29-0AFDF28E2CAA}"/>
+                <a16:creationId xmlns:a16="http://schemas.microsoft.com/office/drawing/2014/main" id="{EF9C7484-C0E4-4DA1-9C9B-FC64F452F689}"/>
               </a:ext>
             </a:extLst>
           </p:cNvPr>
@@ -17312,7 +17312,7 @@
           <p:cNvPr id="30" name="">
             <a:extLst xmlns:a="http://schemas.openxmlformats.org/drawingml/2006/main">
               <a:ext uri="{FF2B5EF4-FFF2-40B4-BE49-F238E27FC236}">
-                <a16:creationId xmlns:a16="http://schemas.microsoft.com/office/drawing/2014/main" id="{0C769376-F712-4BF1-BDE3-C52392A7A328}"/>
+                <a16:creationId xmlns:a16="http://schemas.microsoft.com/office/drawing/2014/main" id="{183ACF37-1F14-495F-8423-986B0B332A4D}"/>
               </a:ext>
             </a:extLst>
           </p:cNvPr>
@@ -17345,7 +17345,7 @@
           <p:cNvPr id="31" name="">
             <a:extLst xmlns:a="http://schemas.openxmlformats.org/drawingml/2006/main">
               <a:ext uri="{FF2B5EF4-FFF2-40B4-BE49-F238E27FC236}">
-                <a16:creationId xmlns:a16="http://schemas.microsoft.com/office/drawing/2014/main" id="{92F174FD-DBDD-4CCC-8E29-D81FBDC5E705}"/>
+                <a16:creationId xmlns:a16="http://schemas.microsoft.com/office/drawing/2014/main" id="{EA754D40-8BA0-4300-BA5F-5B62EE9EA4EC}"/>
               </a:ext>
             </a:extLst>
           </p:cNvPr>
@@ -17395,7 +17395,7 @@
           <p:cNvPr id="32" name="">
             <a:extLst xmlns:a="http://schemas.openxmlformats.org/drawingml/2006/main">
               <a:ext uri="{FF2B5EF4-FFF2-40B4-BE49-F238E27FC236}">
-                <a16:creationId xmlns:a16="http://schemas.microsoft.com/office/drawing/2014/main" id="{71017A4A-8FF5-4F80-A668-A3CB04FC65C3}"/>
+                <a16:creationId xmlns:a16="http://schemas.microsoft.com/office/drawing/2014/main" id="{79A4E796-F844-4BA8-AE9E-D4177B7C0D34}"/>
               </a:ext>
             </a:extLst>
           </p:cNvPr>
@@ -17433,7 +17433,7 @@
           <p:cNvPr id="33" name="">
             <a:extLst xmlns:a="http://schemas.openxmlformats.org/drawingml/2006/main">
               <a:ext uri="{FF2B5EF4-FFF2-40B4-BE49-F238E27FC236}">
-                <a16:creationId xmlns:a16="http://schemas.microsoft.com/office/drawing/2014/main" id="{B9B77815-2134-40EC-AC8A-7D27CBD31520}"/>
+                <a16:creationId xmlns:a16="http://schemas.microsoft.com/office/drawing/2014/main" id="{2EEFAE88-0837-4621-8185-CE2BBD26DAF3}"/>
               </a:ext>
             </a:extLst>
           </p:cNvPr>
@@ -17464,7 +17464,7 @@
           <p:cNvPr id="34" name="">
             <a:extLst xmlns:a="http://schemas.openxmlformats.org/drawingml/2006/main">
               <a:ext uri="{FF2B5EF4-FFF2-40B4-BE49-F238E27FC236}">
-                <a16:creationId xmlns:a16="http://schemas.microsoft.com/office/drawing/2014/main" id="{5F0AA9B0-AC40-41D3-ADB7-DEAC68E633D4}"/>
+                <a16:creationId xmlns:a16="http://schemas.microsoft.com/office/drawing/2014/main" id="{E2752644-02DB-45AE-B041-41C40EDF5284}"/>
               </a:ext>
             </a:extLst>
           </p:cNvPr>
@@ -17514,7 +17514,7 @@
           <p:cNvPr id="35" name="">
             <a:extLst xmlns:a="http://schemas.openxmlformats.org/drawingml/2006/main">
               <a:ext uri="{FF2B5EF4-FFF2-40B4-BE49-F238E27FC236}">
-                <a16:creationId xmlns:a16="http://schemas.microsoft.com/office/drawing/2014/main" id="{DE711767-967F-4712-8EF2-A896C1A9579E}"/>
+                <a16:creationId xmlns:a16="http://schemas.microsoft.com/office/drawing/2014/main" id="{1BFDC95D-D8D2-42D5-BC46-A4DE540EA596}"/>
               </a:ext>
             </a:extLst>
           </p:cNvPr>
@@ -17545,7 +17545,7 @@
           <p:cNvPr id="36" name="">
             <a:extLst xmlns:a="http://schemas.openxmlformats.org/drawingml/2006/main">
               <a:ext uri="{FF2B5EF4-FFF2-40B4-BE49-F238E27FC236}">
-                <a16:creationId xmlns:a16="http://schemas.microsoft.com/office/drawing/2014/main" id="{E74F6E60-FD35-41D3-8806-A882DEB94A27}"/>
+                <a16:creationId xmlns:a16="http://schemas.microsoft.com/office/drawing/2014/main" id="{DA6A777F-7293-4D6F-BD40-07F67331734B}"/>
               </a:ext>
             </a:extLst>
           </p:cNvPr>
@@ -17595,7 +17595,7 @@
           <p:cNvPr id="37" name="">
             <a:extLst xmlns:a="http://schemas.openxmlformats.org/drawingml/2006/main">
               <a:ext uri="{FF2B5EF4-FFF2-40B4-BE49-F238E27FC236}">
-                <a16:creationId xmlns:a16="http://schemas.microsoft.com/office/drawing/2014/main" id="{86BD316D-2EB2-4F8C-A6FF-9516AEF460AC}"/>
+                <a16:creationId xmlns:a16="http://schemas.microsoft.com/office/drawing/2014/main" id="{53C451A7-E29B-4A74-BB48-EC87433F51FD}"/>
               </a:ext>
             </a:extLst>
           </p:cNvPr>
@@ -17626,7 +17626,7 @@
           <p:cNvPr id="38" name="">
             <a:extLst xmlns:a="http://schemas.openxmlformats.org/drawingml/2006/main">
               <a:ext uri="{FF2B5EF4-FFF2-40B4-BE49-F238E27FC236}">
-                <a16:creationId xmlns:a16="http://schemas.microsoft.com/office/drawing/2014/main" id="{0FABE7C4-DE74-4F0B-8712-0BC5DDD6A593}"/>
+                <a16:creationId xmlns:a16="http://schemas.microsoft.com/office/drawing/2014/main" id="{D2FD7DC5-803D-4D51-823D-493921F085EA}"/>
               </a:ext>
             </a:extLst>
           </p:cNvPr>
@@ -17676,7 +17676,7 @@
           <p:cNvPr id="39" name="">
             <a:extLst xmlns:a="http://schemas.openxmlformats.org/drawingml/2006/main">
               <a:ext uri="{FF2B5EF4-FFF2-40B4-BE49-F238E27FC236}">
-                <a16:creationId xmlns:a16="http://schemas.microsoft.com/office/drawing/2014/main" id="{BDFE3EE5-A456-466B-8E56-B80F42E57689}"/>
+                <a16:creationId xmlns:a16="http://schemas.microsoft.com/office/drawing/2014/main" id="{E0C08AB7-2EAB-45A6-B8AE-6F9E9F2AC14F}"/>
               </a:ext>
             </a:extLst>
           </p:cNvPr>
@@ -17724,7 +17724,7 @@
     </p:spTree>
     <p:extLst>
       <p:ext uri="{BB962C8B-B14F-4D97-AF65-F5344CB8AC3E}">
-        <p14:creationId xmlns:p14="http://schemas.microsoft.com/office/powerpoint/2010/main" val="1122138391"/>
+        <p14:creationId xmlns:p14="http://schemas.microsoft.com/office/powerpoint/2010/main" val="1296707214"/>
       </p:ext>
     </p:extLst>
   </p:cSld>
@@ -17755,7 +17755,7 @@
           <p:cNvPr id="1" name="">
             <a:extLst xmlns:a="http://schemas.openxmlformats.org/drawingml/2006/main">
               <a:ext uri="{FF2B5EF4-FFF2-40B4-BE49-F238E27FC236}">
-                <a16:creationId xmlns:a16="http://schemas.microsoft.com/office/drawing/2014/main" id="{F363FBF5-174F-4EB8-86EA-EEC4954D9420}"/>
+                <a16:creationId xmlns:a16="http://schemas.microsoft.com/office/drawing/2014/main" id="{3FB2BA70-3DA6-42A4-8927-87C56E102D9B}"/>
               </a:ext>
             </a:extLst>
           </p:cNvPr>
@@ -17809,7 +17809,7 @@
           <p:cNvPr id="2" name="">
             <a:extLst xmlns:a="http://schemas.openxmlformats.org/drawingml/2006/main">
               <a:ext uri="{FF2B5EF4-FFF2-40B4-BE49-F238E27FC236}">
-                <a16:creationId xmlns:a16="http://schemas.microsoft.com/office/drawing/2014/main" id="{20C56585-8901-43AE-9D4B-C27546FCCF4B}"/>
+                <a16:creationId xmlns:a16="http://schemas.microsoft.com/office/drawing/2014/main" id="{DDEA336F-7B1D-4877-86E7-C2BABCBA708A}"/>
               </a:ext>
             </a:extLst>
           </p:cNvPr>
@@ -17840,7 +17840,7 @@
           <p:cNvPr id="3" name="">
             <a:extLst xmlns:a="http://schemas.openxmlformats.org/drawingml/2006/main">
               <a:ext uri="{FF2B5EF4-FFF2-40B4-BE49-F238E27FC236}">
-                <a16:creationId xmlns:a16="http://schemas.microsoft.com/office/drawing/2014/main" id="{BC6E16D8-19DF-4121-93A1-3AA4DD04E274}"/>
+                <a16:creationId xmlns:a16="http://schemas.microsoft.com/office/drawing/2014/main" id="{5CEEB138-AB22-4DCD-83F1-AEBDDF4559F8}"/>
               </a:ext>
             </a:extLst>
           </p:cNvPr>
@@ -17890,7 +17890,7 @@
           <p:cNvPr id="4" name="">
             <a:extLst xmlns:a="http://schemas.openxmlformats.org/drawingml/2006/main">
               <a:ext uri="{FF2B5EF4-FFF2-40B4-BE49-F238E27FC236}">
-                <a16:creationId xmlns:a16="http://schemas.microsoft.com/office/drawing/2014/main" id="{A5BD41DB-E240-4B1B-8103-4BE1F3596D0B}"/>
+                <a16:creationId xmlns:a16="http://schemas.microsoft.com/office/drawing/2014/main" id="{CA010B01-0CB8-4F1D-AEC4-95A600A225C4}"/>
               </a:ext>
             </a:extLst>
           </p:cNvPr>
@@ -17940,7 +17940,7 @@
           <p:cNvPr id="5" name="">
             <a:extLst xmlns:a="http://schemas.openxmlformats.org/drawingml/2006/main">
               <a:ext uri="{FF2B5EF4-FFF2-40B4-BE49-F238E27FC236}">
-                <a16:creationId xmlns:a16="http://schemas.microsoft.com/office/drawing/2014/main" id="{AECBC106-86FC-4A0D-A888-B96F56E20835}"/>
+                <a16:creationId xmlns:a16="http://schemas.microsoft.com/office/drawing/2014/main" id="{A18A0758-0049-4BC2-BC67-A1B8213B1990}"/>
               </a:ext>
             </a:extLst>
           </p:cNvPr>
@@ -17990,7 +17990,7 @@
           <p:cNvPr id="6" name="">
             <a:extLst xmlns:a="http://schemas.openxmlformats.org/drawingml/2006/main">
               <a:ext uri="{FF2B5EF4-FFF2-40B4-BE49-F238E27FC236}">
-                <a16:creationId xmlns:a16="http://schemas.microsoft.com/office/drawing/2014/main" id="{B6AABFF8-B7B8-4BEC-8D5A-90A1B059D182}"/>
+                <a16:creationId xmlns:a16="http://schemas.microsoft.com/office/drawing/2014/main" id="{28C560DA-1AA4-482A-B36F-2C430D291DC1}"/>
               </a:ext>
             </a:extLst>
           </p:cNvPr>
@@ -18025,7 +18025,7 @@
           <p:cNvPr id="7" name="">
             <a:extLst xmlns:a="http://schemas.openxmlformats.org/drawingml/2006/main">
               <a:ext uri="{FF2B5EF4-FFF2-40B4-BE49-F238E27FC236}">
-                <a16:creationId xmlns:a16="http://schemas.microsoft.com/office/drawing/2014/main" id="{DDE70803-EA77-4138-86C6-26477BDC65FC}"/>
+                <a16:creationId xmlns:a16="http://schemas.microsoft.com/office/drawing/2014/main" id="{BDC22D37-3D0A-4424-8BD7-430EE1F7AD96}"/>
               </a:ext>
             </a:extLst>
           </p:cNvPr>
@@ -18075,7 +18075,7 @@
           <p:cNvPr id="8" name="">
             <a:extLst xmlns:a="http://schemas.openxmlformats.org/drawingml/2006/main">
               <a:ext uri="{FF2B5EF4-FFF2-40B4-BE49-F238E27FC236}">
-                <a16:creationId xmlns:a16="http://schemas.microsoft.com/office/drawing/2014/main" id="{2EDC5E2E-7E36-49A5-B7C2-D0F6E1F406FB}"/>
+                <a16:creationId xmlns:a16="http://schemas.microsoft.com/office/drawing/2014/main" id="{FE94975D-8743-4A80-A552-009DF775F599}"/>
               </a:ext>
             </a:extLst>
           </p:cNvPr>
@@ -18125,7 +18125,7 @@
           <p:cNvPr id="9" name="">
             <a:extLst xmlns:a="http://schemas.openxmlformats.org/drawingml/2006/main">
               <a:ext uri="{FF2B5EF4-FFF2-40B4-BE49-F238E27FC236}">
-                <a16:creationId xmlns:a16="http://schemas.microsoft.com/office/drawing/2014/main" id="{D4EF8DD2-363C-401F-9348-41B77E792DB0}"/>
+                <a16:creationId xmlns:a16="http://schemas.microsoft.com/office/drawing/2014/main" id="{587CF767-D360-41D6-9DAC-ADF897EFF9A4}"/>
               </a:ext>
             </a:extLst>
           </p:cNvPr>
@@ -18160,7 +18160,7 @@
           <p:cNvPr id="10" name="">
             <a:extLst xmlns:a="http://schemas.openxmlformats.org/drawingml/2006/main">
               <a:ext uri="{FF2B5EF4-FFF2-40B4-BE49-F238E27FC236}">
-                <a16:creationId xmlns:a16="http://schemas.microsoft.com/office/drawing/2014/main" id="{4902D733-6FA4-4878-B716-7737440DCC46}"/>
+                <a16:creationId xmlns:a16="http://schemas.microsoft.com/office/drawing/2014/main" id="{C7E0F8AF-3390-439A-8281-D42AEB4558D1}"/>
               </a:ext>
             </a:extLst>
           </p:cNvPr>
@@ -18210,7 +18210,7 @@
           <p:cNvPr id="11" name="">
             <a:extLst xmlns:a="http://schemas.openxmlformats.org/drawingml/2006/main">
               <a:ext uri="{FF2B5EF4-FFF2-40B4-BE49-F238E27FC236}">
-                <a16:creationId xmlns:a16="http://schemas.microsoft.com/office/drawing/2014/main" id="{445E9FD6-F45E-4920-A1FD-CF211A4EA4EE}"/>
+                <a16:creationId xmlns:a16="http://schemas.microsoft.com/office/drawing/2014/main" id="{1ED7B424-1596-47EE-B56F-94839BC915D8}"/>
               </a:ext>
             </a:extLst>
           </p:cNvPr>
@@ -18260,7 +18260,7 @@
           <p:cNvPr id="12" name="">
             <a:extLst xmlns:a="http://schemas.openxmlformats.org/drawingml/2006/main">
               <a:ext uri="{FF2B5EF4-FFF2-40B4-BE49-F238E27FC236}">
-                <a16:creationId xmlns:a16="http://schemas.microsoft.com/office/drawing/2014/main" id="{C896AE64-610A-49AB-9717-9C2779356D40}"/>
+                <a16:creationId xmlns:a16="http://schemas.microsoft.com/office/drawing/2014/main" id="{E16C35DA-36C9-4852-A99F-C33BF71E84AB}"/>
               </a:ext>
             </a:extLst>
           </p:cNvPr>
@@ -18295,7 +18295,7 @@
           <p:cNvPr id="13" name="">
             <a:extLst xmlns:a="http://schemas.openxmlformats.org/drawingml/2006/main">
               <a:ext uri="{FF2B5EF4-FFF2-40B4-BE49-F238E27FC236}">
-                <a16:creationId xmlns:a16="http://schemas.microsoft.com/office/drawing/2014/main" id="{1FB8FCA8-A40B-4B04-B906-5C34E5B1E937}"/>
+                <a16:creationId xmlns:a16="http://schemas.microsoft.com/office/drawing/2014/main" id="{8DD3C1C6-8719-46FF-B78A-CFEACD6AA1C2}"/>
               </a:ext>
             </a:extLst>
           </p:cNvPr>
@@ -18345,7 +18345,7 @@
           <p:cNvPr id="14" name="">
             <a:extLst xmlns:a="http://schemas.openxmlformats.org/drawingml/2006/main">
               <a:ext uri="{FF2B5EF4-FFF2-40B4-BE49-F238E27FC236}">
-                <a16:creationId xmlns:a16="http://schemas.microsoft.com/office/drawing/2014/main" id="{D89465EE-EBE8-43F3-AB2F-850D8E13817F}"/>
+                <a16:creationId xmlns:a16="http://schemas.microsoft.com/office/drawing/2014/main" id="{4F6AA55C-7ED9-4CB3-A0CE-08322369927B}"/>
               </a:ext>
             </a:extLst>
           </p:cNvPr>
@@ -18395,7 +18395,7 @@
           <p:cNvPr id="15" name="">
             <a:extLst xmlns:a="http://schemas.openxmlformats.org/drawingml/2006/main">
               <a:ext uri="{FF2B5EF4-FFF2-40B4-BE49-F238E27FC236}">
-                <a16:creationId xmlns:a16="http://schemas.microsoft.com/office/drawing/2014/main" id="{7ECB2E2E-4F4D-4360-B290-E118F9553276}"/>
+                <a16:creationId xmlns:a16="http://schemas.microsoft.com/office/drawing/2014/main" id="{5236C195-2BC0-41CA-9AD9-06FFB495CA8B}"/>
               </a:ext>
             </a:extLst>
           </p:cNvPr>
@@ -18430,7 +18430,7 @@
           <p:cNvPr id="16" name="">
             <a:extLst xmlns:a="http://schemas.openxmlformats.org/drawingml/2006/main">
               <a:ext uri="{FF2B5EF4-FFF2-40B4-BE49-F238E27FC236}">
-                <a16:creationId xmlns:a16="http://schemas.microsoft.com/office/drawing/2014/main" id="{1F9AF325-7BD1-44C7-BB1D-9BBF5F78831A}"/>
+                <a16:creationId xmlns:a16="http://schemas.microsoft.com/office/drawing/2014/main" id="{D62D1C06-D7B7-4DCE-93E9-723DE637C267}"/>
               </a:ext>
             </a:extLst>
           </p:cNvPr>
@@ -18463,7 +18463,7 @@
           <p:cNvPr id="17" name="">
             <a:extLst xmlns:a="http://schemas.openxmlformats.org/drawingml/2006/main">
               <a:ext uri="{FF2B5EF4-FFF2-40B4-BE49-F238E27FC236}">
-                <a16:creationId xmlns:a16="http://schemas.microsoft.com/office/drawing/2014/main" id="{5F549462-80FB-4AF1-A698-36FAE8B62CB1}"/>
+                <a16:creationId xmlns:a16="http://schemas.microsoft.com/office/drawing/2014/main" id="{1A6B0EDF-3864-47A4-9D3C-CF98DBE34D08}"/>
               </a:ext>
             </a:extLst>
           </p:cNvPr>
@@ -18513,7 +18513,7 @@
           <p:cNvPr id="18" name="">
             <a:extLst xmlns:a="http://schemas.openxmlformats.org/drawingml/2006/main">
               <a:ext uri="{FF2B5EF4-FFF2-40B4-BE49-F238E27FC236}">
-                <a16:creationId xmlns:a16="http://schemas.microsoft.com/office/drawing/2014/main" id="{9CC52E14-C36E-4510-8C63-8E14C9776ADE}"/>
+                <a16:creationId xmlns:a16="http://schemas.microsoft.com/office/drawing/2014/main" id="{EFB6973B-F77F-46E3-B87E-32A730F4E755}"/>
               </a:ext>
             </a:extLst>
           </p:cNvPr>
@@ -18563,7 +18563,7 @@
           <p:cNvPr id="19" name="">
             <a:extLst xmlns:a="http://schemas.openxmlformats.org/drawingml/2006/main">
               <a:ext uri="{FF2B5EF4-FFF2-40B4-BE49-F238E27FC236}">
-                <a16:creationId xmlns:a16="http://schemas.microsoft.com/office/drawing/2014/main" id="{D9777B63-47DF-42F7-A735-1891935D89CD}"/>
+                <a16:creationId xmlns:a16="http://schemas.microsoft.com/office/drawing/2014/main" id="{2654D478-8202-4955-BFBC-68ABE94D6384}"/>
               </a:ext>
             </a:extLst>
           </p:cNvPr>
@@ -18598,7 +18598,7 @@
           <p:cNvPr id="20" name="">
             <a:extLst xmlns:a="http://schemas.openxmlformats.org/drawingml/2006/main">
               <a:ext uri="{FF2B5EF4-FFF2-40B4-BE49-F238E27FC236}">
-                <a16:creationId xmlns:a16="http://schemas.microsoft.com/office/drawing/2014/main" id="{2D6CB7EA-2136-4D8C-8EDD-B6A1AD55C5ED}"/>
+                <a16:creationId xmlns:a16="http://schemas.microsoft.com/office/drawing/2014/main" id="{84AD9268-2398-47ED-9C90-ECAC5CDC798C}"/>
               </a:ext>
             </a:extLst>
           </p:cNvPr>
@@ -18631,7 +18631,7 @@
           <p:cNvPr id="21" name="">
             <a:extLst xmlns:a="http://schemas.openxmlformats.org/drawingml/2006/main">
               <a:ext uri="{FF2B5EF4-FFF2-40B4-BE49-F238E27FC236}">
-                <a16:creationId xmlns:a16="http://schemas.microsoft.com/office/drawing/2014/main" id="{A7C9CF4E-FD7E-4252-874B-8EA0FE1F0178}"/>
+                <a16:creationId xmlns:a16="http://schemas.microsoft.com/office/drawing/2014/main" id="{C9066B6C-D243-4F92-BB3A-7B30F80C7376}"/>
               </a:ext>
             </a:extLst>
           </p:cNvPr>
@@ -18681,7 +18681,7 @@
           <p:cNvPr id="22" name="">
             <a:extLst xmlns:a="http://schemas.openxmlformats.org/drawingml/2006/main">
               <a:ext uri="{FF2B5EF4-FFF2-40B4-BE49-F238E27FC236}">
-                <a16:creationId xmlns:a16="http://schemas.microsoft.com/office/drawing/2014/main" id="{85AB2034-3B01-453E-A556-DD0227F474F1}"/>
+                <a16:creationId xmlns:a16="http://schemas.microsoft.com/office/drawing/2014/main" id="{D54C836F-C857-43F2-8157-F448A60979D5}"/>
               </a:ext>
             </a:extLst>
           </p:cNvPr>
@@ -18719,7 +18719,7 @@
           <p:cNvPr id="23" name="">
             <a:extLst xmlns:a="http://schemas.openxmlformats.org/drawingml/2006/main">
               <a:ext uri="{FF2B5EF4-FFF2-40B4-BE49-F238E27FC236}">
-                <a16:creationId xmlns:a16="http://schemas.microsoft.com/office/drawing/2014/main" id="{338B1D35-5B57-4087-960E-2CB7CA856C91}"/>
+                <a16:creationId xmlns:a16="http://schemas.microsoft.com/office/drawing/2014/main" id="{D765CD5A-EE49-4767-954B-9AC1E95A0B6F}"/>
               </a:ext>
             </a:extLst>
           </p:cNvPr>
@@ -18750,7 +18750,7 @@
           <p:cNvPr id="24" name="">
             <a:extLst xmlns:a="http://schemas.openxmlformats.org/drawingml/2006/main">
               <a:ext uri="{FF2B5EF4-FFF2-40B4-BE49-F238E27FC236}">
-                <a16:creationId xmlns:a16="http://schemas.microsoft.com/office/drawing/2014/main" id="{05C9ED25-2016-43AA-AEF8-987CDA1C4816}"/>
+                <a16:creationId xmlns:a16="http://schemas.microsoft.com/office/drawing/2014/main" id="{D372FB32-C307-4FF0-89FF-9330B2FFE611}"/>
               </a:ext>
             </a:extLst>
           </p:cNvPr>
@@ -18800,7 +18800,7 @@
           <p:cNvPr id="25" name="">
             <a:extLst xmlns:a="http://schemas.openxmlformats.org/drawingml/2006/main">
               <a:ext uri="{FF2B5EF4-FFF2-40B4-BE49-F238E27FC236}">
-                <a16:creationId xmlns:a16="http://schemas.microsoft.com/office/drawing/2014/main" id="{51D1EFD2-5085-4955-9EF0-FDB0178E71DE}"/>
+                <a16:creationId xmlns:a16="http://schemas.microsoft.com/office/drawing/2014/main" id="{116A030F-0B49-4F2D-B2B0-966DA6EA7EC2}"/>
               </a:ext>
             </a:extLst>
           </p:cNvPr>
@@ -18831,7 +18831,7 @@
           <p:cNvPr id="26" name="">
             <a:extLst xmlns:a="http://schemas.openxmlformats.org/drawingml/2006/main">
               <a:ext uri="{FF2B5EF4-FFF2-40B4-BE49-F238E27FC236}">
-                <a16:creationId xmlns:a16="http://schemas.microsoft.com/office/drawing/2014/main" id="{9F713146-ADB0-4C70-86F7-CD89F4A31B31}"/>
+                <a16:creationId xmlns:a16="http://schemas.microsoft.com/office/drawing/2014/main" id="{FFE3AEDC-2C90-44DC-AE25-4593318CDA9E}"/>
               </a:ext>
             </a:extLst>
           </p:cNvPr>
@@ -18881,7 +18881,7 @@
           <p:cNvPr id="27" name="">
             <a:extLst xmlns:a="http://schemas.openxmlformats.org/drawingml/2006/main">
               <a:ext uri="{FF2B5EF4-FFF2-40B4-BE49-F238E27FC236}">
-                <a16:creationId xmlns:a16="http://schemas.microsoft.com/office/drawing/2014/main" id="{74306854-EC92-42AF-89BA-3D6B1008345B}"/>
+                <a16:creationId xmlns:a16="http://schemas.microsoft.com/office/drawing/2014/main" id="{A9830015-6D92-43D2-8CD9-E831AB14672E}"/>
               </a:ext>
             </a:extLst>
           </p:cNvPr>
@@ -18912,7 +18912,7 @@
           <p:cNvPr id="28" name="">
             <a:extLst xmlns:a="http://schemas.openxmlformats.org/drawingml/2006/main">
               <a:ext uri="{FF2B5EF4-FFF2-40B4-BE49-F238E27FC236}">
-                <a16:creationId xmlns:a16="http://schemas.microsoft.com/office/drawing/2014/main" id="{553E9D27-5B78-403B-AB8C-8BD9BF181D00}"/>
+                <a16:creationId xmlns:a16="http://schemas.microsoft.com/office/drawing/2014/main" id="{66C42ABE-ADC5-4FA5-A279-416D573FB169}"/>
               </a:ext>
             </a:extLst>
           </p:cNvPr>
@@ -18962,7 +18962,7 @@
           <p:cNvPr id="29" name="">
             <a:extLst xmlns:a="http://schemas.openxmlformats.org/drawingml/2006/main">
               <a:ext uri="{FF2B5EF4-FFF2-40B4-BE49-F238E27FC236}">
-                <a16:creationId xmlns:a16="http://schemas.microsoft.com/office/drawing/2014/main" id="{7D4ADF68-0296-459F-B0FA-2AE798B67963}"/>
+                <a16:creationId xmlns:a16="http://schemas.microsoft.com/office/drawing/2014/main" id="{B5D3EA7A-1A8E-4C2C-B27E-F029EDA8758B}"/>
               </a:ext>
             </a:extLst>
           </p:cNvPr>
@@ -18997,7 +18997,7 @@
           <p:cNvPr id="30" name="">
             <a:extLst xmlns:a="http://schemas.openxmlformats.org/drawingml/2006/main">
               <a:ext uri="{FF2B5EF4-FFF2-40B4-BE49-F238E27FC236}">
-                <a16:creationId xmlns:a16="http://schemas.microsoft.com/office/drawing/2014/main" id="{828CE307-BC38-4672-9A40-DAF8CDDF5464}"/>
+                <a16:creationId xmlns:a16="http://schemas.microsoft.com/office/drawing/2014/main" id="{27469F5A-CF0B-4221-9B7A-6171AF40EA22}"/>
               </a:ext>
             </a:extLst>
           </p:cNvPr>
@@ -19030,7 +19030,7 @@
           <p:cNvPr id="31" name="">
             <a:extLst xmlns:a="http://schemas.openxmlformats.org/drawingml/2006/main">
               <a:ext uri="{FF2B5EF4-FFF2-40B4-BE49-F238E27FC236}">
-                <a16:creationId xmlns:a16="http://schemas.microsoft.com/office/drawing/2014/main" id="{59181185-3053-4C5A-BC12-75C48C5A80E5}"/>
+                <a16:creationId xmlns:a16="http://schemas.microsoft.com/office/drawing/2014/main" id="{DF231B4D-CF8E-4B63-99D6-E24D5D01A46A}"/>
               </a:ext>
             </a:extLst>
           </p:cNvPr>
@@ -19080,7 +19080,7 @@
           <p:cNvPr id="32" name="">
             <a:extLst xmlns:a="http://schemas.openxmlformats.org/drawingml/2006/main">
               <a:ext uri="{FF2B5EF4-FFF2-40B4-BE49-F238E27FC236}">
-                <a16:creationId xmlns:a16="http://schemas.microsoft.com/office/drawing/2014/main" id="{512490FB-8370-47B2-B434-B54D8CA8FBDB}"/>
+                <a16:creationId xmlns:a16="http://schemas.microsoft.com/office/drawing/2014/main" id="{43EE2CB9-FD4F-400D-AF84-59685CCECCBC}"/>
               </a:ext>
             </a:extLst>
           </p:cNvPr>
@@ -19118,7 +19118,7 @@
           <p:cNvPr id="33" name="">
             <a:extLst xmlns:a="http://schemas.openxmlformats.org/drawingml/2006/main">
               <a:ext uri="{FF2B5EF4-FFF2-40B4-BE49-F238E27FC236}">
-                <a16:creationId xmlns:a16="http://schemas.microsoft.com/office/drawing/2014/main" id="{754B187B-8DCD-4135-808D-0E984CC0D6CF}"/>
+                <a16:creationId xmlns:a16="http://schemas.microsoft.com/office/drawing/2014/main" id="{B6061BF0-0665-4742-B29C-71E51320762B}"/>
               </a:ext>
             </a:extLst>
           </p:cNvPr>
@@ -19149,7 +19149,7 @@
           <p:cNvPr id="34" name="">
             <a:extLst xmlns:a="http://schemas.openxmlformats.org/drawingml/2006/main">
               <a:ext uri="{FF2B5EF4-FFF2-40B4-BE49-F238E27FC236}">
-                <a16:creationId xmlns:a16="http://schemas.microsoft.com/office/drawing/2014/main" id="{ADE5D684-F584-46D6-9C4A-1783D8A81923}"/>
+                <a16:creationId xmlns:a16="http://schemas.microsoft.com/office/drawing/2014/main" id="{DFCD2118-C379-4561-A93A-74C99D67E127}"/>
               </a:ext>
             </a:extLst>
           </p:cNvPr>
@@ -19199,7 +19199,7 @@
           <p:cNvPr id="35" name="">
             <a:extLst xmlns:a="http://schemas.openxmlformats.org/drawingml/2006/main">
               <a:ext uri="{FF2B5EF4-FFF2-40B4-BE49-F238E27FC236}">
-                <a16:creationId xmlns:a16="http://schemas.microsoft.com/office/drawing/2014/main" id="{9C7DC98F-C050-4E70-BE28-7813D36FFF34}"/>
+                <a16:creationId xmlns:a16="http://schemas.microsoft.com/office/drawing/2014/main" id="{BD6FA9CE-055E-40D3-868A-51F308DBCB2B}"/>
               </a:ext>
             </a:extLst>
           </p:cNvPr>
@@ -19230,7 +19230,7 @@
           <p:cNvPr id="36" name="">
             <a:extLst xmlns:a="http://schemas.openxmlformats.org/drawingml/2006/main">
               <a:ext uri="{FF2B5EF4-FFF2-40B4-BE49-F238E27FC236}">
-                <a16:creationId xmlns:a16="http://schemas.microsoft.com/office/drawing/2014/main" id="{27F7A28A-391F-403B-A37B-BAB2439C1699}"/>
+                <a16:creationId xmlns:a16="http://schemas.microsoft.com/office/drawing/2014/main" id="{0877FD67-DA0C-4106-94F3-D684C6A66702}"/>
               </a:ext>
             </a:extLst>
           </p:cNvPr>
@@ -19280,7 +19280,7 @@
           <p:cNvPr id="37" name="">
             <a:extLst xmlns:a="http://schemas.openxmlformats.org/drawingml/2006/main">
               <a:ext uri="{FF2B5EF4-FFF2-40B4-BE49-F238E27FC236}">
-                <a16:creationId xmlns:a16="http://schemas.microsoft.com/office/drawing/2014/main" id="{3CB9DF18-7744-4BB5-B12A-85360191DAA8}"/>
+                <a16:creationId xmlns:a16="http://schemas.microsoft.com/office/drawing/2014/main" id="{9632B2A9-D7B7-4385-976F-1F131DB30B5E}"/>
               </a:ext>
             </a:extLst>
           </p:cNvPr>
@@ -19311,7 +19311,7 @@
           <p:cNvPr id="38" name="">
             <a:extLst xmlns:a="http://schemas.openxmlformats.org/drawingml/2006/main">
               <a:ext uri="{FF2B5EF4-FFF2-40B4-BE49-F238E27FC236}">
-                <a16:creationId xmlns:a16="http://schemas.microsoft.com/office/drawing/2014/main" id="{0A7EF0FA-26BA-41CD-963E-FEB9B5302B27}"/>
+                <a16:creationId xmlns:a16="http://schemas.microsoft.com/office/drawing/2014/main" id="{12DD3BF6-9CFE-4BAB-A17D-89E21ECE8AAD}"/>
               </a:ext>
             </a:extLst>
           </p:cNvPr>
@@ -19359,7 +19359,7 @@
     </p:spTree>
     <p:extLst>
       <p:ext uri="{BB962C8B-B14F-4D97-AF65-F5344CB8AC3E}">
-        <p14:creationId xmlns:p14="http://schemas.microsoft.com/office/powerpoint/2010/main" val="690531678"/>
+        <p14:creationId xmlns:p14="http://schemas.microsoft.com/office/powerpoint/2010/main" val="1874570913"/>
       </p:ext>
     </p:extLst>
   </p:cSld>
@@ -19390,7 +19390,7 @@
           <p:cNvPr id="1" name="">
             <a:extLst xmlns:a="http://schemas.openxmlformats.org/drawingml/2006/main">
               <a:ext uri="{FF2B5EF4-FFF2-40B4-BE49-F238E27FC236}">
-                <a16:creationId xmlns:a16="http://schemas.microsoft.com/office/drawing/2014/main" id="{26C53453-1C73-43FF-86F6-80DA8EDDE7B6}"/>
+                <a16:creationId xmlns:a16="http://schemas.microsoft.com/office/drawing/2014/main" id="{75A9697C-6004-49AB-881A-EFB4C1D30606}"/>
               </a:ext>
             </a:extLst>
           </p:cNvPr>
@@ -19444,7 +19444,7 @@
           <p:cNvPr id="2" name="">
             <a:extLst xmlns:a="http://schemas.openxmlformats.org/drawingml/2006/main">
               <a:ext uri="{FF2B5EF4-FFF2-40B4-BE49-F238E27FC236}">
-                <a16:creationId xmlns:a16="http://schemas.microsoft.com/office/drawing/2014/main" id="{274F0085-EA44-472D-A6D2-E9827F4A27D2}"/>
+                <a16:creationId xmlns:a16="http://schemas.microsoft.com/office/drawing/2014/main" id="{51199745-0109-47D6-B9D0-B9FA5B536945}"/>
               </a:ext>
             </a:extLst>
           </p:cNvPr>
@@ -19475,7 +19475,7 @@
           <p:cNvPr id="3" name="">
             <a:extLst xmlns:a="http://schemas.openxmlformats.org/drawingml/2006/main">
               <a:ext uri="{FF2B5EF4-FFF2-40B4-BE49-F238E27FC236}">
-                <a16:creationId xmlns:a16="http://schemas.microsoft.com/office/drawing/2014/main" id="{39DACCAD-3560-410B-A3D4-4F077F5088E7}"/>
+                <a16:creationId xmlns:a16="http://schemas.microsoft.com/office/drawing/2014/main" id="{E182481E-EEAB-4433-B759-814A66FCEE27}"/>
               </a:ext>
             </a:extLst>
           </p:cNvPr>
@@ -19525,7 +19525,7 @@
           <p:cNvPr id="4" name="">
             <a:extLst xmlns:a="http://schemas.openxmlformats.org/drawingml/2006/main">
               <a:ext uri="{FF2B5EF4-FFF2-40B4-BE49-F238E27FC236}">
-                <a16:creationId xmlns:a16="http://schemas.microsoft.com/office/drawing/2014/main" id="{64448387-19E2-499A-A310-192606F2E005}"/>
+                <a16:creationId xmlns:a16="http://schemas.microsoft.com/office/drawing/2014/main" id="{6F022745-C3BF-4449-8F24-4C0AB51D94FF}"/>
               </a:ext>
             </a:extLst>
           </p:cNvPr>
@@ -19575,7 +19575,7 @@
           <p:cNvPr id="5" name="">
             <a:extLst xmlns:a="http://schemas.openxmlformats.org/drawingml/2006/main">
               <a:ext uri="{FF2B5EF4-FFF2-40B4-BE49-F238E27FC236}">
-                <a16:creationId xmlns:a16="http://schemas.microsoft.com/office/drawing/2014/main" id="{62752977-233F-4604-A3C4-E3FA1CD9BB16}"/>
+                <a16:creationId xmlns:a16="http://schemas.microsoft.com/office/drawing/2014/main" id="{000C100D-6C03-441C-ACFC-2F37D32EB5EC}"/>
               </a:ext>
             </a:extLst>
           </p:cNvPr>
@@ -19625,7 +19625,7 @@
           <p:cNvPr id="6" name="">
             <a:extLst xmlns:a="http://schemas.openxmlformats.org/drawingml/2006/main">
               <a:ext uri="{FF2B5EF4-FFF2-40B4-BE49-F238E27FC236}">
-                <a16:creationId xmlns:a16="http://schemas.microsoft.com/office/drawing/2014/main" id="{BAFEB22F-74ED-463F-A7AE-AD5465B91C79}"/>
+                <a16:creationId xmlns:a16="http://schemas.microsoft.com/office/drawing/2014/main" id="{73D9D88B-CFFE-442A-A370-0F130748EA5A}"/>
               </a:ext>
             </a:extLst>
           </p:cNvPr>
@@ -19660,7 +19660,7 @@
           <p:cNvPr id="7" name="">
             <a:extLst xmlns:a="http://schemas.openxmlformats.org/drawingml/2006/main">
               <a:ext uri="{FF2B5EF4-FFF2-40B4-BE49-F238E27FC236}">
-                <a16:creationId xmlns:a16="http://schemas.microsoft.com/office/drawing/2014/main" id="{1305873D-3F0B-44E7-864A-E64D8662DE87}"/>
+                <a16:creationId xmlns:a16="http://schemas.microsoft.com/office/drawing/2014/main" id="{CD151222-C9BB-48AD-80C4-528F52674227}"/>
               </a:ext>
             </a:extLst>
           </p:cNvPr>
@@ -19710,7 +19710,7 @@
           <p:cNvPr id="8" name="">
             <a:extLst xmlns:a="http://schemas.openxmlformats.org/drawingml/2006/main">
               <a:ext uri="{FF2B5EF4-FFF2-40B4-BE49-F238E27FC236}">
-                <a16:creationId xmlns:a16="http://schemas.microsoft.com/office/drawing/2014/main" id="{9E354A72-9A4E-4813-BB56-3B5962CA9D14}"/>
+                <a16:creationId xmlns:a16="http://schemas.microsoft.com/office/drawing/2014/main" id="{B5C524F0-F9B0-4CD7-BBF3-A0C511F9BF2E}"/>
               </a:ext>
             </a:extLst>
           </p:cNvPr>
@@ -19760,7 +19760,7 @@
           <p:cNvPr id="9" name="">
             <a:extLst xmlns:a="http://schemas.openxmlformats.org/drawingml/2006/main">
               <a:ext uri="{FF2B5EF4-FFF2-40B4-BE49-F238E27FC236}">
-                <a16:creationId xmlns:a16="http://schemas.microsoft.com/office/drawing/2014/main" id="{58454185-C7AF-4C69-91BC-8E3E53223C6F}"/>
+                <a16:creationId xmlns:a16="http://schemas.microsoft.com/office/drawing/2014/main" id="{503FE502-3864-40C5-8981-60D31FA61262}"/>
               </a:ext>
             </a:extLst>
           </p:cNvPr>
@@ -19795,7 +19795,7 @@
           <p:cNvPr id="10" name="">
             <a:extLst xmlns:a="http://schemas.openxmlformats.org/drawingml/2006/main">
               <a:ext uri="{FF2B5EF4-FFF2-40B4-BE49-F238E27FC236}">
-                <a16:creationId xmlns:a16="http://schemas.microsoft.com/office/drawing/2014/main" id="{22D6A7D0-C5F2-455A-BB35-999EA74AE790}"/>
+                <a16:creationId xmlns:a16="http://schemas.microsoft.com/office/drawing/2014/main" id="{9A083BC3-8FE8-4CBF-95DB-81F6979060D5}"/>
               </a:ext>
             </a:extLst>
           </p:cNvPr>
@@ -19845,7 +19845,7 @@
           <p:cNvPr id="11" name="">
             <a:extLst xmlns:a="http://schemas.openxmlformats.org/drawingml/2006/main">
               <a:ext uri="{FF2B5EF4-FFF2-40B4-BE49-F238E27FC236}">
-                <a16:creationId xmlns:a16="http://schemas.microsoft.com/office/drawing/2014/main" id="{1923CACB-762C-48F2-82F5-0B3314E8A2CF}"/>
+                <a16:creationId xmlns:a16="http://schemas.microsoft.com/office/drawing/2014/main" id="{5E1E8FAC-363D-4632-B75B-805463F8536E}"/>
               </a:ext>
             </a:extLst>
           </p:cNvPr>
@@ -19895,7 +19895,7 @@
           <p:cNvPr id="12" name="">
             <a:extLst xmlns:a="http://schemas.openxmlformats.org/drawingml/2006/main">
               <a:ext uri="{FF2B5EF4-FFF2-40B4-BE49-F238E27FC236}">
-                <a16:creationId xmlns:a16="http://schemas.microsoft.com/office/drawing/2014/main" id="{040AEEF9-386B-4D44-B8CE-C5864BDE4A2F}"/>
+                <a16:creationId xmlns:a16="http://schemas.microsoft.com/office/drawing/2014/main" id="{4A203CBC-8B6F-4734-89A9-4A2BF241E4F0}"/>
               </a:ext>
             </a:extLst>
           </p:cNvPr>
@@ -19930,7 +19930,7 @@
           <p:cNvPr id="13" name="">
             <a:extLst xmlns:a="http://schemas.openxmlformats.org/drawingml/2006/main">
               <a:ext uri="{FF2B5EF4-FFF2-40B4-BE49-F238E27FC236}">
-                <a16:creationId xmlns:a16="http://schemas.microsoft.com/office/drawing/2014/main" id="{BB14FA89-E095-472B-9670-40D295B61C3F}"/>
+                <a16:creationId xmlns:a16="http://schemas.microsoft.com/office/drawing/2014/main" id="{CB612E3A-F74F-4679-9976-A94DED14EBD9}"/>
               </a:ext>
             </a:extLst>
           </p:cNvPr>
@@ -19980,7 +19980,7 @@
           <p:cNvPr id="14" name="">
             <a:extLst xmlns:a="http://schemas.openxmlformats.org/drawingml/2006/main">
               <a:ext uri="{FF2B5EF4-FFF2-40B4-BE49-F238E27FC236}">
-                <a16:creationId xmlns:a16="http://schemas.microsoft.com/office/drawing/2014/main" id="{347E2A1E-EBA7-4141-A494-2248791ED240}"/>
+                <a16:creationId xmlns:a16="http://schemas.microsoft.com/office/drawing/2014/main" id="{678A8351-EB14-4539-A176-9E5D33189A85}"/>
               </a:ext>
             </a:extLst>
           </p:cNvPr>
@@ -20030,7 +20030,7 @@
           <p:cNvPr id="15" name="">
             <a:extLst xmlns:a="http://schemas.openxmlformats.org/drawingml/2006/main">
               <a:ext uri="{FF2B5EF4-FFF2-40B4-BE49-F238E27FC236}">
-                <a16:creationId xmlns:a16="http://schemas.microsoft.com/office/drawing/2014/main" id="{EDC6D147-2486-4CBC-AF8E-167AC70E7197}"/>
+                <a16:creationId xmlns:a16="http://schemas.microsoft.com/office/drawing/2014/main" id="{32630605-3034-4BD2-9BAE-9169D08A411B}"/>
               </a:ext>
             </a:extLst>
           </p:cNvPr>
@@ -20065,7 +20065,7 @@
           <p:cNvPr id="16" name="">
             <a:extLst xmlns:a="http://schemas.openxmlformats.org/drawingml/2006/main">
               <a:ext uri="{FF2B5EF4-FFF2-40B4-BE49-F238E27FC236}">
-                <a16:creationId xmlns:a16="http://schemas.microsoft.com/office/drawing/2014/main" id="{DEFE1EA7-D2E2-4405-8E66-FAE121E6FBFC}"/>
+                <a16:creationId xmlns:a16="http://schemas.microsoft.com/office/drawing/2014/main" id="{A6D27B02-1CEE-4FDF-8AA8-3255A0F810A9}"/>
               </a:ext>
             </a:extLst>
           </p:cNvPr>
@@ -20098,7 +20098,7 @@
           <p:cNvPr id="17" name="">
             <a:extLst xmlns:a="http://schemas.openxmlformats.org/drawingml/2006/main">
               <a:ext uri="{FF2B5EF4-FFF2-40B4-BE49-F238E27FC236}">
-                <a16:creationId xmlns:a16="http://schemas.microsoft.com/office/drawing/2014/main" id="{526FA8E6-ED71-4770-A352-C4055A605629}"/>
+                <a16:creationId xmlns:a16="http://schemas.microsoft.com/office/drawing/2014/main" id="{B9F26320-A4EE-4D43-ACC2-7AAAB6D8AAC6}"/>
               </a:ext>
             </a:extLst>
           </p:cNvPr>
@@ -20148,7 +20148,7 @@
           <p:cNvPr id="18" name="">
             <a:extLst xmlns:a="http://schemas.openxmlformats.org/drawingml/2006/main">
               <a:ext uri="{FF2B5EF4-FFF2-40B4-BE49-F238E27FC236}">
-                <a16:creationId xmlns:a16="http://schemas.microsoft.com/office/drawing/2014/main" id="{051B9870-430D-4844-B8C1-FC31D8F7907E}"/>
+                <a16:creationId xmlns:a16="http://schemas.microsoft.com/office/drawing/2014/main" id="{D40420EB-CEA1-4592-BCFA-9B0CFB4BD9EC}"/>
               </a:ext>
             </a:extLst>
           </p:cNvPr>
@@ -20198,7 +20198,7 @@
           <p:cNvPr id="19" name="">
             <a:extLst xmlns:a="http://schemas.openxmlformats.org/drawingml/2006/main">
               <a:ext uri="{FF2B5EF4-FFF2-40B4-BE49-F238E27FC236}">
-                <a16:creationId xmlns:a16="http://schemas.microsoft.com/office/drawing/2014/main" id="{6ACCF0DC-16F5-4EFB-A5C4-041057A432BF}"/>
+                <a16:creationId xmlns:a16="http://schemas.microsoft.com/office/drawing/2014/main" id="{13D84D9E-D820-40C0-AEF3-126A565AC375}"/>
               </a:ext>
             </a:extLst>
           </p:cNvPr>
@@ -20233,7 +20233,7 @@
           <p:cNvPr id="20" name="">
             <a:extLst xmlns:a="http://schemas.openxmlformats.org/drawingml/2006/main">
               <a:ext uri="{FF2B5EF4-FFF2-40B4-BE49-F238E27FC236}">
-                <a16:creationId xmlns:a16="http://schemas.microsoft.com/office/drawing/2014/main" id="{0795CCEE-8957-4C9D-928E-C222AE4D418A}"/>
+                <a16:creationId xmlns:a16="http://schemas.microsoft.com/office/drawing/2014/main" id="{1F15231A-CC69-45CC-8876-9FC73BC32597}"/>
               </a:ext>
             </a:extLst>
           </p:cNvPr>
@@ -20266,7 +20266,7 @@
           <p:cNvPr id="21" name="">
             <a:extLst xmlns:a="http://schemas.openxmlformats.org/drawingml/2006/main">
               <a:ext uri="{FF2B5EF4-FFF2-40B4-BE49-F238E27FC236}">
-                <a16:creationId xmlns:a16="http://schemas.microsoft.com/office/drawing/2014/main" id="{81CCC2E0-9CB7-4E6C-8CBE-AFB465F85E2D}"/>
+                <a16:creationId xmlns:a16="http://schemas.microsoft.com/office/drawing/2014/main" id="{1B81CBFF-9557-4F5F-8F58-B4AF24FBC8E3}"/>
               </a:ext>
             </a:extLst>
           </p:cNvPr>
@@ -20316,7 +20316,7 @@
           <p:cNvPr id="22" name="">
             <a:extLst xmlns:a="http://schemas.openxmlformats.org/drawingml/2006/main">
               <a:ext uri="{FF2B5EF4-FFF2-40B4-BE49-F238E27FC236}">
-                <a16:creationId xmlns:a16="http://schemas.microsoft.com/office/drawing/2014/main" id="{9B429C4E-23D9-4510-823E-1DB8BE82189B}"/>
+                <a16:creationId xmlns:a16="http://schemas.microsoft.com/office/drawing/2014/main" id="{FDF7985D-3D50-4EF9-A8AF-1071B3248909}"/>
               </a:ext>
             </a:extLst>
           </p:cNvPr>
@@ -20354,7 +20354,7 @@
           <p:cNvPr id="23" name="">
             <a:extLst xmlns:a="http://schemas.openxmlformats.org/drawingml/2006/main">
               <a:ext uri="{FF2B5EF4-FFF2-40B4-BE49-F238E27FC236}">
-                <a16:creationId xmlns:a16="http://schemas.microsoft.com/office/drawing/2014/main" id="{547979E4-6DDF-4F04-8C90-EB1BCAC67AE7}"/>
+                <a16:creationId xmlns:a16="http://schemas.microsoft.com/office/drawing/2014/main" id="{63A17895-D6BF-458D-9A56-A44ACAC80E7C}"/>
               </a:ext>
             </a:extLst>
           </p:cNvPr>
@@ -20385,7 +20385,7 @@
           <p:cNvPr id="24" name="">
             <a:extLst xmlns:a="http://schemas.openxmlformats.org/drawingml/2006/main">
               <a:ext uri="{FF2B5EF4-FFF2-40B4-BE49-F238E27FC236}">
-                <a16:creationId xmlns:a16="http://schemas.microsoft.com/office/drawing/2014/main" id="{A2620CE3-A4FA-4BEA-A3C9-CC301B5F711D}"/>
+                <a16:creationId xmlns:a16="http://schemas.microsoft.com/office/drawing/2014/main" id="{B63C44E5-FB40-44EE-8DAF-E1B1423BCB78}"/>
               </a:ext>
             </a:extLst>
           </p:cNvPr>
@@ -20435,7 +20435,7 @@
           <p:cNvPr id="25" name="">
             <a:extLst xmlns:a="http://schemas.openxmlformats.org/drawingml/2006/main">
               <a:ext uri="{FF2B5EF4-FFF2-40B4-BE49-F238E27FC236}">
-                <a16:creationId xmlns:a16="http://schemas.microsoft.com/office/drawing/2014/main" id="{989CD663-9E97-49E9-957D-586A0AEEEDED}"/>
+                <a16:creationId xmlns:a16="http://schemas.microsoft.com/office/drawing/2014/main" id="{957BAF29-8120-4DF9-BF98-9740B89328B8}"/>
               </a:ext>
             </a:extLst>
           </p:cNvPr>
@@ -20466,7 +20466,7 @@
           <p:cNvPr id="26" name="">
             <a:extLst xmlns:a="http://schemas.openxmlformats.org/drawingml/2006/main">
               <a:ext uri="{FF2B5EF4-FFF2-40B4-BE49-F238E27FC236}">
-                <a16:creationId xmlns:a16="http://schemas.microsoft.com/office/drawing/2014/main" id="{20C13DCC-F9B0-4051-B92A-B01E0294E5B7}"/>
+                <a16:creationId xmlns:a16="http://schemas.microsoft.com/office/drawing/2014/main" id="{343BD7BD-8CC8-4A03-BABF-13D295CF4171}"/>
               </a:ext>
             </a:extLst>
           </p:cNvPr>
@@ -20516,7 +20516,7 @@
           <p:cNvPr id="27" name="">
             <a:extLst xmlns:a="http://schemas.openxmlformats.org/drawingml/2006/main">
               <a:ext uri="{FF2B5EF4-FFF2-40B4-BE49-F238E27FC236}">
-                <a16:creationId xmlns:a16="http://schemas.microsoft.com/office/drawing/2014/main" id="{0A64B69A-E0B4-4A4C-AF7C-22561F83B2CC}"/>
+                <a16:creationId xmlns:a16="http://schemas.microsoft.com/office/drawing/2014/main" id="{92F67001-934B-451F-8226-1E83CF66EBD6}"/>
               </a:ext>
             </a:extLst>
           </p:cNvPr>
@@ -20547,7 +20547,7 @@
           <p:cNvPr id="28" name="">
             <a:extLst xmlns:a="http://schemas.openxmlformats.org/drawingml/2006/main">
               <a:ext uri="{FF2B5EF4-FFF2-40B4-BE49-F238E27FC236}">
-                <a16:creationId xmlns:a16="http://schemas.microsoft.com/office/drawing/2014/main" id="{7378FEB3-2AB9-4D65-80F3-002DA713C59C}"/>
+                <a16:creationId xmlns:a16="http://schemas.microsoft.com/office/drawing/2014/main" id="{90BEB737-B7C8-4D10-B559-841D0BC188ED}"/>
               </a:ext>
             </a:extLst>
           </p:cNvPr>
@@ -20597,7 +20597,7 @@
           <p:cNvPr id="29" name="">
             <a:extLst xmlns:a="http://schemas.openxmlformats.org/drawingml/2006/main">
               <a:ext uri="{FF2B5EF4-FFF2-40B4-BE49-F238E27FC236}">
-                <a16:creationId xmlns:a16="http://schemas.microsoft.com/office/drawing/2014/main" id="{E9F9E6C7-B32A-44D4-80EE-CBADF86DB67E}"/>
+                <a16:creationId xmlns:a16="http://schemas.microsoft.com/office/drawing/2014/main" id="{A9A479E7-9974-4FEE-B88B-B126B5CDDBD3}"/>
               </a:ext>
             </a:extLst>
           </p:cNvPr>
@@ -20632,7 +20632,7 @@
           <p:cNvPr id="30" name="">
             <a:extLst xmlns:a="http://schemas.openxmlformats.org/drawingml/2006/main">
               <a:ext uri="{FF2B5EF4-FFF2-40B4-BE49-F238E27FC236}">
-                <a16:creationId xmlns:a16="http://schemas.microsoft.com/office/drawing/2014/main" id="{70FAF4FC-3127-4120-BD7D-55D6E7B344D8}"/>
+                <a16:creationId xmlns:a16="http://schemas.microsoft.com/office/drawing/2014/main" id="{A363F869-2F6D-4E33-9B3D-D01B4A304591}"/>
               </a:ext>
             </a:extLst>
           </p:cNvPr>
@@ -20665,7 +20665,7 @@
           <p:cNvPr id="31" name="">
             <a:extLst xmlns:a="http://schemas.openxmlformats.org/drawingml/2006/main">
               <a:ext uri="{FF2B5EF4-FFF2-40B4-BE49-F238E27FC236}">
-                <a16:creationId xmlns:a16="http://schemas.microsoft.com/office/drawing/2014/main" id="{0F19708A-ABBF-4336-AFBE-B0273E43506A}"/>
+                <a16:creationId xmlns:a16="http://schemas.microsoft.com/office/drawing/2014/main" id="{0F6DAAF4-ABA0-4A23-A099-269287E3551D}"/>
               </a:ext>
             </a:extLst>
           </p:cNvPr>
@@ -20715,7 +20715,7 @@
           <p:cNvPr id="32" name="">
             <a:extLst xmlns:a="http://schemas.openxmlformats.org/drawingml/2006/main">
               <a:ext uri="{FF2B5EF4-FFF2-40B4-BE49-F238E27FC236}">
-                <a16:creationId xmlns:a16="http://schemas.microsoft.com/office/drawing/2014/main" id="{7CAE458F-F56A-42B2-97AE-39B19541ED00}"/>
+                <a16:creationId xmlns:a16="http://schemas.microsoft.com/office/drawing/2014/main" id="{91563FF2-C9F2-4495-B646-D1C99C8ABEA6}"/>
               </a:ext>
             </a:extLst>
           </p:cNvPr>
@@ -20753,7 +20753,7 @@
           <p:cNvPr id="33" name="">
             <a:extLst xmlns:a="http://schemas.openxmlformats.org/drawingml/2006/main">
               <a:ext uri="{FF2B5EF4-FFF2-40B4-BE49-F238E27FC236}">
-                <a16:creationId xmlns:a16="http://schemas.microsoft.com/office/drawing/2014/main" id="{846BD52D-7ABA-468C-810D-1F745B8CD87E}"/>
+                <a16:creationId xmlns:a16="http://schemas.microsoft.com/office/drawing/2014/main" id="{6655F45B-06C0-4F76-BD13-DA423EA06ECF}"/>
               </a:ext>
             </a:extLst>
           </p:cNvPr>
@@ -20784,7 +20784,7 @@
           <p:cNvPr id="34" name="">
             <a:extLst xmlns:a="http://schemas.openxmlformats.org/drawingml/2006/main">
               <a:ext uri="{FF2B5EF4-FFF2-40B4-BE49-F238E27FC236}">
-                <a16:creationId xmlns:a16="http://schemas.microsoft.com/office/drawing/2014/main" id="{A9A49741-6EB4-461F-A07A-91EA61FFEF53}"/>
+                <a16:creationId xmlns:a16="http://schemas.microsoft.com/office/drawing/2014/main" id="{50A6EE55-BFC5-4EDC-AB77-C5DC23B14B3D}"/>
               </a:ext>
             </a:extLst>
           </p:cNvPr>
@@ -20834,7 +20834,7 @@
           <p:cNvPr id="35" name="">
             <a:extLst xmlns:a="http://schemas.openxmlformats.org/drawingml/2006/main">
               <a:ext uri="{FF2B5EF4-FFF2-40B4-BE49-F238E27FC236}">
-                <a16:creationId xmlns:a16="http://schemas.microsoft.com/office/drawing/2014/main" id="{73C22573-01B6-416B-9417-8B67E8B73027}"/>
+                <a16:creationId xmlns:a16="http://schemas.microsoft.com/office/drawing/2014/main" id="{0BF04283-C111-4140-84E8-948FBA3391C3}"/>
               </a:ext>
             </a:extLst>
           </p:cNvPr>
@@ -20865,7 +20865,7 @@
           <p:cNvPr id="36" name="">
             <a:extLst xmlns:a="http://schemas.openxmlformats.org/drawingml/2006/main">
               <a:ext uri="{FF2B5EF4-FFF2-40B4-BE49-F238E27FC236}">
-                <a16:creationId xmlns:a16="http://schemas.microsoft.com/office/drawing/2014/main" id="{97BE63C3-B7F2-4CFC-ACF3-2718B4C0BBED}"/>
+                <a16:creationId xmlns:a16="http://schemas.microsoft.com/office/drawing/2014/main" id="{C616C7F4-8DC8-43D9-B008-DF715DA7B81B}"/>
               </a:ext>
             </a:extLst>
           </p:cNvPr>
@@ -20915,7 +20915,7 @@
           <p:cNvPr id="37" name="">
             <a:extLst xmlns:a="http://schemas.openxmlformats.org/drawingml/2006/main">
               <a:ext uri="{FF2B5EF4-FFF2-40B4-BE49-F238E27FC236}">
-                <a16:creationId xmlns:a16="http://schemas.microsoft.com/office/drawing/2014/main" id="{1514F41F-9BB1-4C8C-AC30-1C9E1B6CDEAA}"/>
+                <a16:creationId xmlns:a16="http://schemas.microsoft.com/office/drawing/2014/main" id="{37E55073-7CF3-4587-A42A-02BC278789C6}"/>
               </a:ext>
             </a:extLst>
           </p:cNvPr>
@@ -20946,7 +20946,7 @@
           <p:cNvPr id="38" name="">
             <a:extLst xmlns:a="http://schemas.openxmlformats.org/drawingml/2006/main">
               <a:ext uri="{FF2B5EF4-FFF2-40B4-BE49-F238E27FC236}">
-                <a16:creationId xmlns:a16="http://schemas.microsoft.com/office/drawing/2014/main" id="{D7D3E31B-445D-4BFB-B703-6B6A0ADE6894}"/>
+                <a16:creationId xmlns:a16="http://schemas.microsoft.com/office/drawing/2014/main" id="{599BE425-64A3-466E-9C7C-A607999CA4F9}"/>
               </a:ext>
             </a:extLst>
           </p:cNvPr>
@@ -20994,7 +20994,7 @@
     </p:spTree>
     <p:extLst>
       <p:ext uri="{BB962C8B-B14F-4D97-AF65-F5344CB8AC3E}">
-        <p14:creationId xmlns:p14="http://schemas.microsoft.com/office/powerpoint/2010/main" val="1005975712"/>
+        <p14:creationId xmlns:p14="http://schemas.microsoft.com/office/powerpoint/2010/main" val="1755857811"/>
       </p:ext>
     </p:extLst>
   </p:cSld>
@@ -21025,7 +21025,7 @@
           <p:cNvPr id="1" name="">
             <a:extLst xmlns:a="http://schemas.openxmlformats.org/drawingml/2006/main">
               <a:ext uri="{FF2B5EF4-FFF2-40B4-BE49-F238E27FC236}">
-                <a16:creationId xmlns:a16="http://schemas.microsoft.com/office/drawing/2014/main" id="{F16F17DB-5934-40A1-BC41-A37D8ADA8899}"/>
+                <a16:creationId xmlns:a16="http://schemas.microsoft.com/office/drawing/2014/main" id="{19C1D191-4DE1-4094-84E9-83167A0A973B}"/>
               </a:ext>
             </a:extLst>
           </p:cNvPr>
@@ -21079,7 +21079,7 @@
           <p:cNvPr id="2" name="">
             <a:extLst xmlns:a="http://schemas.openxmlformats.org/drawingml/2006/main">
               <a:ext uri="{FF2B5EF4-FFF2-40B4-BE49-F238E27FC236}">
-                <a16:creationId xmlns:a16="http://schemas.microsoft.com/office/drawing/2014/main" id="{4D8E8E7C-3476-4E2E-B6AF-8AD1279D943B}"/>
+                <a16:creationId xmlns:a16="http://schemas.microsoft.com/office/drawing/2014/main" id="{D7D21B00-1288-4B2F-A078-410FC1936E2B}"/>
               </a:ext>
             </a:extLst>
           </p:cNvPr>
@@ -21110,7 +21110,7 @@
           <p:cNvPr id="3" name="">
             <a:extLst xmlns:a="http://schemas.openxmlformats.org/drawingml/2006/main">
               <a:ext uri="{FF2B5EF4-FFF2-40B4-BE49-F238E27FC236}">
-                <a16:creationId xmlns:a16="http://schemas.microsoft.com/office/drawing/2014/main" id="{2B64DFDA-15CB-4E73-A1C3-F0185CD1C4A2}"/>
+                <a16:creationId xmlns:a16="http://schemas.microsoft.com/office/drawing/2014/main" id="{80BB4EBB-95EF-4679-983C-CEB2C23593B0}"/>
               </a:ext>
             </a:extLst>
           </p:cNvPr>
@@ -21160,7 +21160,7 @@
           <p:cNvPr id="4" name="">
             <a:extLst xmlns:a="http://schemas.openxmlformats.org/drawingml/2006/main">
               <a:ext uri="{FF2B5EF4-FFF2-40B4-BE49-F238E27FC236}">
-                <a16:creationId xmlns:a16="http://schemas.microsoft.com/office/drawing/2014/main" id="{954FF86E-C891-47D6-97BE-25552DC2ED7E}"/>
+                <a16:creationId xmlns:a16="http://schemas.microsoft.com/office/drawing/2014/main" id="{9C3BD790-0FD0-42DB-AC96-C29FEFC817AB}"/>
               </a:ext>
             </a:extLst>
           </p:cNvPr>
@@ -21210,7 +21210,7 @@
           <p:cNvPr id="5" name="">
             <a:extLst xmlns:a="http://schemas.openxmlformats.org/drawingml/2006/main">
               <a:ext uri="{FF2B5EF4-FFF2-40B4-BE49-F238E27FC236}">
-                <a16:creationId xmlns:a16="http://schemas.microsoft.com/office/drawing/2014/main" id="{91E12BEA-757F-4955-9F87-8825154A02AC}"/>
+                <a16:creationId xmlns:a16="http://schemas.microsoft.com/office/drawing/2014/main" id="{C5877AFB-4406-426D-9B52-325D6DC8FFCD}"/>
               </a:ext>
             </a:extLst>
           </p:cNvPr>
@@ -21260,7 +21260,7 @@
           <p:cNvPr id="6" name="">
             <a:extLst xmlns:a="http://schemas.openxmlformats.org/drawingml/2006/main">
               <a:ext uri="{FF2B5EF4-FFF2-40B4-BE49-F238E27FC236}">
-                <a16:creationId xmlns:a16="http://schemas.microsoft.com/office/drawing/2014/main" id="{99409F73-A083-4077-849A-A00B870E9336}"/>
+                <a16:creationId xmlns:a16="http://schemas.microsoft.com/office/drawing/2014/main" id="{29C9C45C-D129-4C9D-9271-AAA57C9B0282}"/>
               </a:ext>
             </a:extLst>
           </p:cNvPr>
@@ -21295,7 +21295,7 @@
           <p:cNvPr id="7" name="">
             <a:extLst xmlns:a="http://schemas.openxmlformats.org/drawingml/2006/main">
               <a:ext uri="{FF2B5EF4-FFF2-40B4-BE49-F238E27FC236}">
-                <a16:creationId xmlns:a16="http://schemas.microsoft.com/office/drawing/2014/main" id="{8AD3F676-272A-408B-B04F-05CF622838D1}"/>
+                <a16:creationId xmlns:a16="http://schemas.microsoft.com/office/drawing/2014/main" id="{B86E8669-11A7-48A4-91B2-920B69AFA947}"/>
               </a:ext>
             </a:extLst>
           </p:cNvPr>
@@ -21345,7 +21345,7 @@
           <p:cNvPr id="8" name="">
             <a:extLst xmlns:a="http://schemas.openxmlformats.org/drawingml/2006/main">
               <a:ext uri="{FF2B5EF4-FFF2-40B4-BE49-F238E27FC236}">
-                <a16:creationId xmlns:a16="http://schemas.microsoft.com/office/drawing/2014/main" id="{EBB12AB8-F7A7-418D-86A0-6D0F9E4D8DE4}"/>
+                <a16:creationId xmlns:a16="http://schemas.microsoft.com/office/drawing/2014/main" id="{08D38DEF-154F-4338-91D3-34787D957C6F}"/>
               </a:ext>
             </a:extLst>
           </p:cNvPr>
@@ -21395,7 +21395,7 @@
           <p:cNvPr id="9" name="">
             <a:extLst xmlns:a="http://schemas.openxmlformats.org/drawingml/2006/main">
               <a:ext uri="{FF2B5EF4-FFF2-40B4-BE49-F238E27FC236}">
-                <a16:creationId xmlns:a16="http://schemas.microsoft.com/office/drawing/2014/main" id="{6434DF7C-0B10-4504-B3D0-1095FF184BA6}"/>
+                <a16:creationId xmlns:a16="http://schemas.microsoft.com/office/drawing/2014/main" id="{32E1C936-ECF1-4EE8-88AB-FBD73C98E54F}"/>
               </a:ext>
             </a:extLst>
           </p:cNvPr>
@@ -21430,7 +21430,7 @@
           <p:cNvPr id="10" name="">
             <a:extLst xmlns:a="http://schemas.openxmlformats.org/drawingml/2006/main">
               <a:ext uri="{FF2B5EF4-FFF2-40B4-BE49-F238E27FC236}">
-                <a16:creationId xmlns:a16="http://schemas.microsoft.com/office/drawing/2014/main" id="{6924B97E-3007-4207-BE0B-3A1219E014A2}"/>
+                <a16:creationId xmlns:a16="http://schemas.microsoft.com/office/drawing/2014/main" id="{E27FEA7C-B545-4350-B176-A3CD4AEBFA21}"/>
               </a:ext>
             </a:extLst>
           </p:cNvPr>
@@ -21480,7 +21480,7 @@
           <p:cNvPr id="11" name="">
             <a:extLst xmlns:a="http://schemas.openxmlformats.org/drawingml/2006/main">
               <a:ext uri="{FF2B5EF4-FFF2-40B4-BE49-F238E27FC236}">
-                <a16:creationId xmlns:a16="http://schemas.microsoft.com/office/drawing/2014/main" id="{E0A7182E-BE03-467A-A657-FF819EABD264}"/>
+                <a16:creationId xmlns:a16="http://schemas.microsoft.com/office/drawing/2014/main" id="{EE4DFD4A-FF37-4EF1-98EC-1AF2413638E1}"/>
               </a:ext>
             </a:extLst>
           </p:cNvPr>
@@ -21530,7 +21530,7 @@
           <p:cNvPr id="12" name="">
             <a:extLst xmlns:a="http://schemas.openxmlformats.org/drawingml/2006/main">
               <a:ext uri="{FF2B5EF4-FFF2-40B4-BE49-F238E27FC236}">
-                <a16:creationId xmlns:a16="http://schemas.microsoft.com/office/drawing/2014/main" id="{B96A6EE5-6835-40E4-A725-73B27F5A348E}"/>
+                <a16:creationId xmlns:a16="http://schemas.microsoft.com/office/drawing/2014/main" id="{82C13CC6-1B81-474F-9A4A-11BB7D55E4D3}"/>
               </a:ext>
             </a:extLst>
           </p:cNvPr>
@@ -21565,7 +21565,7 @@
           <p:cNvPr id="13" name="">
             <a:extLst xmlns:a="http://schemas.openxmlformats.org/drawingml/2006/main">
               <a:ext uri="{FF2B5EF4-FFF2-40B4-BE49-F238E27FC236}">
-                <a16:creationId xmlns:a16="http://schemas.microsoft.com/office/drawing/2014/main" id="{82AD4FF6-2DA0-4856-9ADC-0740A4CC92D6}"/>
+                <a16:creationId xmlns:a16="http://schemas.microsoft.com/office/drawing/2014/main" id="{E1C62A49-37D1-447F-B1D5-9B6974CF695D}"/>
               </a:ext>
             </a:extLst>
           </p:cNvPr>
@@ -21615,7 +21615,7 @@
           <p:cNvPr id="14" name="">
             <a:extLst xmlns:a="http://schemas.openxmlformats.org/drawingml/2006/main">
               <a:ext uri="{FF2B5EF4-FFF2-40B4-BE49-F238E27FC236}">
-                <a16:creationId xmlns:a16="http://schemas.microsoft.com/office/drawing/2014/main" id="{9306D759-FDAC-4655-B1EE-4EB2F5E4F27A}"/>
+                <a16:creationId xmlns:a16="http://schemas.microsoft.com/office/drawing/2014/main" id="{C1070FB8-888A-44B8-9BE3-50CDDF05383F}"/>
               </a:ext>
             </a:extLst>
           </p:cNvPr>
@@ -21665,7 +21665,7 @@
           <p:cNvPr id="15" name="">
             <a:extLst xmlns:a="http://schemas.openxmlformats.org/drawingml/2006/main">
               <a:ext uri="{FF2B5EF4-FFF2-40B4-BE49-F238E27FC236}">
-                <a16:creationId xmlns:a16="http://schemas.microsoft.com/office/drawing/2014/main" id="{5F0F7405-EB24-4B49-80C6-C39592F04037}"/>
+                <a16:creationId xmlns:a16="http://schemas.microsoft.com/office/drawing/2014/main" id="{749AAA0E-04F4-4F32-A2A9-C298EDFA7E62}"/>
               </a:ext>
             </a:extLst>
           </p:cNvPr>
@@ -21700,7 +21700,7 @@
           <p:cNvPr id="16" name="">
             <a:extLst xmlns:a="http://schemas.openxmlformats.org/drawingml/2006/main">
               <a:ext uri="{FF2B5EF4-FFF2-40B4-BE49-F238E27FC236}">
-                <a16:creationId xmlns:a16="http://schemas.microsoft.com/office/drawing/2014/main" id="{87847FB1-A4A9-488B-B9DB-2A8A8FACE4E0}"/>
+                <a16:creationId xmlns:a16="http://schemas.microsoft.com/office/drawing/2014/main" id="{5E0A55C7-1898-4469-81C2-CA8363A6FA0B}"/>
               </a:ext>
             </a:extLst>
           </p:cNvPr>
@@ -21733,7 +21733,7 @@
           <p:cNvPr id="17" name="">
             <a:extLst xmlns:a="http://schemas.openxmlformats.org/drawingml/2006/main">
               <a:ext uri="{FF2B5EF4-FFF2-40B4-BE49-F238E27FC236}">
-                <a16:creationId xmlns:a16="http://schemas.microsoft.com/office/drawing/2014/main" id="{C7F6D7FD-60A5-4DC5-AD26-1CCD0BD56BB5}"/>
+                <a16:creationId xmlns:a16="http://schemas.microsoft.com/office/drawing/2014/main" id="{2B47DAFA-E828-4B82-9467-FF62DA3F3648}"/>
               </a:ext>
             </a:extLst>
           </p:cNvPr>
@@ -21783,7 +21783,7 @@
           <p:cNvPr id="18" name="">
             <a:extLst xmlns:a="http://schemas.openxmlformats.org/drawingml/2006/main">
               <a:ext uri="{FF2B5EF4-FFF2-40B4-BE49-F238E27FC236}">
-                <a16:creationId xmlns:a16="http://schemas.microsoft.com/office/drawing/2014/main" id="{81E88AA6-52FD-439C-9EAD-DB369B90BB4C}"/>
+                <a16:creationId xmlns:a16="http://schemas.microsoft.com/office/drawing/2014/main" id="{E25267E3-F9AD-4175-A54F-020CE3D70CA1}"/>
               </a:ext>
             </a:extLst>
           </p:cNvPr>
@@ -21833,7 +21833,7 @@
           <p:cNvPr id="19" name="">
             <a:extLst xmlns:a="http://schemas.openxmlformats.org/drawingml/2006/main">
               <a:ext uri="{FF2B5EF4-FFF2-40B4-BE49-F238E27FC236}">
-                <a16:creationId xmlns:a16="http://schemas.microsoft.com/office/drawing/2014/main" id="{D0A1A9DE-405D-4DB6-B826-CF3CEAE5236B}"/>
+                <a16:creationId xmlns:a16="http://schemas.microsoft.com/office/drawing/2014/main" id="{6935BEC4-8439-4D45-9D00-895D0B543D54}"/>
               </a:ext>
             </a:extLst>
           </p:cNvPr>
@@ -21868,7 +21868,7 @@
           <p:cNvPr id="20" name="">
             <a:extLst xmlns:a="http://schemas.openxmlformats.org/drawingml/2006/main">
               <a:ext uri="{FF2B5EF4-FFF2-40B4-BE49-F238E27FC236}">
-                <a16:creationId xmlns:a16="http://schemas.microsoft.com/office/drawing/2014/main" id="{5619E40F-387A-4AAB-BE32-1170D728DC62}"/>
+                <a16:creationId xmlns:a16="http://schemas.microsoft.com/office/drawing/2014/main" id="{B8D2213C-013E-4735-A8FC-1CBCB2BF8E6A}"/>
               </a:ext>
             </a:extLst>
           </p:cNvPr>
@@ -21901,7 +21901,7 @@
           <p:cNvPr id="21" name="">
             <a:extLst xmlns:a="http://schemas.openxmlformats.org/drawingml/2006/main">
               <a:ext uri="{FF2B5EF4-FFF2-40B4-BE49-F238E27FC236}">
-                <a16:creationId xmlns:a16="http://schemas.microsoft.com/office/drawing/2014/main" id="{AF2AC263-F1C3-41F0-9D3F-A4CA47079117}"/>
+                <a16:creationId xmlns:a16="http://schemas.microsoft.com/office/drawing/2014/main" id="{3C23A26D-BF5F-4CF8-830F-EDDB9D471F48}"/>
               </a:ext>
             </a:extLst>
           </p:cNvPr>
@@ -21951,7 +21951,7 @@
           <p:cNvPr id="22" name="">
             <a:extLst xmlns:a="http://schemas.openxmlformats.org/drawingml/2006/main">
               <a:ext uri="{FF2B5EF4-FFF2-40B4-BE49-F238E27FC236}">
-                <a16:creationId xmlns:a16="http://schemas.microsoft.com/office/drawing/2014/main" id="{B4084956-1E92-4357-9A34-8CA67A173D68}"/>
+                <a16:creationId xmlns:a16="http://schemas.microsoft.com/office/drawing/2014/main" id="{CA734F49-7B3C-4A57-8DE7-A9CC9EF46D97}"/>
               </a:ext>
             </a:extLst>
           </p:cNvPr>
@@ -21989,7 +21989,7 @@
           <p:cNvPr id="23" name="">
             <a:extLst xmlns:a="http://schemas.openxmlformats.org/drawingml/2006/main">
               <a:ext uri="{FF2B5EF4-FFF2-40B4-BE49-F238E27FC236}">
-                <a16:creationId xmlns:a16="http://schemas.microsoft.com/office/drawing/2014/main" id="{59DC7D83-87EF-4344-B0BB-1C5CCB1326FF}"/>
+                <a16:creationId xmlns:a16="http://schemas.microsoft.com/office/drawing/2014/main" id="{F5F56020-F33C-4990-9533-92F128FE2858}"/>
               </a:ext>
             </a:extLst>
           </p:cNvPr>
@@ -22020,7 +22020,7 @@
           <p:cNvPr id="24" name="">
             <a:extLst xmlns:a="http://schemas.openxmlformats.org/drawingml/2006/main">
               <a:ext uri="{FF2B5EF4-FFF2-40B4-BE49-F238E27FC236}">
-                <a16:creationId xmlns:a16="http://schemas.microsoft.com/office/drawing/2014/main" id="{B3979D4D-17BB-4AF7-A176-21AF6569A107}"/>
+                <a16:creationId xmlns:a16="http://schemas.microsoft.com/office/drawing/2014/main" id="{7272B741-AF55-4957-BE8B-1A25190D4EAC}"/>
               </a:ext>
             </a:extLst>
           </p:cNvPr>
@@ -22070,7 +22070,7 @@
           <p:cNvPr id="25" name="">
             <a:extLst xmlns:a="http://schemas.openxmlformats.org/drawingml/2006/main">
               <a:ext uri="{FF2B5EF4-FFF2-40B4-BE49-F238E27FC236}">
-                <a16:creationId xmlns:a16="http://schemas.microsoft.com/office/drawing/2014/main" id="{96C1ED5D-7A60-4A78-935D-20F464022BD5}"/>
+                <a16:creationId xmlns:a16="http://schemas.microsoft.com/office/drawing/2014/main" id="{F68FC29F-C7C1-4ADF-8400-BBA07C6FFB5D}"/>
               </a:ext>
             </a:extLst>
           </p:cNvPr>
@@ -22101,7 +22101,7 @@
           <p:cNvPr id="26" name="">
             <a:extLst xmlns:a="http://schemas.openxmlformats.org/drawingml/2006/main">
               <a:ext uri="{FF2B5EF4-FFF2-40B4-BE49-F238E27FC236}">
-                <a16:creationId xmlns:a16="http://schemas.microsoft.com/office/drawing/2014/main" id="{954882F1-C19D-4598-A1D6-135338D33AD8}"/>
+                <a16:creationId xmlns:a16="http://schemas.microsoft.com/office/drawing/2014/main" id="{60345679-EE66-410F-9903-F05D3EBACCD3}"/>
               </a:ext>
             </a:extLst>
           </p:cNvPr>
@@ -22151,7 +22151,7 @@
           <p:cNvPr id="27" name="">
             <a:extLst xmlns:a="http://schemas.openxmlformats.org/drawingml/2006/main">
               <a:ext uri="{FF2B5EF4-FFF2-40B4-BE49-F238E27FC236}">
-                <a16:creationId xmlns:a16="http://schemas.microsoft.com/office/drawing/2014/main" id="{20E1F2A1-265F-4A7B-A160-C02E7903B463}"/>
+                <a16:creationId xmlns:a16="http://schemas.microsoft.com/office/drawing/2014/main" id="{105ADDB7-473E-4346-AEB3-F9211A59EE03}"/>
               </a:ext>
             </a:extLst>
           </p:cNvPr>
@@ -22182,7 +22182,7 @@
           <p:cNvPr id="28" name="">
             <a:extLst xmlns:a="http://schemas.openxmlformats.org/drawingml/2006/main">
               <a:ext uri="{FF2B5EF4-FFF2-40B4-BE49-F238E27FC236}">
-                <a16:creationId xmlns:a16="http://schemas.microsoft.com/office/drawing/2014/main" id="{742606F2-5E67-4882-A3CD-C6A053C5B76A}"/>
+                <a16:creationId xmlns:a16="http://schemas.microsoft.com/office/drawing/2014/main" id="{2D2C8D06-65C5-4589-B0B1-06822FC83450}"/>
               </a:ext>
             </a:extLst>
           </p:cNvPr>
@@ -22232,7 +22232,7 @@
           <p:cNvPr id="29" name="">
             <a:extLst xmlns:a="http://schemas.openxmlformats.org/drawingml/2006/main">
               <a:ext uri="{FF2B5EF4-FFF2-40B4-BE49-F238E27FC236}">
-                <a16:creationId xmlns:a16="http://schemas.microsoft.com/office/drawing/2014/main" id="{81FCB3B9-7036-44C5-A154-6D0BD01E4D12}"/>
+                <a16:creationId xmlns:a16="http://schemas.microsoft.com/office/drawing/2014/main" id="{26F1741F-96E5-4C6C-B26C-8502A8AF93DC}"/>
               </a:ext>
             </a:extLst>
           </p:cNvPr>
@@ -22267,7 +22267,7 @@
           <p:cNvPr id="30" name="">
             <a:extLst xmlns:a="http://schemas.openxmlformats.org/drawingml/2006/main">
               <a:ext uri="{FF2B5EF4-FFF2-40B4-BE49-F238E27FC236}">
-                <a16:creationId xmlns:a16="http://schemas.microsoft.com/office/drawing/2014/main" id="{0DFEAE8A-0B15-4BD1-B98F-0BBD6A2CD5B5}"/>
+                <a16:creationId xmlns:a16="http://schemas.microsoft.com/office/drawing/2014/main" id="{089E4EF9-BE7A-49FF-AB19-86DB66B55F0F}"/>
               </a:ext>
             </a:extLst>
           </p:cNvPr>
@@ -22300,7 +22300,7 @@
           <p:cNvPr id="31" name="">
             <a:extLst xmlns:a="http://schemas.openxmlformats.org/drawingml/2006/main">
               <a:ext uri="{FF2B5EF4-FFF2-40B4-BE49-F238E27FC236}">
-                <a16:creationId xmlns:a16="http://schemas.microsoft.com/office/drawing/2014/main" id="{EF038874-E15A-4885-9A69-E8B9E241E77A}"/>
+                <a16:creationId xmlns:a16="http://schemas.microsoft.com/office/drawing/2014/main" id="{95841710-AF46-4B58-ADA7-792ED89EAE4A}"/>
               </a:ext>
             </a:extLst>
           </p:cNvPr>
@@ -22350,7 +22350,7 @@
           <p:cNvPr id="32" name="">
             <a:extLst xmlns:a="http://schemas.openxmlformats.org/drawingml/2006/main">
               <a:ext uri="{FF2B5EF4-FFF2-40B4-BE49-F238E27FC236}">
-                <a16:creationId xmlns:a16="http://schemas.microsoft.com/office/drawing/2014/main" id="{D0709949-93A5-4323-9477-51D2A09E5C58}"/>
+                <a16:creationId xmlns:a16="http://schemas.microsoft.com/office/drawing/2014/main" id="{770D9EA2-05E0-40ED-8B78-8CE13BF0F61D}"/>
               </a:ext>
             </a:extLst>
           </p:cNvPr>
@@ -22388,7 +22388,7 @@
           <p:cNvPr id="33" name="">
             <a:extLst xmlns:a="http://schemas.openxmlformats.org/drawingml/2006/main">
               <a:ext uri="{FF2B5EF4-FFF2-40B4-BE49-F238E27FC236}">
-                <a16:creationId xmlns:a16="http://schemas.microsoft.com/office/drawing/2014/main" id="{0259726D-4176-46EF-BC1C-34856262A16E}"/>
+                <a16:creationId xmlns:a16="http://schemas.microsoft.com/office/drawing/2014/main" id="{0E74725C-0E25-48D3-B98C-E400E67737F9}"/>
               </a:ext>
             </a:extLst>
           </p:cNvPr>
@@ -22419,7 +22419,7 @@
           <p:cNvPr id="34" name="">
             <a:extLst xmlns:a="http://schemas.openxmlformats.org/drawingml/2006/main">
               <a:ext uri="{FF2B5EF4-FFF2-40B4-BE49-F238E27FC236}">
-                <a16:creationId xmlns:a16="http://schemas.microsoft.com/office/drawing/2014/main" id="{39E409E8-A2D6-4D8D-BA81-EF90E085DC3F}"/>
+                <a16:creationId xmlns:a16="http://schemas.microsoft.com/office/drawing/2014/main" id="{7BF0AA83-458E-4247-BC98-E58C97AEBA97}"/>
               </a:ext>
             </a:extLst>
           </p:cNvPr>
@@ -22469,7 +22469,7 @@
           <p:cNvPr id="35" name="">
             <a:extLst xmlns:a="http://schemas.openxmlformats.org/drawingml/2006/main">
               <a:ext uri="{FF2B5EF4-FFF2-40B4-BE49-F238E27FC236}">
-                <a16:creationId xmlns:a16="http://schemas.microsoft.com/office/drawing/2014/main" id="{F364804E-4641-4688-AFD0-A47481EBD080}"/>
+                <a16:creationId xmlns:a16="http://schemas.microsoft.com/office/drawing/2014/main" id="{465B4ABA-9977-435A-9AA4-09A8F5B89844}"/>
               </a:ext>
             </a:extLst>
           </p:cNvPr>
@@ -22500,7 +22500,7 @@
           <p:cNvPr id="36" name="">
             <a:extLst xmlns:a="http://schemas.openxmlformats.org/drawingml/2006/main">
               <a:ext uri="{FF2B5EF4-FFF2-40B4-BE49-F238E27FC236}">
-                <a16:creationId xmlns:a16="http://schemas.microsoft.com/office/drawing/2014/main" id="{59E0A4D8-CC75-4E77-B1F2-1FF7B20F80C8}"/>
+                <a16:creationId xmlns:a16="http://schemas.microsoft.com/office/drawing/2014/main" id="{FD45215F-85D4-4644-8DEF-A52C9EB6ADC6}"/>
               </a:ext>
             </a:extLst>
           </p:cNvPr>
@@ -22550,7 +22550,7 @@
           <p:cNvPr id="37" name="">
             <a:extLst xmlns:a="http://schemas.openxmlformats.org/drawingml/2006/main">
               <a:ext uri="{FF2B5EF4-FFF2-40B4-BE49-F238E27FC236}">
-                <a16:creationId xmlns:a16="http://schemas.microsoft.com/office/drawing/2014/main" id="{FB39C5DF-2C18-4C82-A199-148BC432617B}"/>
+                <a16:creationId xmlns:a16="http://schemas.microsoft.com/office/drawing/2014/main" id="{6623E255-CE69-4D35-BDB4-C3B416D78ACA}"/>
               </a:ext>
             </a:extLst>
           </p:cNvPr>
@@ -22581,7 +22581,7 @@
           <p:cNvPr id="38" name="">
             <a:extLst xmlns:a="http://schemas.openxmlformats.org/drawingml/2006/main">
               <a:ext uri="{FF2B5EF4-FFF2-40B4-BE49-F238E27FC236}">
-                <a16:creationId xmlns:a16="http://schemas.microsoft.com/office/drawing/2014/main" id="{3B4F564D-C0C5-4506-B233-9FA9D35BD304}"/>
+                <a16:creationId xmlns:a16="http://schemas.microsoft.com/office/drawing/2014/main" id="{EA89DFC3-0810-4619-B810-6FFEAB155DE2}"/>
               </a:ext>
             </a:extLst>
           </p:cNvPr>
@@ -22629,7 +22629,7 @@
     </p:spTree>
     <p:extLst>
       <p:ext uri="{BB962C8B-B14F-4D97-AF65-F5344CB8AC3E}">
-        <p14:creationId xmlns:p14="http://schemas.microsoft.com/office/powerpoint/2010/main" val="154787895"/>
+        <p14:creationId xmlns:p14="http://schemas.microsoft.com/office/powerpoint/2010/main" val="1852689874"/>
       </p:ext>
     </p:extLst>
   </p:cSld>

</xml_diff>